<commit_message>
fix: layout for CLU
</commit_message>
<xml_diff>
--- a/preview-out/preview.pptx
+++ b/preview-out/preview.pptx
@@ -11,10 +11,9 @@
     <p:sldId id="259" r:id="rId5"/>
     <p:sldId id="260" r:id="rId6"/>
     <p:sldId id="261" r:id="rId7"/>
-    <p:sldId id="262" r:id="rId8"/>
   </p:sldIdLst>
   <p:notesMasterIdLst>
-    <p:notesMasterId r:id="rId9"/>
+    <p:notesMasterId r:id="rId8"/>
   </p:notesMasterIdLst>
   <p:sldSz cx="9144000" cy="5143500"/>
   <p:notesSz cx="5143500" cy="9144000"/>
@@ -990,94 +989,6 @@
 </p:notes>
 </file>
 
-<file path=ppt/notesSlides/notesSlide7.xml><?xml version="1.0" encoding="utf-8"?>
-<p:notes xmlns:a="http://schemas.openxmlformats.org/drawingml/2006/main" xmlns:r="http://schemas.openxmlformats.org/officeDocument/2006/relationships" xmlns:p="http://schemas.openxmlformats.org/presentationml/2006/main">
-  <p:cSld>
-    <p:spTree>
-      <p:nvGrpSpPr>
-        <p:cNvPr id="1" name=""/>
-        <p:cNvGrpSpPr/>
-        <p:nvPr/>
-      </p:nvGrpSpPr>
-      <p:grpSpPr>
-        <a:xfrm>
-          <a:off x="0" y="0"/>
-          <a:ext cx="0" cy="0"/>
-          <a:chOff x="0" y="0"/>
-          <a:chExt cx="0" cy="0"/>
-        </a:xfrm>
-      </p:grpSpPr>
-      <p:sp>
-        <p:nvSpPr>
-          <p:cNvPr id="2" name="Slide Image Placeholder 1"/>
-          <p:cNvSpPr>
-            <a:spLocks noGrp="1" noRot="1" noChangeAspect="1"/>
-          </p:cNvSpPr>
-          <p:nvPr>
-            <p:ph type="sldImg"/>
-          </p:nvPr>
-        </p:nvSpPr>
-        <p:spPr/>
-      </p:sp>
-      <p:sp>
-        <p:nvSpPr>
-          <p:cNvPr id="3" name="Notes Placeholder 2"/>
-          <p:cNvSpPr>
-            <a:spLocks noGrp="1"/>
-          </p:cNvSpPr>
-          <p:nvPr>
-            <p:ph type="body" idx="1"/>
-          </p:nvPr>
-        </p:nvSpPr>
-        <p:spPr/>
-        <p:txBody>
-          <a:bodyPr/>
-          <a:lstStyle/>
-          <a:p>
-            <a:r>
-              <a:rPr lang="en-US" dirty="0"/>
-              <a:t/>
-            </a:r>
-            <a:endParaRPr lang="en-US" dirty="0"/>
-          </a:p>
-        </p:txBody>
-      </p:sp>
-      <p:sp>
-        <p:nvSpPr>
-          <p:cNvPr id="4" name="Slide Number Placeholder 3"/>
-          <p:cNvSpPr>
-            <a:spLocks noGrp="1"/>
-          </p:cNvSpPr>
-          <p:nvPr>
-            <p:ph type="sldNum" sz="quarter" idx="10"/>
-          </p:nvPr>
-        </p:nvSpPr>
-        <p:spPr/>
-        <p:txBody>
-          <a:bodyPr/>
-          <a:lstStyle/>
-          <a:p>
-            <a:fld id="{F7021451-1387-4CA6-816F-3879F97B5CBC}" type="slidenum">
-              <a:rPr lang="en-US"/>
-              <a:t>7</a:t>
-            </a:fld>
-            <a:endParaRPr lang="en-US"/>
-          </a:p>
-        </p:txBody>
-      </p:sp>
-    </p:spTree>
-    <p:extLst>
-      <p:ext uri="{BB962C8B-B14F-4D97-AF65-F5344CB8AC3E}">
-        <p14:creationId xmlns:p14="http://schemas.microsoft.com/office/powerpoint/2010/main" val="1024086991"/>
-      </p:ext>
-    </p:extLst>
-  </p:cSld>
-  <p:clrMapOvr>
-    <a:masterClrMapping/>
-  </p:clrMapOvr>
-</p:notes>
-</file>
-
 <file path=ppt/slideLayouts/slideLayout1.xml><?xml version="1.0" encoding="utf-8"?>
 <p:sldLayout xmlns:a="http://schemas.openxmlformats.org/drawingml/2006/main" xmlns:r="http://schemas.openxmlformats.org/officeDocument/2006/relationships" xmlns:p="http://schemas.openxmlformats.org/presentationml/2006/main" preserve="1">
   <p:cSld name="DEFAULT">
@@ -1500,7 +1411,7 @@
         </p:blipFill>
         <p:spPr>
           <a:xfrm>
-            <a:off x="182880" y="182880"/>
+            <a:off x="146304" y="182880"/>
             <a:ext cx="1463040" cy="1463040"/>
           </a:xfrm>
           <a:prstGeom prst="rect">
@@ -1516,7 +1427,7 @@
         </p:nvSpPr>
         <p:spPr>
           <a:xfrm>
-            <a:off x="411480" y="2232050"/>
+            <a:off x="329184" y="2232050"/>
             <a:ext cx="4709160" cy="1325880"/>
           </a:xfrm>
           <a:prstGeom prst="rect">
@@ -1586,7 +1497,7 @@
         </p:nvSpPr>
         <p:spPr>
           <a:xfrm>
-            <a:off x="502920" y="3858768"/>
+            <a:off x="402336" y="3858768"/>
             <a:ext cx="457200" cy="50292"/>
           </a:xfrm>
           <a:prstGeom prst="rect">
@@ -1611,7 +1522,7 @@
         </p:nvSpPr>
         <p:spPr>
           <a:xfrm>
-            <a:off x="1024128" y="3858768"/>
+            <a:off x="819302" y="3858768"/>
             <a:ext cx="3017520" cy="50292"/>
           </a:xfrm>
           <a:prstGeom prst="rect">
@@ -1636,8 +1547,8 @@
         </p:nvSpPr>
         <p:spPr>
           <a:xfrm>
-            <a:off x="521208" y="4041648"/>
-            <a:ext cx="3443630" cy="402336"/>
+            <a:off x="329184" y="4041648"/>
+            <a:ext cx="3553358" cy="402336"/>
           </a:xfrm>
           <a:prstGeom prst="rect">
             <a:avLst/>
@@ -1661,7 +1572,7 @@
                 <a:ea typeface="Montserrat" pitchFamily="34" charset="-122"/>
                 <a:cs typeface="Montserrat" pitchFamily="34" charset="-120"/>
               </a:rPr>
-              <a:t>Ahmedabad   ·   4 Properties</a:t>
+              <a:t>Bangalore   ·   3 Properties</a:t>
             </a:r>
             <a:endParaRPr lang="en-US" sz="1100" dirty="0"/>
           </a:p>
@@ -1675,8 +1586,8 @@
         </p:nvSpPr>
         <p:spPr>
           <a:xfrm>
-            <a:off x="502920" y="4887468"/>
-            <a:ext cx="4389120" cy="256032"/>
+            <a:off x="329184" y="4773168"/>
+            <a:ext cx="4480560" cy="256032"/>
           </a:xfrm>
           <a:prstGeom prst="rect">
             <a:avLst/>
@@ -1692,7 +1603,7 @@
               <a:buNone/>
             </a:pPr>
             <a:r>
-              <a:rPr lang="en-US" sz="850" dirty="0">
+              <a:rPr lang="en-US" sz="750" dirty="0">
                 <a:solidFill>
                   <a:srgbClr val="1A3350"/>
                 </a:solidFill>
@@ -1700,9 +1611,9 @@
                 <a:ea typeface="Montserrat" pitchFamily="34" charset="-122"/>
                 <a:cs typeface="Montserrat" pitchFamily="34" charset="-120"/>
               </a:rPr>
-              <a:t>Prepared by WareOnGo  |  Dated 23/05/2026  |  Confidential</a:t>
+              <a:t>Prepared by WareOnGo  |  Dated 25/05/2026  |  Confidential</a:t>
             </a:r>
-            <a:endParaRPr lang="en-US" sz="850" dirty="0"/>
+            <a:endParaRPr lang="en-US" sz="750" dirty="0"/>
           </a:p>
         </p:txBody>
       </p:sp>
@@ -1759,7 +1670,7 @@
           <a:bodyPr wrap="square" rtlCol="0" anchor="ctr"/>
           <a:lstStyle/>
           <a:p>
-            <a:pPr indent="0" marL="0">
+            <a:pPr algn="ctr" indent="0" marL="0">
               <a:buNone/>
             </a:pPr>
             <a:r>
@@ -2303,7 +2214,7 @@
                           <a:ea typeface="Montserrat" pitchFamily="34" charset="-122"/>
                           <a:cs typeface="Montserrat" pitchFamily="34" charset="-120"/>
                         </a:rPr>
-                        <a:t>298</a:t>
+                        <a:t>1512</a:t>
                       </a:r>
                       <a:endParaRPr lang="en-US" sz="800" dirty="0">
                         <a:latin typeface="Montserrat" charset="0"/>
@@ -2371,7 +2282,7 @@
                           <a:ea typeface="Montserrat" pitchFamily="34" charset="-122"/>
                           <a:cs typeface="Montserrat" pitchFamily="34" charset="-120"/>
                         </a:rPr>
-                        <a:t>Ahmedabad, Gujarat</a:t>
+                        <a:t>Bangalore, Karnataka</a:t>
                       </a:r>
                       <a:endParaRPr lang="en-US" sz="800" dirty="0">
                         <a:latin typeface="Montserrat" charset="0"/>
@@ -2439,7 +2350,7 @@
                           <a:ea typeface="Montserrat" pitchFamily="34" charset="-122"/>
                           <a:cs typeface="Montserrat" pitchFamily="34" charset="-120"/>
                         </a:rPr>
-                        <a:t>19/-</a:t>
+                        <a:t>28/-</a:t>
                       </a:r>
                       <a:endParaRPr lang="en-US" sz="800" dirty="0">
                         <a:latin typeface="Montserrat" charset="0"/>
@@ -2507,7 +2418,7 @@
                           <a:ea typeface="Montserrat" pitchFamily="34" charset="-122"/>
                           <a:cs typeface="Montserrat" pitchFamily="34" charset="-120"/>
                         </a:rPr>
-                        <a:t>34000</a:t>
+                        <a:t>25000</a:t>
                       </a:r>
                       <a:endParaRPr lang="en-US" sz="800" dirty="0">
                         <a:latin typeface="Montserrat" charset="0"/>
@@ -2713,7 +2624,7 @@
                           <a:ea typeface="Montserrat" pitchFamily="34" charset="-122"/>
                           <a:cs typeface="Montserrat" pitchFamily="34" charset="-120"/>
                         </a:rPr>
-                        <a:t>299</a:t>
+                        <a:t>325</a:t>
                       </a:r>
                       <a:endParaRPr lang="en-US" sz="800" dirty="0">
                         <a:latin typeface="Montserrat" charset="0"/>
@@ -2781,7 +2692,7 @@
                           <a:ea typeface="Montserrat" pitchFamily="34" charset="-122"/>
                           <a:cs typeface="Montserrat" pitchFamily="34" charset="-120"/>
                         </a:rPr>
-                        <a:t>Ahmedabad, Gujarat</a:t>
+                        <a:t>Bangalore, Karnataka</a:t>
                       </a:r>
                       <a:endParaRPr lang="en-US" sz="800" dirty="0">
                         <a:latin typeface="Montserrat" charset="0"/>
@@ -2849,7 +2760,7 @@
                           <a:ea typeface="Montserrat" pitchFamily="34" charset="-122"/>
                           <a:cs typeface="Montserrat" pitchFamily="34" charset="-120"/>
                         </a:rPr>
-                        <a:t>17/-</a:t>
+                        <a:t>24/-</a:t>
                       </a:r>
                       <a:endParaRPr lang="en-US" sz="800" dirty="0">
                         <a:latin typeface="Montserrat" charset="0"/>
@@ -2917,7 +2828,7 @@
                           <a:ea typeface="Montserrat" pitchFamily="34" charset="-122"/>
                           <a:cs typeface="Montserrat" pitchFamily="34" charset="-120"/>
                         </a:rPr>
-                        <a:t>23000</a:t>
+                        <a:t>15000, 65000</a:t>
                       </a:r>
                       <a:endParaRPr lang="en-US" sz="800" dirty="0">
                         <a:latin typeface="Montserrat" charset="0"/>
@@ -2985,7 +2896,7 @@
                           <a:ea typeface="Montserrat" pitchFamily="34" charset="-122"/>
                           <a:cs typeface="Montserrat" pitchFamily="34" charset="-120"/>
                         </a:rPr>
-                        <a:t>Immediate</a:t>
+                        <a:t>3 months post LOI</a:t>
                       </a:r>
                       <a:endParaRPr lang="en-US" sz="800" dirty="0">
                         <a:latin typeface="Montserrat" charset="0"/>
@@ -3123,7 +3034,7 @@
                           <a:ea typeface="Montserrat" pitchFamily="34" charset="-122"/>
                           <a:cs typeface="Montserrat" pitchFamily="34" charset="-120"/>
                         </a:rPr>
-                        <a:t>569</a:t>
+                        <a:t>893</a:t>
                       </a:r>
                       <a:endParaRPr lang="en-US" sz="800" dirty="0">
                         <a:latin typeface="Montserrat" charset="0"/>
@@ -3191,7 +3102,7 @@
                           <a:ea typeface="Montserrat" pitchFamily="34" charset="-122"/>
                           <a:cs typeface="Montserrat" pitchFamily="34" charset="-120"/>
                         </a:rPr>
-                        <a:t>Bengaluru, Karnataka</a:t>
+                        <a:t>Bangalore, Karnataka</a:t>
                       </a:r>
                       <a:endParaRPr lang="en-US" sz="800" dirty="0">
                         <a:latin typeface="Montserrat" charset="0"/>
@@ -3259,7 +3170,7 @@
                           <a:ea typeface="Montserrat" pitchFamily="34" charset="-122"/>
                           <a:cs typeface="Montserrat" pitchFamily="34" charset="-120"/>
                         </a:rPr>
-                        <a:t>60/-</a:t>
+                        <a:t>27+1/-</a:t>
                       </a:r>
                       <a:endParaRPr lang="en-US" sz="800" dirty="0">
                         <a:latin typeface="Montserrat" charset="0"/>
@@ -3327,417 +3238,7 @@
                           <a:ea typeface="Montserrat" pitchFamily="34" charset="-122"/>
                           <a:cs typeface="Montserrat" pitchFamily="34" charset="-120"/>
                         </a:rPr>
-                        <a:t>3500</a:t>
-                      </a:r>
-                      <a:endParaRPr lang="en-US" sz="800" dirty="0">
-                        <a:latin typeface="Montserrat" charset="0"/>
-                        <a:ea typeface="Montserrat" charset="0"/>
-                        <a:cs typeface="Montserrat" charset="0"/>
-                      </a:endParaRPr>
-                    </a:p>
-                  </a:txBody>
-                  <a:tcPr marL="91440" marR="91440" marT="45720" marB="45720" anchor="ctr">
-                    <a:lnL w="6350" cap="flat" cmpd="sng" algn="ctr">
-                      <a:solidFill>
-                        <a:srgbClr val="CCCCCC"/>
-                      </a:solidFill>
-                      <a:prstDash val="solid"/>
-                      <a:round/>
-                      <a:headEnd type="none" w="med" len="med"/>
-                      <a:tailEnd type="none" w="med" len="med"/>
-                    </a:lnL>
-                    <a:lnR w="6350" cap="flat" cmpd="sng" algn="ctr">
-                      <a:solidFill>
-                        <a:srgbClr val="CCCCCC"/>
-                      </a:solidFill>
-                      <a:prstDash val="solid"/>
-                      <a:round/>
-                      <a:headEnd type="none" w="med" len="med"/>
-                      <a:tailEnd type="none" w="med" len="med"/>
-                    </a:lnR>
-                    <a:lnT w="6350" cap="flat" cmpd="sng" algn="ctr">
-                      <a:solidFill>
-                        <a:srgbClr val="CCCCCC"/>
-                      </a:solidFill>
-                      <a:prstDash val="solid"/>
-                      <a:round/>
-                      <a:headEnd type="none" w="med" len="med"/>
-                      <a:tailEnd type="none" w="med" len="med"/>
-                    </a:lnT>
-                    <a:lnB w="6350" cap="flat" cmpd="sng" algn="ctr">
-                      <a:solidFill>
-                        <a:srgbClr val="CCCCCC"/>
-                      </a:solidFill>
-                      <a:prstDash val="solid"/>
-                      <a:round/>
-                      <a:headEnd type="none" w="med" len="med"/>
-                      <a:tailEnd type="none" w="med" len="med"/>
-                    </a:lnB>
-                    <a:solidFill>
-                      <a:srgbClr val="F8F6F1"/>
-                    </a:solidFill>
-                  </a:tcPr>
-                </a:tc>
-                <a:tc>
-                  <a:txBody>
-                    <a:bodyPr/>
-                    <a:lstStyle/>
-                    <a:p>
-                      <a:pPr algn="ctr" indent="0" marL="0">
-                        <a:buNone/>
-                      </a:pPr>
-                      <a:r>
-                        <a:rPr lang="en-US" sz="800" dirty="0">
-                          <a:solidFill>
-                            <a:srgbClr val="1A3350"/>
-                          </a:solidFill>
-                          <a:latin typeface="Montserrat" pitchFamily="34" charset="0"/>
-                          <a:ea typeface="Montserrat" pitchFamily="34" charset="-122"/>
-                          <a:cs typeface="Montserrat" pitchFamily="34" charset="-120"/>
-                        </a:rPr>
-                        <a:t>Immediate</a:t>
-                      </a:r>
-                      <a:endParaRPr lang="en-US" sz="800" dirty="0">
-                        <a:latin typeface="Montserrat" charset="0"/>
-                        <a:ea typeface="Montserrat" charset="0"/>
-                        <a:cs typeface="Montserrat" charset="0"/>
-                      </a:endParaRPr>
-                    </a:p>
-                  </a:txBody>
-                  <a:tcPr marL="91440" marR="91440" marT="45720" marB="45720" anchor="ctr">
-                    <a:lnL w="6350" cap="flat" cmpd="sng" algn="ctr">
-                      <a:solidFill>
-                        <a:srgbClr val="CCCCCC"/>
-                      </a:solidFill>
-                      <a:prstDash val="solid"/>
-                      <a:round/>
-                      <a:headEnd type="none" w="med" len="med"/>
-                      <a:tailEnd type="none" w="med" len="med"/>
-                    </a:lnL>
-                    <a:lnR w="6350" cap="flat" cmpd="sng" algn="ctr">
-                      <a:solidFill>
-                        <a:srgbClr val="CCCCCC"/>
-                      </a:solidFill>
-                      <a:prstDash val="solid"/>
-                      <a:round/>
-                      <a:headEnd type="none" w="med" len="med"/>
-                      <a:tailEnd type="none" w="med" len="med"/>
-                    </a:lnR>
-                    <a:lnT w="6350" cap="flat" cmpd="sng" algn="ctr">
-                      <a:solidFill>
-                        <a:srgbClr val="CCCCCC"/>
-                      </a:solidFill>
-                      <a:prstDash val="solid"/>
-                      <a:round/>
-                      <a:headEnd type="none" w="med" len="med"/>
-                      <a:tailEnd type="none" w="med" len="med"/>
-                    </a:lnT>
-                    <a:lnB w="6350" cap="flat" cmpd="sng" algn="ctr">
-                      <a:solidFill>
-                        <a:srgbClr val="CCCCCC"/>
-                      </a:solidFill>
-                      <a:prstDash val="solid"/>
-                      <a:round/>
-                      <a:headEnd type="none" w="med" len="med"/>
-                      <a:tailEnd type="none" w="med" len="med"/>
-                    </a:lnB>
-                    <a:solidFill>
-                      <a:srgbClr val="F8F6F1"/>
-                    </a:solidFill>
-                  </a:tcPr>
-                </a:tc>
-              </a:tr>
-              <a:tr h="365760">
-                <a:tc>
-                  <a:txBody>
-                    <a:bodyPr/>
-                    <a:lstStyle/>
-                    <a:p>
-                      <a:pPr algn="ctr" indent="0" marL="0">
-                        <a:buNone/>
-                      </a:pPr>
-                      <a:r>
-                        <a:rPr lang="en-US" sz="800" dirty="0">
-                          <a:solidFill>
-                            <a:srgbClr val="1A3350"/>
-                          </a:solidFill>
-                          <a:latin typeface="Montserrat" pitchFamily="34" charset="0"/>
-                          <a:ea typeface="Montserrat" pitchFamily="34" charset="-122"/>
-                          <a:cs typeface="Montserrat" pitchFamily="34" charset="-120"/>
-                        </a:rPr>
-                        <a:t>4</a:t>
-                      </a:r>
-                      <a:endParaRPr lang="en-US" sz="800" dirty="0">
-                        <a:latin typeface="Montserrat" charset="0"/>
-                        <a:ea typeface="Montserrat" charset="0"/>
-                        <a:cs typeface="Montserrat" charset="0"/>
-                      </a:endParaRPr>
-                    </a:p>
-                  </a:txBody>
-                  <a:tcPr marL="91440" marR="91440" marT="45720" marB="45720" anchor="ctr">
-                    <a:lnL w="6350" cap="flat" cmpd="sng" algn="ctr">
-                      <a:solidFill>
-                        <a:srgbClr val="CCCCCC"/>
-                      </a:solidFill>
-                      <a:prstDash val="solid"/>
-                      <a:round/>
-                      <a:headEnd type="none" w="med" len="med"/>
-                      <a:tailEnd type="none" w="med" len="med"/>
-                    </a:lnL>
-                    <a:lnR w="6350" cap="flat" cmpd="sng" algn="ctr">
-                      <a:solidFill>
-                        <a:srgbClr val="CCCCCC"/>
-                      </a:solidFill>
-                      <a:prstDash val="solid"/>
-                      <a:round/>
-                      <a:headEnd type="none" w="med" len="med"/>
-                      <a:tailEnd type="none" w="med" len="med"/>
-                    </a:lnR>
-                    <a:lnT w="6350" cap="flat" cmpd="sng" algn="ctr">
-                      <a:solidFill>
-                        <a:srgbClr val="CCCCCC"/>
-                      </a:solidFill>
-                      <a:prstDash val="solid"/>
-                      <a:round/>
-                      <a:headEnd type="none" w="med" len="med"/>
-                      <a:tailEnd type="none" w="med" len="med"/>
-                    </a:lnT>
-                    <a:lnB w="6350" cap="flat" cmpd="sng" algn="ctr">
-                      <a:solidFill>
-                        <a:srgbClr val="CCCCCC"/>
-                      </a:solidFill>
-                      <a:prstDash val="solid"/>
-                      <a:round/>
-                      <a:headEnd type="none" w="med" len="med"/>
-                      <a:tailEnd type="none" w="med" len="med"/>
-                    </a:lnB>
-                    <a:solidFill>
-                      <a:srgbClr val="F8F6F1"/>
-                    </a:solidFill>
-                  </a:tcPr>
-                </a:tc>
-                <a:tc>
-                  <a:txBody>
-                    <a:bodyPr/>
-                    <a:lstStyle/>
-                    <a:p>
-                      <a:pPr algn="ctr" indent="0" marL="0">
-                        <a:buNone/>
-                      </a:pPr>
-                      <a:r>
-                        <a:rPr lang="en-US" sz="800" dirty="0">
-                          <a:solidFill>
-                            <a:srgbClr val="1A3350"/>
-                          </a:solidFill>
-                          <a:latin typeface="Montserrat" pitchFamily="34" charset="0"/>
-                          <a:ea typeface="Montserrat" pitchFamily="34" charset="-122"/>
-                          <a:cs typeface="Montserrat" pitchFamily="34" charset="-120"/>
-                        </a:rPr>
-                        <a:t>1638</a:t>
-                      </a:r>
-                      <a:endParaRPr lang="en-US" sz="800" dirty="0">
-                        <a:latin typeface="Montserrat" charset="0"/>
-                        <a:ea typeface="Montserrat" charset="0"/>
-                        <a:cs typeface="Montserrat" charset="0"/>
-                      </a:endParaRPr>
-                    </a:p>
-                  </a:txBody>
-                  <a:tcPr marL="91440" marR="91440" marT="45720" marB="45720" anchor="ctr">
-                    <a:lnL w="6350" cap="flat" cmpd="sng" algn="ctr">
-                      <a:solidFill>
-                        <a:srgbClr val="CCCCCC"/>
-                      </a:solidFill>
-                      <a:prstDash val="solid"/>
-                      <a:round/>
-                      <a:headEnd type="none" w="med" len="med"/>
-                      <a:tailEnd type="none" w="med" len="med"/>
-                    </a:lnL>
-                    <a:lnR w="6350" cap="flat" cmpd="sng" algn="ctr">
-                      <a:solidFill>
-                        <a:srgbClr val="CCCCCC"/>
-                      </a:solidFill>
-                      <a:prstDash val="solid"/>
-                      <a:round/>
-                      <a:headEnd type="none" w="med" len="med"/>
-                      <a:tailEnd type="none" w="med" len="med"/>
-                    </a:lnR>
-                    <a:lnT w="6350" cap="flat" cmpd="sng" algn="ctr">
-                      <a:solidFill>
-                        <a:srgbClr val="CCCCCC"/>
-                      </a:solidFill>
-                      <a:prstDash val="solid"/>
-                      <a:round/>
-                      <a:headEnd type="none" w="med" len="med"/>
-                      <a:tailEnd type="none" w="med" len="med"/>
-                    </a:lnT>
-                    <a:lnB w="6350" cap="flat" cmpd="sng" algn="ctr">
-                      <a:solidFill>
-                        <a:srgbClr val="CCCCCC"/>
-                      </a:solidFill>
-                      <a:prstDash val="solid"/>
-                      <a:round/>
-                      <a:headEnd type="none" w="med" len="med"/>
-                      <a:tailEnd type="none" w="med" len="med"/>
-                    </a:lnB>
-                    <a:solidFill>
-                      <a:srgbClr val="F8F6F1"/>
-                    </a:solidFill>
-                  </a:tcPr>
-                </a:tc>
-                <a:tc>
-                  <a:txBody>
-                    <a:bodyPr/>
-                    <a:lstStyle/>
-                    <a:p>
-                      <a:pPr algn="ctr" indent="0" marL="0">
-                        <a:buNone/>
-                      </a:pPr>
-                      <a:r>
-                        <a:rPr lang="en-US" sz="800" dirty="0">
-                          <a:solidFill>
-                            <a:srgbClr val="1A3350"/>
-                          </a:solidFill>
-                          <a:latin typeface="Montserrat" pitchFamily="34" charset="0"/>
-                          <a:ea typeface="Montserrat" pitchFamily="34" charset="-122"/>
-                          <a:cs typeface="Montserrat" pitchFamily="34" charset="-120"/>
-                        </a:rPr>
-                        <a:t>Secunderabad, Telangana</a:t>
-                      </a:r>
-                      <a:endParaRPr lang="en-US" sz="800" dirty="0">
-                        <a:latin typeface="Montserrat" charset="0"/>
-                        <a:ea typeface="Montserrat" charset="0"/>
-                        <a:cs typeface="Montserrat" charset="0"/>
-                      </a:endParaRPr>
-                    </a:p>
-                  </a:txBody>
-                  <a:tcPr marL="91440" marR="91440" marT="45720" marB="45720" anchor="ctr">
-                    <a:lnL w="6350" cap="flat" cmpd="sng" algn="ctr">
-                      <a:solidFill>
-                        <a:srgbClr val="CCCCCC"/>
-                      </a:solidFill>
-                      <a:prstDash val="solid"/>
-                      <a:round/>
-                      <a:headEnd type="none" w="med" len="med"/>
-                      <a:tailEnd type="none" w="med" len="med"/>
-                    </a:lnL>
-                    <a:lnR w="6350" cap="flat" cmpd="sng" algn="ctr">
-                      <a:solidFill>
-                        <a:srgbClr val="CCCCCC"/>
-                      </a:solidFill>
-                      <a:prstDash val="solid"/>
-                      <a:round/>
-                      <a:headEnd type="none" w="med" len="med"/>
-                      <a:tailEnd type="none" w="med" len="med"/>
-                    </a:lnR>
-                    <a:lnT w="6350" cap="flat" cmpd="sng" algn="ctr">
-                      <a:solidFill>
-                        <a:srgbClr val="CCCCCC"/>
-                      </a:solidFill>
-                      <a:prstDash val="solid"/>
-                      <a:round/>
-                      <a:headEnd type="none" w="med" len="med"/>
-                      <a:tailEnd type="none" w="med" len="med"/>
-                    </a:lnT>
-                    <a:lnB w="6350" cap="flat" cmpd="sng" algn="ctr">
-                      <a:solidFill>
-                        <a:srgbClr val="CCCCCC"/>
-                      </a:solidFill>
-                      <a:prstDash val="solid"/>
-                      <a:round/>
-                      <a:headEnd type="none" w="med" len="med"/>
-                      <a:tailEnd type="none" w="med" len="med"/>
-                    </a:lnB>
-                    <a:solidFill>
-                      <a:srgbClr val="F8F6F1"/>
-                    </a:solidFill>
-                  </a:tcPr>
-                </a:tc>
-                <a:tc>
-                  <a:txBody>
-                    <a:bodyPr/>
-                    <a:lstStyle/>
-                    <a:p>
-                      <a:pPr algn="ctr" indent="0" marL="0">
-                        <a:buNone/>
-                      </a:pPr>
-                      <a:r>
-                        <a:rPr lang="en-US" sz="800" dirty="0">
-                          <a:solidFill>
-                            <a:srgbClr val="1A3350"/>
-                          </a:solidFill>
-                          <a:latin typeface="Montserrat" pitchFamily="34" charset="0"/>
-                          <a:ea typeface="Montserrat" pitchFamily="34" charset="-122"/>
-                          <a:cs typeface="Montserrat" pitchFamily="34" charset="-120"/>
-                        </a:rPr>
-                        <a:t>22/-</a:t>
-                      </a:r>
-                      <a:endParaRPr lang="en-US" sz="800" dirty="0">
-                        <a:latin typeface="Montserrat" charset="0"/>
-                        <a:ea typeface="Montserrat" charset="0"/>
-                        <a:cs typeface="Montserrat" charset="0"/>
-                      </a:endParaRPr>
-                    </a:p>
-                  </a:txBody>
-                  <a:tcPr marL="91440" marR="91440" marT="45720" marB="45720" anchor="ctr">
-                    <a:lnL w="6350" cap="flat" cmpd="sng" algn="ctr">
-                      <a:solidFill>
-                        <a:srgbClr val="CCCCCC"/>
-                      </a:solidFill>
-                      <a:prstDash val="solid"/>
-                      <a:round/>
-                      <a:headEnd type="none" w="med" len="med"/>
-                      <a:tailEnd type="none" w="med" len="med"/>
-                    </a:lnL>
-                    <a:lnR w="6350" cap="flat" cmpd="sng" algn="ctr">
-                      <a:solidFill>
-                        <a:srgbClr val="CCCCCC"/>
-                      </a:solidFill>
-                      <a:prstDash val="solid"/>
-                      <a:round/>
-                      <a:headEnd type="none" w="med" len="med"/>
-                      <a:tailEnd type="none" w="med" len="med"/>
-                    </a:lnR>
-                    <a:lnT w="6350" cap="flat" cmpd="sng" algn="ctr">
-                      <a:solidFill>
-                        <a:srgbClr val="CCCCCC"/>
-                      </a:solidFill>
-                      <a:prstDash val="solid"/>
-                      <a:round/>
-                      <a:headEnd type="none" w="med" len="med"/>
-                      <a:tailEnd type="none" w="med" len="med"/>
-                    </a:lnT>
-                    <a:lnB w="6350" cap="flat" cmpd="sng" algn="ctr">
-                      <a:solidFill>
-                        <a:srgbClr val="CCCCCC"/>
-                      </a:solidFill>
-                      <a:prstDash val="solid"/>
-                      <a:round/>
-                      <a:headEnd type="none" w="med" len="med"/>
-                      <a:tailEnd type="none" w="med" len="med"/>
-                    </a:lnB>
-                    <a:solidFill>
-                      <a:srgbClr val="F8F6F1"/>
-                    </a:solidFill>
-                  </a:tcPr>
-                </a:tc>
-                <a:tc>
-                  <a:txBody>
-                    <a:bodyPr/>
-                    <a:lstStyle/>
-                    <a:p>
-                      <a:pPr algn="ctr" indent="0" marL="0">
-                        <a:buNone/>
-                      </a:pPr>
-                      <a:r>
-                        <a:rPr lang="en-US" sz="800" dirty="0">
-                          <a:solidFill>
-                            <a:srgbClr val="1A3350"/>
-                          </a:solidFill>
-                          <a:latin typeface="Montserrat" pitchFamily="34" charset="0"/>
-                          <a:ea typeface="Montserrat" pitchFamily="34" charset="-122"/>
-                          <a:cs typeface="Montserrat" pitchFamily="34" charset="-120"/>
-                        </a:rPr>
-                        <a:t>17100</a:t>
+                        <a:t>235060</a:t>
                       </a:r>
                       <a:endParaRPr lang="en-US" sz="800" dirty="0">
                         <a:latin typeface="Montserrat" charset="0"/>
@@ -3893,8 +3394,8 @@
         </p:nvSpPr>
         <p:spPr>
           <a:xfrm>
-            <a:off x="4572000" y="4887468"/>
-            <a:ext cx="4389120" cy="256032"/>
+            <a:off x="4251960" y="4773168"/>
+            <a:ext cx="4572000" cy="256032"/>
           </a:xfrm>
           <a:prstGeom prst="rect">
             <a:avLst/>
@@ -3910,7 +3411,7 @@
               <a:buNone/>
             </a:pPr>
             <a:r>
-              <a:rPr lang="en-US" sz="850" dirty="0">
+              <a:rPr lang="en-US" sz="750" dirty="0">
                 <a:solidFill>
                   <a:srgbClr val="1A3350"/>
                 </a:solidFill>
@@ -3918,9 +3419,9 @@
                 <a:ea typeface="Montserrat" pitchFamily="34" charset="-122"/>
                 <a:cs typeface="Montserrat" pitchFamily="34" charset="-120"/>
               </a:rPr>
-              <a:t>Prepared by WareOnGo  |  Dated 23/05/2026  |  Confidential</a:t>
+              <a:t>Prepared by WareOnGo  |  Dated 25/05/2026  |  Confidential</a:t>
             </a:r>
-            <a:endParaRPr lang="en-US" sz="850" dirty="0"/>
+            <a:endParaRPr lang="en-US" sz="750" dirty="0"/>
           </a:p>
         </p:txBody>
       </p:sp>
@@ -3965,7 +3466,7 @@
         <p:spPr>
           <a:xfrm>
             <a:off x="0" y="0"/>
-            <a:ext cx="2400300" cy="5143500"/>
+            <a:ext cx="2606040" cy="5143500"/>
           </a:xfrm>
           <a:prstGeom prst="rect">
             <a:avLst/>
@@ -3989,7 +3490,7 @@
         </p:nvSpPr>
         <p:spPr>
           <a:xfrm>
-            <a:off x="2400300" y="0"/>
+            <a:off x="2606040" y="0"/>
             <a:ext cx="0" cy="5143500"/>
           </a:xfrm>
           <a:prstGeom prst="line">
@@ -4037,7 +3538,7 @@
                 <a:ea typeface="Montserrat ExtraBold" pitchFamily="34" charset="-122"/>
                 <a:cs typeface="Montserrat ExtraBold" pitchFamily="34" charset="-120"/>
               </a:rPr>
-              <a:t>Option 1 - ID 298</a:t>
+              <a:t>Option 1 - ID 1512</a:t>
             </a:r>
             <a:endParaRPr lang="en-US" sz="1300" dirty="0"/>
           </a:p>
@@ -4098,7 +3599,7 @@
         </p:nvGraphicFramePr>
         <p:xfrm>
           <a:off x="137160" y="735178"/>
-          <a:ext cx="2121408" cy="914400"/>
+          <a:ext cx="2395728" cy="914400"/>
         </p:xfrm>
         <a:graphic>
           <a:graphicData uri="http://schemas.openxmlformats.org/drawingml/2006/table">
@@ -4106,7 +3607,7 @@
               <a:tblPr/>
               <a:tblGrid>
                 <a:gridCol w="749808"/>
-                <a:gridCol w="1371600"/>
+                <a:gridCol w="1645920"/>
               </a:tblGrid>
               <a:tr h="286664">
                 <a:tc>
@@ -4194,7 +3695,7 @@
                           <a:ea typeface="Montserrat" pitchFamily="34" charset="-122"/>
                           <a:cs typeface="Montserrat" pitchFamily="34" charset="-120"/>
                         </a:rPr>
-                        <a:t>Ahmedabad, Gujarat</a:t>
+                        <a:t>Bangalore, Karnataka</a:t>
                       </a:r>
                       <a:endParaRPr lang="en-US" sz="700" dirty="0">
                         <a:latin typeface="Montserrat" charset="0"/>
@@ -4324,13 +3825,20 @@
                         <a:buNone/>
                       </a:pPr>
                       <a:r>
-                        <a:rPr lang="en-US" sz="700" dirty="0">
+                        <a:rPr lang="en-US" sz="700" u="sng" dirty="0">
                           <a:solidFill>
-                            <a:srgbClr val="1A3350"/>
+                            <a:srgbClr val="1A56DB"/>
                           </a:solidFill>
                           <a:latin typeface="Montserrat" pitchFamily="34" charset="0"/>
                           <a:ea typeface="Montserrat" pitchFamily="34" charset="-122"/>
                           <a:cs typeface="Montserrat" pitchFamily="34" charset="-120"/>
+                          <a:hlinkClick r:id="rId1" invalidUrl="" action="" tgtFrame="" tooltip="" history="1" highlightClick="0" endSnd="0">
+                            <a:extLst>
+                              <a:ext uri="{A12FA001-AC4F-418D-AE19-62706E023703}">
+                                <ahyp:hlinkClr xmlns:ahyp="http://schemas.microsoft.com/office/drawing/2018/hyperlinkcolor" val="tx"/>
+                              </a:ext>
+                            </a:extLst>
+                          </a:hlinkClick>
                         </a:rPr>
                         <a:t>See link</a:t>
                       </a:r>
@@ -4443,7 +3951,7 @@
         </p:nvGraphicFramePr>
         <p:xfrm>
           <a:off x="137160" y="1674266"/>
-          <a:ext cx="2121408" cy="914400"/>
+          <a:ext cx="2395728" cy="914400"/>
         </p:xfrm>
         <a:graphic>
           <a:graphicData uri="http://schemas.openxmlformats.org/drawingml/2006/table">
@@ -4451,7 +3959,7 @@
               <a:tblPr/>
               <a:tblGrid>
                 <a:gridCol w="749808"/>
-                <a:gridCol w="594360"/>
+                <a:gridCol w="868680"/>
                 <a:gridCol w="777240"/>
               </a:tblGrid>
               <a:tr h="286664">
@@ -4540,7 +4048,7 @@
                           <a:ea typeface="Montserrat" pitchFamily="34" charset="-122"/>
                           <a:cs typeface="Montserrat" pitchFamily="34" charset="-120"/>
                         </a:rPr>
-                        <a:t>34000 sqft</a:t>
+                        <a:t>25000 sqft</a:t>
                       </a:r>
                       <a:endParaRPr lang="en-US" sz="700" dirty="0">
                         <a:latin typeface="Montserrat" charset="0"/>
@@ -4736,7 +4244,7 @@
                   <a:tcPr/>
                 </a:tc>
               </a:tr>
-              <a:tr h="286664">
+              <a:tr h="416966">
                 <a:tc>
                   <a:txBody>
                     <a:bodyPr/>
@@ -4805,7 +4313,7 @@
                     </a:solidFill>
                   </a:tcPr>
                 </a:tc>
-                <a:tc gridSpan="2">
+                <a:tc>
                   <a:txBody>
                     <a:bodyPr/>
                     <a:lstStyle/>
@@ -4822,7 +4330,7 @@
                           <a:ea typeface="Montserrat" pitchFamily="34" charset="-122"/>
                           <a:cs typeface="Montserrat" pitchFamily="34" charset="-120"/>
                         </a:rPr>
-                        <a:t>4</a:t>
+                        <a:t>3</a:t>
                       </a:r>
                       <a:endParaRPr lang="en-US" sz="700" dirty="0">
                         <a:latin typeface="Montserrat" charset="0"/>
@@ -4873,8 +4381,73 @@
                     </a:solidFill>
                   </a:tcPr>
                 </a:tc>
-                <a:tc hMerge="1">
-                  <a:tcPr/>
+                <a:tc>
+                  <a:txBody>
+                    <a:bodyPr/>
+                    <a:lstStyle/>
+                    <a:p>
+                      <a:pPr indent="0" marL="0">
+                        <a:buNone/>
+                      </a:pPr>
+                      <a:r>
+                        <a:rPr lang="en-US" sz="700" dirty="0">
+                          <a:solidFill>
+                            <a:srgbClr val="1A3350"/>
+                          </a:solidFill>
+                          <a:latin typeface="Montserrat" pitchFamily="34" charset="0"/>
+                          <a:ea typeface="Montserrat" pitchFamily="34" charset="-122"/>
+                          <a:cs typeface="Montserrat" pitchFamily="34" charset="-120"/>
+                        </a:rPr>
+                        <a:t>4ft plinth height</a:t>
+                      </a:r>
+                      <a:endParaRPr lang="en-US" sz="700" dirty="0">
+                        <a:latin typeface="Montserrat" charset="0"/>
+                        <a:ea typeface="Montserrat" charset="0"/>
+                        <a:cs typeface="Montserrat" charset="0"/>
+                      </a:endParaRPr>
+                    </a:p>
+                  </a:txBody>
+                  <a:tcPr marL="45720" marR="45720" marT="45720" marB="45720" anchor="ctr">
+                    <a:lnL w="6350" cap="flat" cmpd="sng" algn="ctr">
+                      <a:solidFill>
+                        <a:srgbClr val="CCCCCC"/>
+                      </a:solidFill>
+                      <a:prstDash val="solid"/>
+                      <a:round/>
+                      <a:headEnd type="none" w="med" len="med"/>
+                      <a:tailEnd type="none" w="med" len="med"/>
+                    </a:lnL>
+                    <a:lnR w="6350" cap="flat" cmpd="sng" algn="ctr">
+                      <a:solidFill>
+                        <a:srgbClr val="CCCCCC"/>
+                      </a:solidFill>
+                      <a:prstDash val="solid"/>
+                      <a:round/>
+                      <a:headEnd type="none" w="med" len="med"/>
+                      <a:tailEnd type="none" w="med" len="med"/>
+                    </a:lnR>
+                    <a:lnT w="6350" cap="flat" cmpd="sng" algn="ctr">
+                      <a:solidFill>
+                        <a:srgbClr val="CCCCCC"/>
+                      </a:solidFill>
+                      <a:prstDash val="solid"/>
+                      <a:round/>
+                      <a:headEnd type="none" w="med" len="med"/>
+                      <a:tailEnd type="none" w="med" len="med"/>
+                    </a:lnT>
+                    <a:lnB w="6350" cap="flat" cmpd="sng" algn="ctr">
+                      <a:solidFill>
+                        <a:srgbClr val="CCCCCC"/>
+                      </a:solidFill>
+                      <a:prstDash val="solid"/>
+                      <a:round/>
+                      <a:headEnd type="none" w="med" len="med"/>
+                      <a:tailEnd type="none" w="med" len="med"/>
+                    </a:lnB>
+                    <a:solidFill>
+                      <a:srgbClr val="F8F6F1"/>
+                    </a:solidFill>
+                  </a:tcPr>
                 </a:tc>
               </a:tr>
               <a:tr h="286664">
@@ -4946,7 +4519,7 @@
                     </a:solidFill>
                   </a:tcPr>
                 </a:tc>
-                <a:tc gridSpan="2">
+                <a:tc>
                   <a:txBody>
                     <a:bodyPr/>
                     <a:lstStyle/>
@@ -4963,7 +4536,7 @@
                           <a:ea typeface="Montserrat" pitchFamily="34" charset="-122"/>
                           <a:cs typeface="Montserrat" pitchFamily="34" charset="-120"/>
                         </a:rPr>
-                        <a:t>27ft</a:t>
+                        <a:t>35ft eaves</a:t>
                       </a:r>
                       <a:endParaRPr lang="en-US" sz="700" dirty="0">
                         <a:latin typeface="Montserrat" charset="0"/>
@@ -5014,8 +4587,73 @@
                     </a:solidFill>
                   </a:tcPr>
                 </a:tc>
-                <a:tc hMerge="1">
-                  <a:tcPr/>
+                <a:tc>
+                  <a:txBody>
+                    <a:bodyPr/>
+                    <a:lstStyle/>
+                    <a:p>
+                      <a:pPr indent="0" marL="0">
+                        <a:buNone/>
+                      </a:pPr>
+                      <a:r>
+                        <a:rPr lang="en-US" sz="700" dirty="0">
+                          <a:solidFill>
+                            <a:srgbClr val="1A3350"/>
+                          </a:solidFill>
+                          <a:latin typeface="Montserrat" pitchFamily="34" charset="0"/>
+                          <a:ea typeface="Montserrat" pitchFamily="34" charset="-122"/>
+                          <a:cs typeface="Montserrat" pitchFamily="34" charset="-120"/>
+                        </a:rPr>
+                        <a:t>40ft centre</a:t>
+                      </a:r>
+                      <a:endParaRPr lang="en-US" sz="700" dirty="0">
+                        <a:latin typeface="Montserrat" charset="0"/>
+                        <a:ea typeface="Montserrat" charset="0"/>
+                        <a:cs typeface="Montserrat" charset="0"/>
+                      </a:endParaRPr>
+                    </a:p>
+                  </a:txBody>
+                  <a:tcPr marL="45720" marR="45720" marT="45720" marB="45720" anchor="ctr">
+                    <a:lnL w="6350" cap="flat" cmpd="sng" algn="ctr">
+                      <a:solidFill>
+                        <a:srgbClr val="CCCCCC"/>
+                      </a:solidFill>
+                      <a:prstDash val="solid"/>
+                      <a:round/>
+                      <a:headEnd type="none" w="med" len="med"/>
+                      <a:tailEnd type="none" w="med" len="med"/>
+                    </a:lnL>
+                    <a:lnR w="6350" cap="flat" cmpd="sng" algn="ctr">
+                      <a:solidFill>
+                        <a:srgbClr val="CCCCCC"/>
+                      </a:solidFill>
+                      <a:prstDash val="solid"/>
+                      <a:round/>
+                      <a:headEnd type="none" w="med" len="med"/>
+                      <a:tailEnd type="none" w="med" len="med"/>
+                    </a:lnR>
+                    <a:lnT w="6350" cap="flat" cmpd="sng" algn="ctr">
+                      <a:solidFill>
+                        <a:srgbClr val="CCCCCC"/>
+                      </a:solidFill>
+                      <a:prstDash val="solid"/>
+                      <a:round/>
+                      <a:headEnd type="none" w="med" len="med"/>
+                      <a:tailEnd type="none" w="med" len="med"/>
+                    </a:lnT>
+                    <a:lnB w="6350" cap="flat" cmpd="sng" algn="ctr">
+                      <a:solidFill>
+                        <a:srgbClr val="CCCCCC"/>
+                      </a:solidFill>
+                      <a:prstDash val="solid"/>
+                      <a:round/>
+                      <a:headEnd type="none" w="med" len="med"/>
+                      <a:tailEnd type="none" w="med" len="med"/>
+                    </a:lnB>
+                    <a:solidFill>
+                      <a:srgbClr val="F8F6F1"/>
+                    </a:solidFill>
+                  </a:tcPr>
                 </a:tc>
               </a:tr>
               <a:tr h="286664">
@@ -5087,7 +4725,7 @@
                     </a:solidFill>
                   </a:tcPr>
                 </a:tc>
-                <a:tc gridSpan="2">
+                <a:tc>
                   <a:txBody>
                     <a:bodyPr/>
                     <a:lstStyle/>
@@ -5104,7 +4742,7 @@
                           <a:ea typeface="Montserrat" pitchFamily="34" charset="-122"/>
                           <a:cs typeface="Montserrat" pitchFamily="34" charset="-120"/>
                         </a:rPr>
-                        <a:t>warehouse compound</a:t>
+                        <a:t>VDF</a:t>
                       </a:r>
                       <a:endParaRPr lang="en-US" sz="700" dirty="0">
                         <a:latin typeface="Montserrat" charset="0"/>
@@ -5155,8 +4793,73 @@
                     </a:solidFill>
                   </a:tcPr>
                 </a:tc>
-                <a:tc hMerge="1">
-                  <a:tcPr/>
+                <a:tc>
+                  <a:txBody>
+                    <a:bodyPr/>
+                    <a:lstStyle/>
+                    <a:p>
+                      <a:pPr indent="0" marL="0">
+                        <a:buNone/>
+                      </a:pPr>
+                      <a:r>
+                        <a:rPr lang="en-US" sz="700" dirty="0">
+                          <a:solidFill>
+                            <a:srgbClr val="1A3350"/>
+                          </a:solidFill>
+                          <a:latin typeface="Montserrat" pitchFamily="34" charset="0"/>
+                          <a:ea typeface="Montserrat" pitchFamily="34" charset="-122"/>
+                          <a:cs typeface="Montserrat" pitchFamily="34" charset="-120"/>
+                        </a:rPr>
+                        <a:t>5 mtr/sqm</a:t>
+                      </a:r>
+                      <a:endParaRPr lang="en-US" sz="700" dirty="0">
+                        <a:latin typeface="Montserrat" charset="0"/>
+                        <a:ea typeface="Montserrat" charset="0"/>
+                        <a:cs typeface="Montserrat" charset="0"/>
+                      </a:endParaRPr>
+                    </a:p>
+                  </a:txBody>
+                  <a:tcPr marL="45720" marR="45720" marT="45720" marB="45720" anchor="ctr">
+                    <a:lnL w="6350" cap="flat" cmpd="sng" algn="ctr">
+                      <a:solidFill>
+                        <a:srgbClr val="CCCCCC"/>
+                      </a:solidFill>
+                      <a:prstDash val="solid"/>
+                      <a:round/>
+                      <a:headEnd type="none" w="med" len="med"/>
+                      <a:tailEnd type="none" w="med" len="med"/>
+                    </a:lnL>
+                    <a:lnR w="6350" cap="flat" cmpd="sng" algn="ctr">
+                      <a:solidFill>
+                        <a:srgbClr val="CCCCCC"/>
+                      </a:solidFill>
+                      <a:prstDash val="solid"/>
+                      <a:round/>
+                      <a:headEnd type="none" w="med" len="med"/>
+                      <a:tailEnd type="none" w="med" len="med"/>
+                    </a:lnR>
+                    <a:lnT w="6350" cap="flat" cmpd="sng" algn="ctr">
+                      <a:solidFill>
+                        <a:srgbClr val="CCCCCC"/>
+                      </a:solidFill>
+                      <a:prstDash val="solid"/>
+                      <a:round/>
+                      <a:headEnd type="none" w="med" len="med"/>
+                      <a:tailEnd type="none" w="med" len="med"/>
+                    </a:lnT>
+                    <a:lnB w="6350" cap="flat" cmpd="sng" algn="ctr">
+                      <a:solidFill>
+                        <a:srgbClr val="CCCCCC"/>
+                      </a:solidFill>
+                      <a:prstDash val="solid"/>
+                      <a:round/>
+                      <a:headEnd type="none" w="med" len="med"/>
+                      <a:tailEnd type="none" w="med" len="med"/>
+                    </a:lnB>
+                    <a:solidFill>
+                      <a:srgbClr val="F8F6F1"/>
+                    </a:solidFill>
+                  </a:tcPr>
                 </a:tc>
               </a:tr>
               <a:tr h="286664">
@@ -5245,7 +4948,7 @@
                           <a:ea typeface="Montserrat" pitchFamily="34" charset="-122"/>
                           <a:cs typeface="Montserrat" pitchFamily="34" charset="-120"/>
                         </a:rPr>
-                        <a:t>N/A</a:t>
+                        <a:t>Hydrants + Sprinklers</a:t>
                       </a:r>
                       <a:endParaRPr lang="en-US" sz="700" dirty="0">
                         <a:latin typeface="Montserrat" charset="0"/>
@@ -5369,7 +5072,7 @@
                     </a:solidFill>
                   </a:tcPr>
                 </a:tc>
-                <a:tc gridSpan="2">
+                <a:tc>
                   <a:txBody>
                     <a:bodyPr/>
                     <a:lstStyle/>
@@ -5386,7 +5089,7 @@
                           <a:ea typeface="Montserrat" pitchFamily="34" charset="-122"/>
                           <a:cs typeface="Montserrat" pitchFamily="34" charset="-120"/>
                         </a:rPr>
-                        <a:t>Fire hydrants</a:t>
+                        <a:t>Commercial CLU</a:t>
                       </a:r>
                       <a:endParaRPr lang="en-US" sz="700" dirty="0">
                         <a:latin typeface="Montserrat" charset="0"/>
@@ -5437,8 +5140,73 @@
                     </a:solidFill>
                   </a:tcPr>
                 </a:tc>
-                <a:tc hMerge="1">
-                  <a:tcPr/>
+                <a:tc>
+                  <a:txBody>
+                    <a:bodyPr/>
+                    <a:lstStyle/>
+                    <a:p>
+                      <a:pPr indent="0" marL="0">
+                        <a:buNone/>
+                      </a:pPr>
+                      <a:r>
+                        <a:rPr lang="en-US" sz="700" dirty="0">
+                          <a:solidFill>
+                            <a:srgbClr val="1A3350"/>
+                          </a:solidFill>
+                          <a:latin typeface="Montserrat" pitchFamily="34" charset="0"/>
+                          <a:ea typeface="Montserrat" pitchFamily="34" charset="-122"/>
+                          <a:cs typeface="Montserrat" pitchFamily="34" charset="-120"/>
+                        </a:rPr>
+                        <a:t>Fire NOC - Y</a:t>
+                      </a:r>
+                      <a:endParaRPr lang="en-US" sz="700" dirty="0">
+                        <a:latin typeface="Montserrat" charset="0"/>
+                        <a:ea typeface="Montserrat" charset="0"/>
+                        <a:cs typeface="Montserrat" charset="0"/>
+                      </a:endParaRPr>
+                    </a:p>
+                  </a:txBody>
+                  <a:tcPr marL="45720" marR="45720" marT="45720" marB="45720" anchor="ctr">
+                    <a:lnL w="6350" cap="flat" cmpd="sng" algn="ctr">
+                      <a:solidFill>
+                        <a:srgbClr val="CCCCCC"/>
+                      </a:solidFill>
+                      <a:prstDash val="solid"/>
+                      <a:round/>
+                      <a:headEnd type="none" w="med" len="med"/>
+                      <a:tailEnd type="none" w="med" len="med"/>
+                    </a:lnL>
+                    <a:lnR w="6350" cap="flat" cmpd="sng" algn="ctr">
+                      <a:solidFill>
+                        <a:srgbClr val="CCCCCC"/>
+                      </a:solidFill>
+                      <a:prstDash val="solid"/>
+                      <a:round/>
+                      <a:headEnd type="none" w="med" len="med"/>
+                      <a:tailEnd type="none" w="med" len="med"/>
+                    </a:lnR>
+                    <a:lnT w="6350" cap="flat" cmpd="sng" algn="ctr">
+                      <a:solidFill>
+                        <a:srgbClr val="CCCCCC"/>
+                      </a:solidFill>
+                      <a:prstDash val="solid"/>
+                      <a:round/>
+                      <a:headEnd type="none" w="med" len="med"/>
+                      <a:tailEnd type="none" w="med" len="med"/>
+                    </a:lnT>
+                    <a:lnB w="6350" cap="flat" cmpd="sng" algn="ctr">
+                      <a:solidFill>
+                        <a:srgbClr val="CCCCCC"/>
+                      </a:solidFill>
+                      <a:prstDash val="solid"/>
+                      <a:round/>
+                      <a:headEnd type="none" w="med" len="med"/>
+                      <a:tailEnd type="none" w="med" len="med"/>
+                    </a:lnB>
+                    <a:solidFill>
+                      <a:srgbClr val="F8F6F1"/>
+                    </a:solidFill>
+                  </a:tcPr>
                 </a:tc>
               </a:tr>
               <a:tr h="286664">
@@ -5594,7 +5362,7 @@
         </p:nvSpPr>
         <p:spPr>
           <a:xfrm>
-            <a:off x="81382" y="4027566"/>
+            <a:off x="81382" y="4157868"/>
             <a:ext cx="2057400" cy="320040"/>
           </a:xfrm>
           <a:prstGeom prst="rect">
@@ -5640,8 +5408,8 @@
           </p:nvPr>
         </p:nvGraphicFramePr>
         <p:xfrm>
-          <a:off x="137160" y="4333342"/>
-          <a:ext cx="2121408" cy="914400"/>
+          <a:off x="137160" y="4463644"/>
+          <a:ext cx="2395728" cy="914400"/>
         </p:xfrm>
         <a:graphic>
           <a:graphicData uri="http://schemas.openxmlformats.org/drawingml/2006/table">
@@ -5649,7 +5417,7 @@
               <a:tblPr/>
               <a:tblGrid>
                 <a:gridCol w="749808"/>
-                <a:gridCol w="1371600"/>
+                <a:gridCol w="1645920"/>
               </a:tblGrid>
               <a:tr h="416966">
                 <a:tc>
@@ -5737,7 +5505,7 @@
                           <a:ea typeface="Montserrat" pitchFamily="34" charset="-122"/>
                           <a:cs typeface="Montserrat" pitchFamily="34" charset="-120"/>
                         </a:rPr>
-                        <a:t>19</a:t>
+                        <a:t>28</a:t>
                       </a:r>
                       <a:endParaRPr lang="en-US" sz="700" dirty="0">
                         <a:latin typeface="Montserrat" charset="0"/>
@@ -5802,14 +5570,14 @@
           <p:nvPr/>
         </p:nvPicPr>
         <p:blipFill>
-          <a:blip r:embed="rId1"/>
+          <a:blip r:embed="rId2"/>
           <a:srcRect l="0" r="0" t="0" b="0"/>
           <a:stretch/>
         </p:blipFill>
         <p:spPr>
           <a:xfrm>
-            <a:off x="2655418" y="851306"/>
-            <a:ext cx="6084418" cy="3311042"/>
+            <a:off x="5800954" y="2615184"/>
+            <a:ext cx="2904134" cy="2093976"/>
           </a:xfrm>
           <a:prstGeom prst="rect">
             <a:avLst/>
@@ -5818,14 +5586,83 @@
       </p:pic>
       <p:pic>
         <p:nvPicPr>
-          <p:cNvPr id="12" name="Image 1" descr="/home/rs0125/dev/wareongo/Warehouse-Proposal-Engine/assets/WOG_logo_Transparent.png">    </p:cNvPr>
+          <p:cNvPr id="12" name="Image 1" descr="preencoded.png">    </p:cNvPr>
           <p:cNvPicPr>
             <a:picLocks noChangeAspect="1"/>
           </p:cNvPicPr>
           <p:nvPr/>
         </p:nvPicPr>
         <p:blipFill>
-          <a:blip r:embed="rId2"/>
+          <a:blip r:embed="rId3"/>
+          <a:srcRect l="0" r="0" t="0" b="0"/>
+          <a:stretch/>
+        </p:blipFill>
+        <p:spPr>
+          <a:xfrm>
+            <a:off x="5800954" y="327355"/>
+            <a:ext cx="2904134" cy="2093976"/>
+          </a:xfrm>
+          <a:prstGeom prst="rect">
+            <a:avLst/>
+          </a:prstGeom>
+        </p:spPr>
+      </p:pic>
+      <p:pic>
+        <p:nvPicPr>
+          <p:cNvPr id="13" name="Image 2" descr="preencoded.png">    </p:cNvPr>
+          <p:cNvPicPr>
+            <a:picLocks noChangeAspect="1"/>
+          </p:cNvPicPr>
+          <p:nvPr/>
+        </p:nvPicPr>
+        <p:blipFill>
+          <a:blip r:embed="rId4"/>
+          <a:srcRect l="0" r="0" t="0" b="0"/>
+          <a:stretch/>
+        </p:blipFill>
+        <p:spPr>
+          <a:xfrm>
+            <a:off x="2676449" y="327355"/>
+            <a:ext cx="2904134" cy="2093976"/>
+          </a:xfrm>
+          <a:prstGeom prst="rect">
+            <a:avLst/>
+          </a:prstGeom>
+        </p:spPr>
+      </p:pic>
+      <p:pic>
+        <p:nvPicPr>
+          <p:cNvPr id="14" name="Image 3" descr="preencoded.png">    </p:cNvPr>
+          <p:cNvPicPr>
+            <a:picLocks noChangeAspect="1"/>
+          </p:cNvPicPr>
+          <p:nvPr/>
+        </p:nvPicPr>
+        <p:blipFill>
+          <a:blip r:embed="rId5"/>
+          <a:srcRect l="0" r="0" t="0" b="0"/>
+          <a:stretch/>
+        </p:blipFill>
+        <p:spPr>
+          <a:xfrm>
+            <a:off x="2676449" y="2615184"/>
+            <a:ext cx="2904134" cy="2093976"/>
+          </a:xfrm>
+          <a:prstGeom prst="rect">
+            <a:avLst/>
+          </a:prstGeom>
+        </p:spPr>
+      </p:pic>
+      <p:pic>
+        <p:nvPicPr>
+          <p:cNvPr id="15" name="Image 4" descr="/home/rs0125/dev/wareongo/Warehouse-Proposal-Engine/assets/WOG_logo_Transparent.png">    </p:cNvPr>
+          <p:cNvPicPr>
+            <a:picLocks noChangeAspect="1"/>
+          </p:cNvPicPr>
+          <p:nvPr/>
+        </p:nvPicPr>
+        <p:blipFill>
+          <a:blip r:embed="rId6"/>
           <a:stretch>
             <a:fillRect/>
           </a:stretch>
@@ -5842,14 +5679,14 @@
       </p:pic>
       <p:sp>
         <p:nvSpPr>
-          <p:cNvPr id="13" name="Text 6"/>
+          <p:cNvPr id="16" name="Text 6"/>
           <p:cNvSpPr/>
           <p:nvPr/>
         </p:nvSpPr>
         <p:spPr>
           <a:xfrm>
-            <a:off x="4572000" y="4887468"/>
-            <a:ext cx="4389120" cy="256032"/>
+            <a:off x="4251960" y="4773168"/>
+            <a:ext cx="4572000" cy="256032"/>
           </a:xfrm>
           <a:prstGeom prst="rect">
             <a:avLst/>
@@ -5865,7 +5702,7 @@
               <a:buNone/>
             </a:pPr>
             <a:r>
-              <a:rPr lang="en-US" sz="850" dirty="0">
+              <a:rPr lang="en-US" sz="750" dirty="0">
                 <a:solidFill>
                   <a:srgbClr val="1A3350"/>
                 </a:solidFill>
@@ -5873,9 +5710,9 @@
                 <a:ea typeface="Montserrat" pitchFamily="34" charset="-122"/>
                 <a:cs typeface="Montserrat" pitchFamily="34" charset="-120"/>
               </a:rPr>
-              <a:t>Prepared by WareOnGo  |  Dated 23/05/2026  |  Confidential</a:t>
+              <a:t>Prepared by WareOnGo  |  Dated 25/05/2026  |  Confidential</a:t>
             </a:r>
-            <a:endParaRPr lang="en-US" sz="850" dirty="0"/>
+            <a:endParaRPr lang="en-US" sz="750" dirty="0"/>
           </a:p>
         </p:txBody>
       </p:sp>
@@ -5920,7 +5757,7 @@
         <p:spPr>
           <a:xfrm>
             <a:off x="0" y="0"/>
-            <a:ext cx="2400300" cy="5143500"/>
+            <a:ext cx="2606040" cy="5143500"/>
           </a:xfrm>
           <a:prstGeom prst="rect">
             <a:avLst/>
@@ -5944,7 +5781,7 @@
         </p:nvSpPr>
         <p:spPr>
           <a:xfrm>
-            <a:off x="2400300" y="0"/>
+            <a:off x="2606040" y="0"/>
             <a:ext cx="0" cy="5143500"/>
           </a:xfrm>
           <a:prstGeom prst="line">
@@ -5992,7 +5829,7 @@
                 <a:ea typeface="Montserrat ExtraBold" pitchFamily="34" charset="-122"/>
                 <a:cs typeface="Montserrat ExtraBold" pitchFamily="34" charset="-120"/>
               </a:rPr>
-              <a:t>Option 2 - ID 299</a:t>
+              <a:t>Option 2 - ID 325</a:t>
             </a:r>
             <a:endParaRPr lang="en-US" sz="1300" dirty="0"/>
           </a:p>
@@ -6053,7 +5890,7 @@
         </p:nvGraphicFramePr>
         <p:xfrm>
           <a:off x="137160" y="735178"/>
-          <a:ext cx="2121408" cy="914400"/>
+          <a:ext cx="2395728" cy="914400"/>
         </p:xfrm>
         <a:graphic>
           <a:graphicData uri="http://schemas.openxmlformats.org/drawingml/2006/table">
@@ -6061,7 +5898,7 @@
               <a:tblPr/>
               <a:tblGrid>
                 <a:gridCol w="749808"/>
-                <a:gridCol w="1371600"/>
+                <a:gridCol w="1645920"/>
               </a:tblGrid>
               <a:tr h="286664">
                 <a:tc>
@@ -6149,7 +5986,7 @@
                           <a:ea typeface="Montserrat" pitchFamily="34" charset="-122"/>
                           <a:cs typeface="Montserrat" pitchFamily="34" charset="-120"/>
                         </a:rPr>
-                        <a:t>Ahmedabad, Gujarat</a:t>
+                        <a:t>Bangalore, Karnataka</a:t>
                       </a:r>
                       <a:endParaRPr lang="en-US" sz="700" dirty="0">
                         <a:latin typeface="Montserrat" charset="0"/>
@@ -6279,13 +6116,20 @@
                         <a:buNone/>
                       </a:pPr>
                       <a:r>
-                        <a:rPr lang="en-US" sz="700" dirty="0">
+                        <a:rPr lang="en-US" sz="700" u="sng" dirty="0">
                           <a:solidFill>
-                            <a:srgbClr val="1A3350"/>
+                            <a:srgbClr val="1A56DB"/>
                           </a:solidFill>
                           <a:latin typeface="Montserrat" pitchFamily="34" charset="0"/>
                           <a:ea typeface="Montserrat" pitchFamily="34" charset="-122"/>
                           <a:cs typeface="Montserrat" pitchFamily="34" charset="-120"/>
+                          <a:hlinkClick r:id="rId1" invalidUrl="" action="" tgtFrame="" tooltip="" history="1" highlightClick="0" endSnd="0">
+                            <a:extLst>
+                              <a:ext uri="{A12FA001-AC4F-418D-AE19-62706E023703}">
+                                <ahyp:hlinkClr xmlns:ahyp="http://schemas.microsoft.com/office/drawing/2018/hyperlinkcolor" val="tx"/>
+                              </a:ext>
+                            </a:extLst>
+                          </a:hlinkClick>
                         </a:rPr>
                         <a:t>See link</a:t>
                       </a:r>
@@ -6398,7 +6242,7 @@
         </p:nvGraphicFramePr>
         <p:xfrm>
           <a:off x="137160" y="1674266"/>
-          <a:ext cx="2121408" cy="914400"/>
+          <a:ext cx="2395728" cy="914400"/>
         </p:xfrm>
         <a:graphic>
           <a:graphicData uri="http://schemas.openxmlformats.org/drawingml/2006/table">
@@ -6406,7 +6250,7 @@
               <a:tblPr/>
               <a:tblGrid>
                 <a:gridCol w="749808"/>
-                <a:gridCol w="594360"/>
+                <a:gridCol w="868680"/>
                 <a:gridCol w="777240"/>
               </a:tblGrid>
               <a:tr h="286664">
@@ -6495,7 +6339,7 @@
                           <a:ea typeface="Montserrat" pitchFamily="34" charset="-122"/>
                           <a:cs typeface="Montserrat" pitchFamily="34" charset="-120"/>
                         </a:rPr>
-                        <a:t>23000 sqft</a:t>
+                        <a:t>15000, 65000 sqft</a:t>
                       </a:r>
                       <a:endParaRPr lang="en-US" sz="700" dirty="0">
                         <a:latin typeface="Montserrat" charset="0"/>
@@ -6691,7 +6535,7 @@
                   <a:tcPr/>
                 </a:tc>
               </a:tr>
-              <a:tr h="286664">
+              <a:tr h="416966">
                 <a:tc>
                   <a:txBody>
                     <a:bodyPr/>
@@ -6760,7 +6604,7 @@
                     </a:solidFill>
                   </a:tcPr>
                 </a:tc>
-                <a:tc gridSpan="2">
+                <a:tc>
                   <a:txBody>
                     <a:bodyPr/>
                     <a:lstStyle/>
@@ -6777,7 +6621,7 @@
                           <a:ea typeface="Montserrat" pitchFamily="34" charset="-122"/>
                           <a:cs typeface="Montserrat" pitchFamily="34" charset="-120"/>
                         </a:rPr>
-                        <a:t>4</a:t>
+                        <a:t>6</a:t>
                       </a:r>
                       <a:endParaRPr lang="en-US" sz="700" dirty="0">
                         <a:latin typeface="Montserrat" charset="0"/>
@@ -6828,8 +6672,73 @@
                     </a:solidFill>
                   </a:tcPr>
                 </a:tc>
-                <a:tc hMerge="1">
-                  <a:tcPr/>
+                <a:tc>
+                  <a:txBody>
+                    <a:bodyPr/>
+                    <a:lstStyle/>
+                    <a:p>
+                      <a:pPr indent="0" marL="0">
+                        <a:buNone/>
+                      </a:pPr>
+                      <a:r>
+                        <a:rPr lang="en-US" sz="700" dirty="0">
+                          <a:solidFill>
+                            <a:srgbClr val="1A3350"/>
+                          </a:solidFill>
+                          <a:latin typeface="Montserrat" pitchFamily="34" charset="0"/>
+                          <a:ea typeface="Montserrat" pitchFamily="34" charset="-122"/>
+                          <a:cs typeface="Montserrat" pitchFamily="34" charset="-120"/>
+                        </a:rPr>
+                        <a:t>3ft plinth height</a:t>
+                      </a:r>
+                      <a:endParaRPr lang="en-US" sz="700" dirty="0">
+                        <a:latin typeface="Montserrat" charset="0"/>
+                        <a:ea typeface="Montserrat" charset="0"/>
+                        <a:cs typeface="Montserrat" charset="0"/>
+                      </a:endParaRPr>
+                    </a:p>
+                  </a:txBody>
+                  <a:tcPr marL="45720" marR="45720" marT="45720" marB="45720" anchor="ctr">
+                    <a:lnL w="6350" cap="flat" cmpd="sng" algn="ctr">
+                      <a:solidFill>
+                        <a:srgbClr val="CCCCCC"/>
+                      </a:solidFill>
+                      <a:prstDash val="solid"/>
+                      <a:round/>
+                      <a:headEnd type="none" w="med" len="med"/>
+                      <a:tailEnd type="none" w="med" len="med"/>
+                    </a:lnL>
+                    <a:lnR w="6350" cap="flat" cmpd="sng" algn="ctr">
+                      <a:solidFill>
+                        <a:srgbClr val="CCCCCC"/>
+                      </a:solidFill>
+                      <a:prstDash val="solid"/>
+                      <a:round/>
+                      <a:headEnd type="none" w="med" len="med"/>
+                      <a:tailEnd type="none" w="med" len="med"/>
+                    </a:lnR>
+                    <a:lnT w="6350" cap="flat" cmpd="sng" algn="ctr">
+                      <a:solidFill>
+                        <a:srgbClr val="CCCCCC"/>
+                      </a:solidFill>
+                      <a:prstDash val="solid"/>
+                      <a:round/>
+                      <a:headEnd type="none" w="med" len="med"/>
+                      <a:tailEnd type="none" w="med" len="med"/>
+                    </a:lnT>
+                    <a:lnB w="6350" cap="flat" cmpd="sng" algn="ctr">
+                      <a:solidFill>
+                        <a:srgbClr val="CCCCCC"/>
+                      </a:solidFill>
+                      <a:prstDash val="solid"/>
+                      <a:round/>
+                      <a:headEnd type="none" w="med" len="med"/>
+                      <a:tailEnd type="none" w="med" len="med"/>
+                    </a:lnB>
+                    <a:solidFill>
+                      <a:srgbClr val="F8F6F1"/>
+                    </a:solidFill>
+                  </a:tcPr>
                 </a:tc>
               </a:tr>
               <a:tr h="286664">
@@ -6901,7 +6810,7 @@
                     </a:solidFill>
                   </a:tcPr>
                 </a:tc>
-                <a:tc gridSpan="2">
+                <a:tc>
                   <a:txBody>
                     <a:bodyPr/>
                     <a:lstStyle/>
@@ -6918,7 +6827,7 @@
                           <a:ea typeface="Montserrat" pitchFamily="34" charset="-122"/>
                           <a:cs typeface="Montserrat" pitchFamily="34" charset="-120"/>
                         </a:rPr>
-                        <a:t>27ft</a:t>
+                        <a:t>30ft eaves</a:t>
                       </a:r>
                       <a:endParaRPr lang="en-US" sz="700" dirty="0">
                         <a:latin typeface="Montserrat" charset="0"/>
@@ -6969,8 +6878,73 @@
                     </a:solidFill>
                   </a:tcPr>
                 </a:tc>
-                <a:tc hMerge="1">
-                  <a:tcPr/>
+                <a:tc>
+                  <a:txBody>
+                    <a:bodyPr/>
+                    <a:lstStyle/>
+                    <a:p>
+                      <a:pPr indent="0" marL="0">
+                        <a:buNone/>
+                      </a:pPr>
+                      <a:r>
+                        <a:rPr lang="en-US" sz="700" dirty="0">
+                          <a:solidFill>
+                            <a:srgbClr val="1A3350"/>
+                          </a:solidFill>
+                          <a:latin typeface="Montserrat" pitchFamily="34" charset="0"/>
+                          <a:ea typeface="Montserrat" pitchFamily="34" charset="-122"/>
+                          <a:cs typeface="Montserrat" pitchFamily="34" charset="-120"/>
+                        </a:rPr>
+                        <a:t>36ft centre</a:t>
+                      </a:r>
+                      <a:endParaRPr lang="en-US" sz="700" dirty="0">
+                        <a:latin typeface="Montserrat" charset="0"/>
+                        <a:ea typeface="Montserrat" charset="0"/>
+                        <a:cs typeface="Montserrat" charset="0"/>
+                      </a:endParaRPr>
+                    </a:p>
+                  </a:txBody>
+                  <a:tcPr marL="45720" marR="45720" marT="45720" marB="45720" anchor="ctr">
+                    <a:lnL w="6350" cap="flat" cmpd="sng" algn="ctr">
+                      <a:solidFill>
+                        <a:srgbClr val="CCCCCC"/>
+                      </a:solidFill>
+                      <a:prstDash val="solid"/>
+                      <a:round/>
+                      <a:headEnd type="none" w="med" len="med"/>
+                      <a:tailEnd type="none" w="med" len="med"/>
+                    </a:lnL>
+                    <a:lnR w="6350" cap="flat" cmpd="sng" algn="ctr">
+                      <a:solidFill>
+                        <a:srgbClr val="CCCCCC"/>
+                      </a:solidFill>
+                      <a:prstDash val="solid"/>
+                      <a:round/>
+                      <a:headEnd type="none" w="med" len="med"/>
+                      <a:tailEnd type="none" w="med" len="med"/>
+                    </a:lnR>
+                    <a:lnT w="6350" cap="flat" cmpd="sng" algn="ctr">
+                      <a:solidFill>
+                        <a:srgbClr val="CCCCCC"/>
+                      </a:solidFill>
+                      <a:prstDash val="solid"/>
+                      <a:round/>
+                      <a:headEnd type="none" w="med" len="med"/>
+                      <a:tailEnd type="none" w="med" len="med"/>
+                    </a:lnT>
+                    <a:lnB w="6350" cap="flat" cmpd="sng" algn="ctr">
+                      <a:solidFill>
+                        <a:srgbClr val="CCCCCC"/>
+                      </a:solidFill>
+                      <a:prstDash val="solid"/>
+                      <a:round/>
+                      <a:headEnd type="none" w="med" len="med"/>
+                      <a:tailEnd type="none" w="med" len="med"/>
+                    </a:lnB>
+                    <a:solidFill>
+                      <a:srgbClr val="F8F6F1"/>
+                    </a:solidFill>
+                  </a:tcPr>
                 </a:tc>
               </a:tr>
               <a:tr h="286664">
@@ -7042,7 +7016,7 @@
                     </a:solidFill>
                   </a:tcPr>
                 </a:tc>
-                <a:tc gridSpan="2">
+                <a:tc>
                   <a:txBody>
                     <a:bodyPr/>
                     <a:lstStyle/>
@@ -7059,7 +7033,7 @@
                           <a:ea typeface="Montserrat" pitchFamily="34" charset="-122"/>
                           <a:cs typeface="Montserrat" pitchFamily="34" charset="-120"/>
                         </a:rPr>
-                        <a:t>warehouse compound</a:t>
+                        <a:t>VDF</a:t>
                       </a:r>
                       <a:endParaRPr lang="en-US" sz="700" dirty="0">
                         <a:latin typeface="Montserrat" charset="0"/>
@@ -7110,8 +7084,73 @@
                     </a:solidFill>
                   </a:tcPr>
                 </a:tc>
-                <a:tc hMerge="1">
-                  <a:tcPr/>
+                <a:tc>
+                  <a:txBody>
+                    <a:bodyPr/>
+                    <a:lstStyle/>
+                    <a:p>
+                      <a:pPr indent="0" marL="0">
+                        <a:buNone/>
+                      </a:pPr>
+                      <a:r>
+                        <a:rPr lang="en-US" sz="700" dirty="0">
+                          <a:solidFill>
+                            <a:srgbClr val="1A3350"/>
+                          </a:solidFill>
+                          <a:latin typeface="Montserrat" pitchFamily="34" charset="0"/>
+                          <a:ea typeface="Montserrat" pitchFamily="34" charset="-122"/>
+                          <a:cs typeface="Montserrat" pitchFamily="34" charset="-120"/>
+                        </a:rPr>
+                        <a:t>N/A</a:t>
+                      </a:r>
+                      <a:endParaRPr lang="en-US" sz="700" dirty="0">
+                        <a:latin typeface="Montserrat" charset="0"/>
+                        <a:ea typeface="Montserrat" charset="0"/>
+                        <a:cs typeface="Montserrat" charset="0"/>
+                      </a:endParaRPr>
+                    </a:p>
+                  </a:txBody>
+                  <a:tcPr marL="45720" marR="45720" marT="45720" marB="45720" anchor="ctr">
+                    <a:lnL w="6350" cap="flat" cmpd="sng" algn="ctr">
+                      <a:solidFill>
+                        <a:srgbClr val="CCCCCC"/>
+                      </a:solidFill>
+                      <a:prstDash val="solid"/>
+                      <a:round/>
+                      <a:headEnd type="none" w="med" len="med"/>
+                      <a:tailEnd type="none" w="med" len="med"/>
+                    </a:lnL>
+                    <a:lnR w="6350" cap="flat" cmpd="sng" algn="ctr">
+                      <a:solidFill>
+                        <a:srgbClr val="CCCCCC"/>
+                      </a:solidFill>
+                      <a:prstDash val="solid"/>
+                      <a:round/>
+                      <a:headEnd type="none" w="med" len="med"/>
+                      <a:tailEnd type="none" w="med" len="med"/>
+                    </a:lnR>
+                    <a:lnT w="6350" cap="flat" cmpd="sng" algn="ctr">
+                      <a:solidFill>
+                        <a:srgbClr val="CCCCCC"/>
+                      </a:solidFill>
+                      <a:prstDash val="solid"/>
+                      <a:round/>
+                      <a:headEnd type="none" w="med" len="med"/>
+                      <a:tailEnd type="none" w="med" len="med"/>
+                    </a:lnT>
+                    <a:lnB w="6350" cap="flat" cmpd="sng" algn="ctr">
+                      <a:solidFill>
+                        <a:srgbClr val="CCCCCC"/>
+                      </a:solidFill>
+                      <a:prstDash val="solid"/>
+                      <a:round/>
+                      <a:headEnd type="none" w="med" len="med"/>
+                      <a:tailEnd type="none" w="med" len="med"/>
+                    </a:lnB>
+                    <a:solidFill>
+                      <a:srgbClr val="F8F6F1"/>
+                    </a:solidFill>
+                  </a:tcPr>
                 </a:tc>
               </a:tr>
               <a:tr h="286664">
@@ -7324,7 +7363,7 @@
                     </a:solidFill>
                   </a:tcPr>
                 </a:tc>
-                <a:tc gridSpan="2">
+                <a:tc>
                   <a:txBody>
                     <a:bodyPr/>
                     <a:lstStyle/>
@@ -7341,7 +7380,7 @@
                           <a:ea typeface="Montserrat" pitchFamily="34" charset="-122"/>
                           <a:cs typeface="Montserrat" pitchFamily="34" charset="-120"/>
                         </a:rPr>
-                        <a:t>Fire hydrants</a:t>
+                        <a:t>Unverified CLU</a:t>
                       </a:r>
                       <a:endParaRPr lang="en-US" sz="700" dirty="0">
                         <a:latin typeface="Montserrat" charset="0"/>
@@ -7392,8 +7431,73 @@
                     </a:solidFill>
                   </a:tcPr>
                 </a:tc>
-                <a:tc hMerge="1">
-                  <a:tcPr/>
+                <a:tc>
+                  <a:txBody>
+                    <a:bodyPr/>
+                    <a:lstStyle/>
+                    <a:p>
+                      <a:pPr indent="0" marL="0">
+                        <a:buNone/>
+                      </a:pPr>
+                      <a:r>
+                        <a:rPr lang="en-US" sz="700" dirty="0">
+                          <a:solidFill>
+                            <a:srgbClr val="1A3350"/>
+                          </a:solidFill>
+                          <a:latin typeface="Montserrat" pitchFamily="34" charset="0"/>
+                          <a:ea typeface="Montserrat" pitchFamily="34" charset="-122"/>
+                          <a:cs typeface="Montserrat" pitchFamily="34" charset="-120"/>
+                        </a:rPr>
+                        <a:t>Fire NOC - N</a:t>
+                      </a:r>
+                      <a:endParaRPr lang="en-US" sz="700" dirty="0">
+                        <a:latin typeface="Montserrat" charset="0"/>
+                        <a:ea typeface="Montserrat" charset="0"/>
+                        <a:cs typeface="Montserrat" charset="0"/>
+                      </a:endParaRPr>
+                    </a:p>
+                  </a:txBody>
+                  <a:tcPr marL="45720" marR="45720" marT="45720" marB="45720" anchor="ctr">
+                    <a:lnL w="6350" cap="flat" cmpd="sng" algn="ctr">
+                      <a:solidFill>
+                        <a:srgbClr val="CCCCCC"/>
+                      </a:solidFill>
+                      <a:prstDash val="solid"/>
+                      <a:round/>
+                      <a:headEnd type="none" w="med" len="med"/>
+                      <a:tailEnd type="none" w="med" len="med"/>
+                    </a:lnL>
+                    <a:lnR w="6350" cap="flat" cmpd="sng" algn="ctr">
+                      <a:solidFill>
+                        <a:srgbClr val="CCCCCC"/>
+                      </a:solidFill>
+                      <a:prstDash val="solid"/>
+                      <a:round/>
+                      <a:headEnd type="none" w="med" len="med"/>
+                      <a:tailEnd type="none" w="med" len="med"/>
+                    </a:lnR>
+                    <a:lnT w="6350" cap="flat" cmpd="sng" algn="ctr">
+                      <a:solidFill>
+                        <a:srgbClr val="CCCCCC"/>
+                      </a:solidFill>
+                      <a:prstDash val="solid"/>
+                      <a:round/>
+                      <a:headEnd type="none" w="med" len="med"/>
+                      <a:tailEnd type="none" w="med" len="med"/>
+                    </a:lnT>
+                    <a:lnB w="6350" cap="flat" cmpd="sng" algn="ctr">
+                      <a:solidFill>
+                        <a:srgbClr val="CCCCCC"/>
+                      </a:solidFill>
+                      <a:prstDash val="solid"/>
+                      <a:round/>
+                      <a:headEnd type="none" w="med" len="med"/>
+                      <a:tailEnd type="none" w="med" len="med"/>
+                    </a:lnB>
+                    <a:solidFill>
+                      <a:srgbClr val="F8F6F1"/>
+                    </a:solidFill>
+                  </a:tcPr>
                 </a:tc>
               </a:tr>
               <a:tr h="286664">
@@ -7482,7 +7586,7 @@
                           <a:ea typeface="Montserrat" pitchFamily="34" charset="-122"/>
                           <a:cs typeface="Montserrat" pitchFamily="34" charset="-120"/>
                         </a:rPr>
-                        <a:t>Immediate</a:t>
+                        <a:t>3 months post LOI</a:t>
                       </a:r>
                       <a:endParaRPr lang="en-US" sz="700" dirty="0">
                         <a:latin typeface="Montserrat" charset="0"/>
@@ -7549,7 +7653,7 @@
         </p:nvSpPr>
         <p:spPr>
           <a:xfrm>
-            <a:off x="81382" y="4027566"/>
+            <a:off x="81382" y="4157868"/>
             <a:ext cx="2057400" cy="320040"/>
           </a:xfrm>
           <a:prstGeom prst="rect">
@@ -7595,8 +7699,8 @@
           </p:nvPr>
         </p:nvGraphicFramePr>
         <p:xfrm>
-          <a:off x="137160" y="4333342"/>
-          <a:ext cx="2121408" cy="914400"/>
+          <a:off x="137160" y="4463644"/>
+          <a:ext cx="2395728" cy="914400"/>
         </p:xfrm>
         <a:graphic>
           <a:graphicData uri="http://schemas.openxmlformats.org/drawingml/2006/table">
@@ -7604,7 +7708,7 @@
               <a:tblPr/>
               <a:tblGrid>
                 <a:gridCol w="749808"/>
-                <a:gridCol w="1371600"/>
+                <a:gridCol w="1645920"/>
               </a:tblGrid>
               <a:tr h="416966">
                 <a:tc>
@@ -7692,7 +7796,7 @@
                           <a:ea typeface="Montserrat" pitchFamily="34" charset="-122"/>
                           <a:cs typeface="Montserrat" pitchFamily="34" charset="-120"/>
                         </a:rPr>
-                        <a:t>17</a:t>
+                        <a:t>24</a:t>
                       </a:r>
                       <a:endParaRPr lang="en-US" sz="700" dirty="0">
                         <a:latin typeface="Montserrat" charset="0"/>
@@ -7757,14 +7861,14 @@
           <p:nvPr/>
         </p:nvPicPr>
         <p:blipFill>
-          <a:blip r:embed="rId1"/>
+          <a:blip r:embed="rId2"/>
           <a:srcRect l="0" r="0" t="0" b="0"/>
           <a:stretch/>
         </p:blipFill>
         <p:spPr>
           <a:xfrm>
-            <a:off x="2651760" y="1440180"/>
-            <a:ext cx="2971800" cy="2194560"/>
+            <a:off x="5800954" y="327355"/>
+            <a:ext cx="2904134" cy="2093976"/>
           </a:xfrm>
           <a:prstGeom prst="rect">
             <a:avLst/>
@@ -7780,14 +7884,14 @@
           <p:nvPr/>
         </p:nvPicPr>
         <p:blipFill>
-          <a:blip r:embed="rId2"/>
+          <a:blip r:embed="rId3"/>
           <a:srcRect l="0" r="0" t="0" b="0"/>
           <a:stretch/>
         </p:blipFill>
         <p:spPr>
           <a:xfrm>
-            <a:off x="5760720" y="1440180"/>
-            <a:ext cx="2971800" cy="2194560"/>
+            <a:off x="2676449" y="2615184"/>
+            <a:ext cx="2904134" cy="2093976"/>
           </a:xfrm>
           <a:prstGeom prst="rect">
             <a:avLst/>
@@ -7796,14 +7900,60 @@
       </p:pic>
       <p:pic>
         <p:nvPicPr>
-          <p:cNvPr id="13" name="Image 2" descr="/home/rs0125/dev/wareongo/Warehouse-Proposal-Engine/assets/WOG_logo_Transparent.png">    </p:cNvPr>
+          <p:cNvPr id="13" name="Image 2" descr="preencoded.png">    </p:cNvPr>
           <p:cNvPicPr>
             <a:picLocks noChangeAspect="1"/>
           </p:cNvPicPr>
           <p:nvPr/>
         </p:nvPicPr>
         <p:blipFill>
-          <a:blip r:embed="rId3"/>
+          <a:blip r:embed="rId4"/>
+          <a:srcRect l="0" r="0" t="0" b="0"/>
+          <a:stretch/>
+        </p:blipFill>
+        <p:spPr>
+          <a:xfrm>
+            <a:off x="5800954" y="2615184"/>
+            <a:ext cx="2904134" cy="2093976"/>
+          </a:xfrm>
+          <a:prstGeom prst="rect">
+            <a:avLst/>
+          </a:prstGeom>
+        </p:spPr>
+      </p:pic>
+      <p:pic>
+        <p:nvPicPr>
+          <p:cNvPr id="14" name="Image 3" descr="preencoded.png">    </p:cNvPr>
+          <p:cNvPicPr>
+            <a:picLocks noChangeAspect="1"/>
+          </p:cNvPicPr>
+          <p:nvPr/>
+        </p:nvPicPr>
+        <p:blipFill>
+          <a:blip r:embed="rId5"/>
+          <a:srcRect l="0" r="0" t="0" b="0"/>
+          <a:stretch/>
+        </p:blipFill>
+        <p:spPr>
+          <a:xfrm>
+            <a:off x="2676449" y="327355"/>
+            <a:ext cx="2904134" cy="2093976"/>
+          </a:xfrm>
+          <a:prstGeom prst="rect">
+            <a:avLst/>
+          </a:prstGeom>
+        </p:spPr>
+      </p:pic>
+      <p:pic>
+        <p:nvPicPr>
+          <p:cNvPr id="15" name="Image 4" descr="/home/rs0125/dev/wareongo/Warehouse-Proposal-Engine/assets/WOG_logo_Transparent.png">    </p:cNvPr>
+          <p:cNvPicPr>
+            <a:picLocks noChangeAspect="1"/>
+          </p:cNvPicPr>
+          <p:nvPr/>
+        </p:nvPicPr>
+        <p:blipFill>
+          <a:blip r:embed="rId6"/>
           <a:stretch>
             <a:fillRect/>
           </a:stretch>
@@ -7820,14 +7970,14 @@
       </p:pic>
       <p:sp>
         <p:nvSpPr>
-          <p:cNvPr id="14" name="Text 6"/>
+          <p:cNvPr id="16" name="Text 6"/>
           <p:cNvSpPr/>
           <p:nvPr/>
         </p:nvSpPr>
         <p:spPr>
           <a:xfrm>
-            <a:off x="4572000" y="4887468"/>
-            <a:ext cx="4389120" cy="256032"/>
+            <a:off x="4251960" y="4773168"/>
+            <a:ext cx="4572000" cy="256032"/>
           </a:xfrm>
           <a:prstGeom prst="rect">
             <a:avLst/>
@@ -7843,7 +7993,7 @@
               <a:buNone/>
             </a:pPr>
             <a:r>
-              <a:rPr lang="en-US" sz="850" dirty="0">
+              <a:rPr lang="en-US" sz="750" dirty="0">
                 <a:solidFill>
                   <a:srgbClr val="1A3350"/>
                 </a:solidFill>
@@ -7851,9 +8001,9 @@
                 <a:ea typeface="Montserrat" pitchFamily="34" charset="-122"/>
                 <a:cs typeface="Montserrat" pitchFamily="34" charset="-120"/>
               </a:rPr>
-              <a:t>Prepared by WareOnGo  |  Dated 23/05/2026  |  Confidential</a:t>
+              <a:t>Prepared by WareOnGo  |  Dated 25/05/2026  |  Confidential</a:t>
             </a:r>
-            <a:endParaRPr lang="en-US" sz="850" dirty="0"/>
+            <a:endParaRPr lang="en-US" sz="750" dirty="0"/>
           </a:p>
         </p:txBody>
       </p:sp>
@@ -7898,7 +8048,7 @@
         <p:spPr>
           <a:xfrm>
             <a:off x="0" y="0"/>
-            <a:ext cx="2400300" cy="5143500"/>
+            <a:ext cx="2606040" cy="5143500"/>
           </a:xfrm>
           <a:prstGeom prst="rect">
             <a:avLst/>
@@ -7922,7 +8072,7 @@
         </p:nvSpPr>
         <p:spPr>
           <a:xfrm>
-            <a:off x="2400300" y="0"/>
+            <a:off x="2606040" y="0"/>
             <a:ext cx="0" cy="5143500"/>
           </a:xfrm>
           <a:prstGeom prst="line">
@@ -7970,7 +8120,7 @@
                 <a:ea typeface="Montserrat ExtraBold" pitchFamily="34" charset="-122"/>
                 <a:cs typeface="Montserrat ExtraBold" pitchFamily="34" charset="-120"/>
               </a:rPr>
-              <a:t>Option 3 - ID 569</a:t>
+              <a:t>Option 3 - ID 893</a:t>
             </a:r>
             <a:endParaRPr lang="en-US" sz="1300" dirty="0"/>
           </a:p>
@@ -8031,7 +8181,7 @@
         </p:nvGraphicFramePr>
         <p:xfrm>
           <a:off x="137160" y="735178"/>
-          <a:ext cx="2121408" cy="914400"/>
+          <a:ext cx="2395728" cy="914400"/>
         </p:xfrm>
         <a:graphic>
           <a:graphicData uri="http://schemas.openxmlformats.org/drawingml/2006/table">
@@ -8039,7 +8189,7 @@
               <a:tblPr/>
               <a:tblGrid>
                 <a:gridCol w="749808"/>
-                <a:gridCol w="1371600"/>
+                <a:gridCol w="1645920"/>
               </a:tblGrid>
               <a:tr h="286664">
                 <a:tc>
@@ -8127,7 +8277,7 @@
                           <a:ea typeface="Montserrat" pitchFamily="34" charset="-122"/>
                           <a:cs typeface="Montserrat" pitchFamily="34" charset="-120"/>
                         </a:rPr>
-                        <a:t>Bengaluru, Karnataka</a:t>
+                        <a:t>Bangalore, Karnataka</a:t>
                       </a:r>
                       <a:endParaRPr lang="en-US" sz="700" dirty="0">
                         <a:latin typeface="Montserrat" charset="0"/>
@@ -8257,15 +8407,22 @@
                         <a:buNone/>
                       </a:pPr>
                       <a:r>
-                        <a:rPr lang="en-US" sz="700" dirty="0">
+                        <a:rPr lang="en-US" sz="700" u="sng" dirty="0">
                           <a:solidFill>
-                            <a:srgbClr val="1A3350"/>
+                            <a:srgbClr val="1A56DB"/>
                           </a:solidFill>
                           <a:latin typeface="Montserrat" pitchFamily="34" charset="0"/>
                           <a:ea typeface="Montserrat" pitchFamily="34" charset="-122"/>
                           <a:cs typeface="Montserrat" pitchFamily="34" charset="-120"/>
+                          <a:hlinkClick r:id="rId1" invalidUrl="" action="" tgtFrame="" tooltip="" history="1" highlightClick="0" endSnd="0">
+                            <a:extLst>
+                              <a:ext uri="{A12FA001-AC4F-418D-AE19-62706E023703}">
+                                <ahyp:hlinkClr xmlns:ahyp="http://schemas.microsoft.com/office/drawing/2018/hyperlinkcolor" val="tx"/>
+                              </a:ext>
+                            </a:extLst>
+                          </a:hlinkClick>
                         </a:rPr>
-                        <a:t>Awaited</a:t>
+                        <a:t>See link</a:t>
                       </a:r>
                       <a:endParaRPr lang="en-US" sz="700" dirty="0">
                         <a:latin typeface="Montserrat" charset="0"/>
@@ -8376,7 +8533,7 @@
         </p:nvGraphicFramePr>
         <p:xfrm>
           <a:off x="137160" y="1674266"/>
-          <a:ext cx="2121408" cy="914400"/>
+          <a:ext cx="2395728" cy="914400"/>
         </p:xfrm>
         <a:graphic>
           <a:graphicData uri="http://schemas.openxmlformats.org/drawingml/2006/table">
@@ -8384,7 +8541,7 @@
               <a:tblPr/>
               <a:tblGrid>
                 <a:gridCol w="749808"/>
-                <a:gridCol w="594360"/>
+                <a:gridCol w="868680"/>
                 <a:gridCol w="777240"/>
               </a:tblGrid>
               <a:tr h="286664">
@@ -8473,7 +8630,7 @@
                           <a:ea typeface="Montserrat" pitchFamily="34" charset="-122"/>
                           <a:cs typeface="Montserrat" pitchFamily="34" charset="-120"/>
                         </a:rPr>
-                        <a:t>3500 sqft</a:t>
+                        <a:t>235060 sqft</a:t>
                       </a:r>
                       <a:endParaRPr lang="en-US" sz="700" dirty="0">
                         <a:latin typeface="Montserrat" charset="0"/>
@@ -8669,7 +8826,7 @@
                   <a:tcPr/>
                 </a:tc>
               </a:tr>
-              <a:tr h="286664">
+              <a:tr h="416966">
                 <a:tc>
                   <a:txBody>
                     <a:bodyPr/>
@@ -8738,7 +8895,7 @@
                     </a:solidFill>
                   </a:tcPr>
                 </a:tc>
-                <a:tc gridSpan="2">
+                <a:tc>
                   <a:txBody>
                     <a:bodyPr/>
                     <a:lstStyle/>
@@ -8755,7 +8912,7 @@
                           <a:ea typeface="Montserrat" pitchFamily="34" charset="-122"/>
                           <a:cs typeface="Montserrat" pitchFamily="34" charset="-120"/>
                         </a:rPr>
-                        <a:t>0</a:t>
+                        <a:t>20</a:t>
                       </a:r>
                       <a:endParaRPr lang="en-US" sz="700" dirty="0">
                         <a:latin typeface="Montserrat" charset="0"/>
@@ -8806,8 +8963,73 @@
                     </a:solidFill>
                   </a:tcPr>
                 </a:tc>
-                <a:tc hMerge="1">
-                  <a:tcPr/>
+                <a:tc>
+                  <a:txBody>
+                    <a:bodyPr/>
+                    <a:lstStyle/>
+                    <a:p>
+                      <a:pPr indent="0" marL="0">
+                        <a:buNone/>
+                      </a:pPr>
+                      <a:r>
+                        <a:rPr lang="en-US" sz="700" dirty="0">
+                          <a:solidFill>
+                            <a:srgbClr val="1A3350"/>
+                          </a:solidFill>
+                          <a:latin typeface="Montserrat" pitchFamily="34" charset="0"/>
+                          <a:ea typeface="Montserrat" pitchFamily="34" charset="-122"/>
+                          <a:cs typeface="Montserrat" pitchFamily="34" charset="-120"/>
+                        </a:rPr>
+                        <a:t>4ft plinth height</a:t>
+                      </a:r>
+                      <a:endParaRPr lang="en-US" sz="700" dirty="0">
+                        <a:latin typeface="Montserrat" charset="0"/>
+                        <a:ea typeface="Montserrat" charset="0"/>
+                        <a:cs typeface="Montserrat" charset="0"/>
+                      </a:endParaRPr>
+                    </a:p>
+                  </a:txBody>
+                  <a:tcPr marL="45720" marR="45720" marT="45720" marB="45720" anchor="ctr">
+                    <a:lnL w="6350" cap="flat" cmpd="sng" algn="ctr">
+                      <a:solidFill>
+                        <a:srgbClr val="CCCCCC"/>
+                      </a:solidFill>
+                      <a:prstDash val="solid"/>
+                      <a:round/>
+                      <a:headEnd type="none" w="med" len="med"/>
+                      <a:tailEnd type="none" w="med" len="med"/>
+                    </a:lnL>
+                    <a:lnR w="6350" cap="flat" cmpd="sng" algn="ctr">
+                      <a:solidFill>
+                        <a:srgbClr val="CCCCCC"/>
+                      </a:solidFill>
+                      <a:prstDash val="solid"/>
+                      <a:round/>
+                      <a:headEnd type="none" w="med" len="med"/>
+                      <a:tailEnd type="none" w="med" len="med"/>
+                    </a:lnR>
+                    <a:lnT w="6350" cap="flat" cmpd="sng" algn="ctr">
+                      <a:solidFill>
+                        <a:srgbClr val="CCCCCC"/>
+                      </a:solidFill>
+                      <a:prstDash val="solid"/>
+                      <a:round/>
+                      <a:headEnd type="none" w="med" len="med"/>
+                      <a:tailEnd type="none" w="med" len="med"/>
+                    </a:lnT>
+                    <a:lnB w="6350" cap="flat" cmpd="sng" algn="ctr">
+                      <a:solidFill>
+                        <a:srgbClr val="CCCCCC"/>
+                      </a:solidFill>
+                      <a:prstDash val="solid"/>
+                      <a:round/>
+                      <a:headEnd type="none" w="med" len="med"/>
+                      <a:tailEnd type="none" w="med" len="med"/>
+                    </a:lnB>
+                    <a:solidFill>
+                      <a:srgbClr val="F8F6F1"/>
+                    </a:solidFill>
+                  </a:tcPr>
                 </a:tc>
               </a:tr>
               <a:tr h="286664">
@@ -8879,7 +9101,7 @@
                     </a:solidFill>
                   </a:tcPr>
                 </a:tc>
-                <a:tc gridSpan="2">
+                <a:tc>
                   <a:txBody>
                     <a:bodyPr/>
                     <a:lstStyle/>
@@ -8896,7 +9118,7 @@
                           <a:ea typeface="Montserrat" pitchFamily="34" charset="-122"/>
                           <a:cs typeface="Montserrat" pitchFamily="34" charset="-120"/>
                         </a:rPr>
-                        <a:t>24ft</a:t>
+                        <a:t>40ft eaves</a:t>
                       </a:r>
                       <a:endParaRPr lang="en-US" sz="700" dirty="0">
                         <a:latin typeface="Montserrat" charset="0"/>
@@ -8947,11 +9169,76 @@
                     </a:solidFill>
                   </a:tcPr>
                 </a:tc>
-                <a:tc hMerge="1">
-                  <a:tcPr/>
+                <a:tc>
+                  <a:txBody>
+                    <a:bodyPr/>
+                    <a:lstStyle/>
+                    <a:p>
+                      <a:pPr indent="0" marL="0">
+                        <a:buNone/>
+                      </a:pPr>
+                      <a:r>
+                        <a:rPr lang="en-US" sz="700" dirty="0">
+                          <a:solidFill>
+                            <a:srgbClr val="1A3350"/>
+                          </a:solidFill>
+                          <a:latin typeface="Montserrat" pitchFamily="34" charset="0"/>
+                          <a:ea typeface="Montserrat" pitchFamily="34" charset="-122"/>
+                          <a:cs typeface="Montserrat" pitchFamily="34" charset="-120"/>
+                        </a:rPr>
+                        <a:t>48ft centre</a:t>
+                      </a:r>
+                      <a:endParaRPr lang="en-US" sz="700" dirty="0">
+                        <a:latin typeface="Montserrat" charset="0"/>
+                        <a:ea typeface="Montserrat" charset="0"/>
+                        <a:cs typeface="Montserrat" charset="0"/>
+                      </a:endParaRPr>
+                    </a:p>
+                  </a:txBody>
+                  <a:tcPr marL="45720" marR="45720" marT="45720" marB="45720" anchor="ctr">
+                    <a:lnL w="6350" cap="flat" cmpd="sng" algn="ctr">
+                      <a:solidFill>
+                        <a:srgbClr val="CCCCCC"/>
+                      </a:solidFill>
+                      <a:prstDash val="solid"/>
+                      <a:round/>
+                      <a:headEnd type="none" w="med" len="med"/>
+                      <a:tailEnd type="none" w="med" len="med"/>
+                    </a:lnL>
+                    <a:lnR w="6350" cap="flat" cmpd="sng" algn="ctr">
+                      <a:solidFill>
+                        <a:srgbClr val="CCCCCC"/>
+                      </a:solidFill>
+                      <a:prstDash val="solid"/>
+                      <a:round/>
+                      <a:headEnd type="none" w="med" len="med"/>
+                      <a:tailEnd type="none" w="med" len="med"/>
+                    </a:lnR>
+                    <a:lnT w="6350" cap="flat" cmpd="sng" algn="ctr">
+                      <a:solidFill>
+                        <a:srgbClr val="CCCCCC"/>
+                      </a:solidFill>
+                      <a:prstDash val="solid"/>
+                      <a:round/>
+                      <a:headEnd type="none" w="med" len="med"/>
+                      <a:tailEnd type="none" w="med" len="med"/>
+                    </a:lnT>
+                    <a:lnB w="6350" cap="flat" cmpd="sng" algn="ctr">
+                      <a:solidFill>
+                        <a:srgbClr val="CCCCCC"/>
+                      </a:solidFill>
+                      <a:prstDash val="solid"/>
+                      <a:round/>
+                      <a:headEnd type="none" w="med" len="med"/>
+                      <a:tailEnd type="none" w="med" len="med"/>
+                    </a:lnB>
+                    <a:solidFill>
+                      <a:srgbClr val="F8F6F1"/>
+                    </a:solidFill>
+                  </a:tcPr>
                 </a:tc>
               </a:tr>
-              <a:tr h="416966">
+              <a:tr h="286664">
                 <a:tc>
                   <a:txBody>
                     <a:bodyPr/>
@@ -9020,7 +9307,7 @@
                     </a:solidFill>
                   </a:tcPr>
                 </a:tc>
-                <a:tc gridSpan="2">
+                <a:tc>
                   <a:txBody>
                     <a:bodyPr/>
                     <a:lstStyle/>
@@ -9037,7 +9324,7 @@
                           <a:ea typeface="Montserrat" pitchFamily="34" charset="-122"/>
                           <a:cs typeface="Montserrat" pitchFamily="34" charset="-120"/>
                         </a:rPr>
-                        <a:t>1 Shutter, 5HP Power, Road width 40 fts</a:t>
+                        <a:t>FM2</a:t>
                       </a:r>
                       <a:endParaRPr lang="en-US" sz="700" dirty="0">
                         <a:latin typeface="Montserrat" charset="0"/>
@@ -9088,8 +9375,73 @@
                     </a:solidFill>
                   </a:tcPr>
                 </a:tc>
-                <a:tc hMerge="1">
-                  <a:tcPr/>
+                <a:tc>
+                  <a:txBody>
+                    <a:bodyPr/>
+                    <a:lstStyle/>
+                    <a:p>
+                      <a:pPr indent="0" marL="0">
+                        <a:buNone/>
+                      </a:pPr>
+                      <a:r>
+                        <a:rPr lang="en-US" sz="700" dirty="0">
+                          <a:solidFill>
+                            <a:srgbClr val="1A3350"/>
+                          </a:solidFill>
+                          <a:latin typeface="Montserrat" pitchFamily="34" charset="0"/>
+                          <a:ea typeface="Montserrat" pitchFamily="34" charset="-122"/>
+                          <a:cs typeface="Montserrat" pitchFamily="34" charset="-120"/>
+                        </a:rPr>
+                        <a:t>N/A</a:t>
+                      </a:r>
+                      <a:endParaRPr lang="en-US" sz="700" dirty="0">
+                        <a:latin typeface="Montserrat" charset="0"/>
+                        <a:ea typeface="Montserrat" charset="0"/>
+                        <a:cs typeface="Montserrat" charset="0"/>
+                      </a:endParaRPr>
+                    </a:p>
+                  </a:txBody>
+                  <a:tcPr marL="45720" marR="45720" marT="45720" marB="45720" anchor="ctr">
+                    <a:lnL w="6350" cap="flat" cmpd="sng" algn="ctr">
+                      <a:solidFill>
+                        <a:srgbClr val="CCCCCC"/>
+                      </a:solidFill>
+                      <a:prstDash val="solid"/>
+                      <a:round/>
+                      <a:headEnd type="none" w="med" len="med"/>
+                      <a:tailEnd type="none" w="med" len="med"/>
+                    </a:lnL>
+                    <a:lnR w="6350" cap="flat" cmpd="sng" algn="ctr">
+                      <a:solidFill>
+                        <a:srgbClr val="CCCCCC"/>
+                      </a:solidFill>
+                      <a:prstDash val="solid"/>
+                      <a:round/>
+                      <a:headEnd type="none" w="med" len="med"/>
+                      <a:tailEnd type="none" w="med" len="med"/>
+                    </a:lnR>
+                    <a:lnT w="6350" cap="flat" cmpd="sng" algn="ctr">
+                      <a:solidFill>
+                        <a:srgbClr val="CCCCCC"/>
+                      </a:solidFill>
+                      <a:prstDash val="solid"/>
+                      <a:round/>
+                      <a:headEnd type="none" w="med" len="med"/>
+                      <a:tailEnd type="none" w="med" len="med"/>
+                    </a:lnT>
+                    <a:lnB w="6350" cap="flat" cmpd="sng" algn="ctr">
+                      <a:solidFill>
+                        <a:srgbClr val="CCCCCC"/>
+                      </a:solidFill>
+                      <a:prstDash val="solid"/>
+                      <a:round/>
+                      <a:headEnd type="none" w="med" len="med"/>
+                      <a:tailEnd type="none" w="med" len="med"/>
+                    </a:lnB>
+                    <a:solidFill>
+                      <a:srgbClr val="F8F6F1"/>
+                    </a:solidFill>
+                  </a:tcPr>
                 </a:tc>
               </a:tr>
               <a:tr h="286664">
@@ -9178,7 +9530,7 @@
                           <a:ea typeface="Montserrat" pitchFamily="34" charset="-122"/>
                           <a:cs typeface="Montserrat" pitchFamily="34" charset="-120"/>
                         </a:rPr>
-                        <a:t>N/A</a:t>
+                        <a:t>Hydrants+Sprinklers</a:t>
                       </a:r>
                       <a:endParaRPr lang="en-US" sz="700" dirty="0">
                         <a:latin typeface="Montserrat" charset="0"/>
@@ -9302,7 +9654,7 @@
                     </a:solidFill>
                   </a:tcPr>
                 </a:tc>
-                <a:tc gridSpan="2">
+                <a:tc>
                   <a:txBody>
                     <a:bodyPr/>
                     <a:lstStyle/>
@@ -9319,7 +9671,7 @@
                           <a:ea typeface="Montserrat" pitchFamily="34" charset="-122"/>
                           <a:cs typeface="Montserrat" pitchFamily="34" charset="-120"/>
                         </a:rPr>
-                        <a:t>Commercial CLU</a:t>
+                        <a:t>Unverified CLU</a:t>
                       </a:r>
                       <a:endParaRPr lang="en-US" sz="700" dirty="0">
                         <a:latin typeface="Montserrat" charset="0"/>
@@ -9370,8 +9722,73 @@
                     </a:solidFill>
                   </a:tcPr>
                 </a:tc>
-                <a:tc hMerge="1">
-                  <a:tcPr/>
+                <a:tc>
+                  <a:txBody>
+                    <a:bodyPr/>
+                    <a:lstStyle/>
+                    <a:p>
+                      <a:pPr indent="0" marL="0">
+                        <a:buNone/>
+                      </a:pPr>
+                      <a:r>
+                        <a:rPr lang="en-US" sz="700" dirty="0">
+                          <a:solidFill>
+                            <a:srgbClr val="1A3350"/>
+                          </a:solidFill>
+                          <a:latin typeface="Montserrat" pitchFamily="34" charset="0"/>
+                          <a:ea typeface="Montserrat" pitchFamily="34" charset="-122"/>
+                          <a:cs typeface="Montserrat" pitchFamily="34" charset="-120"/>
+                        </a:rPr>
+                        <a:t>Fire NOC - Y</a:t>
+                      </a:r>
+                      <a:endParaRPr lang="en-US" sz="700" dirty="0">
+                        <a:latin typeface="Montserrat" charset="0"/>
+                        <a:ea typeface="Montserrat" charset="0"/>
+                        <a:cs typeface="Montserrat" charset="0"/>
+                      </a:endParaRPr>
+                    </a:p>
+                  </a:txBody>
+                  <a:tcPr marL="45720" marR="45720" marT="45720" marB="45720" anchor="ctr">
+                    <a:lnL w="6350" cap="flat" cmpd="sng" algn="ctr">
+                      <a:solidFill>
+                        <a:srgbClr val="CCCCCC"/>
+                      </a:solidFill>
+                      <a:prstDash val="solid"/>
+                      <a:round/>
+                      <a:headEnd type="none" w="med" len="med"/>
+                      <a:tailEnd type="none" w="med" len="med"/>
+                    </a:lnL>
+                    <a:lnR w="6350" cap="flat" cmpd="sng" algn="ctr">
+                      <a:solidFill>
+                        <a:srgbClr val="CCCCCC"/>
+                      </a:solidFill>
+                      <a:prstDash val="solid"/>
+                      <a:round/>
+                      <a:headEnd type="none" w="med" len="med"/>
+                      <a:tailEnd type="none" w="med" len="med"/>
+                    </a:lnR>
+                    <a:lnT w="6350" cap="flat" cmpd="sng" algn="ctr">
+                      <a:solidFill>
+                        <a:srgbClr val="CCCCCC"/>
+                      </a:solidFill>
+                      <a:prstDash val="solid"/>
+                      <a:round/>
+                      <a:headEnd type="none" w="med" len="med"/>
+                      <a:tailEnd type="none" w="med" len="med"/>
+                    </a:lnT>
+                    <a:lnB w="6350" cap="flat" cmpd="sng" algn="ctr">
+                      <a:solidFill>
+                        <a:srgbClr val="CCCCCC"/>
+                      </a:solidFill>
+                      <a:prstDash val="solid"/>
+                      <a:round/>
+                      <a:headEnd type="none" w="med" len="med"/>
+                      <a:tailEnd type="none" w="med" len="med"/>
+                    </a:lnB>
+                    <a:solidFill>
+                      <a:srgbClr val="F8F6F1"/>
+                    </a:solidFill>
+                  </a:tcPr>
                 </a:tc>
               </a:tr>
               <a:tr h="286664">
@@ -9574,7 +9991,7 @@
         </p:nvGraphicFramePr>
         <p:xfrm>
           <a:off x="137160" y="4463644"/>
-          <a:ext cx="2121408" cy="914400"/>
+          <a:ext cx="2395728" cy="914400"/>
         </p:xfrm>
         <a:graphic>
           <a:graphicData uri="http://schemas.openxmlformats.org/drawingml/2006/table">
@@ -9582,7 +9999,7 @@
               <a:tblPr/>
               <a:tblGrid>
                 <a:gridCol w="749808"/>
-                <a:gridCol w="1371600"/>
+                <a:gridCol w="1645920"/>
               </a:tblGrid>
               <a:tr h="416966">
                 <a:tc>
@@ -9670,7 +10087,7 @@
                           <a:ea typeface="Montserrat" pitchFamily="34" charset="-122"/>
                           <a:cs typeface="Montserrat" pitchFamily="34" charset="-120"/>
                         </a:rPr>
-                        <a:t>60</a:t>
+                        <a:t>27+1</a:t>
                       </a:r>
                       <a:endParaRPr lang="en-US" sz="700" dirty="0">
                         <a:latin typeface="Montserrat" charset="0"/>
@@ -9735,2008 +10152,7 @@
           <p:nvPr/>
         </p:nvPicPr>
         <p:blipFill>
-          <a:blip r:embed="rId1"/>
-          <a:srcRect l="0" r="0" t="0" b="0"/>
-          <a:stretch/>
-        </p:blipFill>
-        <p:spPr>
-          <a:xfrm>
-            <a:off x="2651760" y="365760"/>
-            <a:ext cx="6080760" cy="2194560"/>
-          </a:xfrm>
-          <a:prstGeom prst="rect">
-            <a:avLst/>
-          </a:prstGeom>
-        </p:spPr>
-      </p:pic>
-      <p:pic>
-        <p:nvPicPr>
-          <p:cNvPr id="12" name="Image 1" descr="preencoded.png">    </p:cNvPr>
-          <p:cNvPicPr>
-            <a:picLocks noChangeAspect="1"/>
-          </p:cNvPicPr>
-          <p:nvPr/>
-        </p:nvPicPr>
-        <p:blipFill>
           <a:blip r:embed="rId2"/>
-          <a:srcRect l="0" r="0" t="0" b="0"/>
-          <a:stretch/>
-        </p:blipFill>
-        <p:spPr>
-          <a:xfrm>
-            <a:off x="2651760" y="2697480"/>
-            <a:ext cx="2971800" cy="2011680"/>
-          </a:xfrm>
-          <a:prstGeom prst="rect">
-            <a:avLst/>
-          </a:prstGeom>
-        </p:spPr>
-      </p:pic>
-      <p:pic>
-        <p:nvPicPr>
-          <p:cNvPr id="13" name="Image 2" descr="preencoded.png">    </p:cNvPr>
-          <p:cNvPicPr>
-            <a:picLocks noChangeAspect="1"/>
-          </p:cNvPicPr>
-          <p:nvPr/>
-        </p:nvPicPr>
-        <p:blipFill>
-          <a:blip r:embed="rId3"/>
-          <a:srcRect l="0" r="0" t="0" b="0"/>
-          <a:stretch/>
-        </p:blipFill>
-        <p:spPr>
-          <a:xfrm>
-            <a:off x="5760720" y="2697480"/>
-            <a:ext cx="2971800" cy="2011680"/>
-          </a:xfrm>
-          <a:prstGeom prst="rect">
-            <a:avLst/>
-          </a:prstGeom>
-        </p:spPr>
-      </p:pic>
-      <p:pic>
-        <p:nvPicPr>
-          <p:cNvPr id="14" name="Image 3" descr="/home/rs0125/dev/wareongo/Warehouse-Proposal-Engine/assets/WOG_logo_Transparent.png">    </p:cNvPr>
-          <p:cNvPicPr>
-            <a:picLocks noChangeAspect="1"/>
-          </p:cNvPicPr>
-          <p:nvPr/>
-        </p:nvPicPr>
-        <p:blipFill>
-          <a:blip r:embed="rId4"/>
-          <a:stretch>
-            <a:fillRect/>
-          </a:stretch>
-        </p:blipFill>
-        <p:spPr>
-          <a:xfrm>
-            <a:off x="8732520" y="45720"/>
-            <a:ext cx="365760" cy="365760"/>
-          </a:xfrm>
-          <a:prstGeom prst="rect">
-            <a:avLst/>
-          </a:prstGeom>
-        </p:spPr>
-      </p:pic>
-      <p:sp>
-        <p:nvSpPr>
-          <p:cNvPr id="15" name="Text 6"/>
-          <p:cNvSpPr/>
-          <p:nvPr/>
-        </p:nvSpPr>
-        <p:spPr>
-          <a:xfrm>
-            <a:off x="4572000" y="4887468"/>
-            <a:ext cx="4389120" cy="256032"/>
-          </a:xfrm>
-          <a:prstGeom prst="rect">
-            <a:avLst/>
-          </a:prstGeom>
-          <a:noFill/>
-          <a:ln/>
-        </p:spPr>
-        <p:txBody>
-          <a:bodyPr wrap="square" rtlCol="0" anchor="ctr"/>
-          <a:lstStyle/>
-          <a:p>
-            <a:pPr algn="r" indent="0" marL="0">
-              <a:buNone/>
-            </a:pPr>
-            <a:r>
-              <a:rPr lang="en-US" sz="850" dirty="0">
-                <a:solidFill>
-                  <a:srgbClr val="1A3350"/>
-                </a:solidFill>
-                <a:latin typeface="Montserrat" pitchFamily="34" charset="0"/>
-                <a:ea typeface="Montserrat" pitchFamily="34" charset="-122"/>
-                <a:cs typeface="Montserrat" pitchFamily="34" charset="-120"/>
-              </a:rPr>
-              <a:t>Prepared by WareOnGo  |  Dated 23/05/2026  |  Confidential</a:t>
-            </a:r>
-            <a:endParaRPr lang="en-US" sz="850" dirty="0"/>
-          </a:p>
-        </p:txBody>
-      </p:sp>
-    </p:spTree>
-  </p:cSld>
-  <p:clrMapOvr>
-    <a:masterClrMapping/>
-  </p:clrMapOvr>
-</p:sld>
-</file>
-
-<file path=ppt/slides/slide6.xml><?xml version="1.0" encoding="utf-8"?>
-<p:sld xmlns:a="http://schemas.openxmlformats.org/drawingml/2006/main" xmlns:r="http://schemas.openxmlformats.org/officeDocument/2006/relationships" xmlns:p="http://schemas.openxmlformats.org/presentationml/2006/main">
-  <p:cSld name="Slide 6">
-    <p:bg>
-      <p:bgPr>
-        <a:solidFill>
-          <a:srgbClr val="F8F6F1"/>
-        </a:solidFill>
-      </p:bgPr>
-    </p:bg>
-    <p:spTree>
-      <p:nvGrpSpPr>
-        <p:cNvPr id="1" name=""/>
-        <p:cNvGrpSpPr/>
-        <p:nvPr/>
-      </p:nvGrpSpPr>
-      <p:grpSpPr>
-        <a:xfrm>
-          <a:off x="0" y="0"/>
-          <a:ext cx="0" cy="0"/>
-          <a:chOff x="0" y="0"/>
-          <a:chExt cx="0" cy="0"/>
-        </a:xfrm>
-      </p:grpSpPr>
-      <p:sp>
-        <p:nvSpPr>
-          <p:cNvPr id="2" name="Shape 0"/>
-          <p:cNvSpPr/>
-          <p:nvPr/>
-        </p:nvSpPr>
-        <p:spPr>
-          <a:xfrm>
-            <a:off x="0" y="0"/>
-            <a:ext cx="2400300" cy="5143500"/>
-          </a:xfrm>
-          <a:prstGeom prst="rect">
-            <a:avLst/>
-          </a:prstGeom>
-          <a:solidFill>
-            <a:srgbClr val="F8F6F1"/>
-          </a:solidFill>
-          <a:ln w="12700">
-            <a:solidFill>
-              <a:srgbClr val="F8F6F1"/>
-            </a:solidFill>
-            <a:prstDash val="solid"/>
-          </a:ln>
-        </p:spPr>
-      </p:sp>
-      <p:sp>
-        <p:nvSpPr>
-          <p:cNvPr id="3" name="Shape 1"/>
-          <p:cNvSpPr/>
-          <p:nvPr/>
-        </p:nvSpPr>
-        <p:spPr>
-          <a:xfrm>
-            <a:off x="2400300" y="0"/>
-            <a:ext cx="0" cy="5143500"/>
-          </a:xfrm>
-          <a:prstGeom prst="line">
-            <a:avLst/>
-          </a:prstGeom>
-          <a:noFill/>
-          <a:ln w="6350">
-            <a:solidFill>
-              <a:srgbClr val="CCCCCC"/>
-            </a:solidFill>
-            <a:prstDash val="solid"/>
-          </a:ln>
-        </p:spPr>
-      </p:sp>
-      <p:sp>
-        <p:nvSpPr>
-          <p:cNvPr id="4" name="Text 2"/>
-          <p:cNvSpPr/>
-          <p:nvPr/>
-        </p:nvSpPr>
-        <p:spPr>
-          <a:xfrm>
-            <a:off x="81382" y="71323"/>
-            <a:ext cx="2240280" cy="448970"/>
-          </a:xfrm>
-          <a:prstGeom prst="rect">
-            <a:avLst/>
-          </a:prstGeom>
-          <a:noFill/>
-          <a:ln/>
-        </p:spPr>
-        <p:txBody>
-          <a:bodyPr wrap="square" rtlCol="0" anchor="ctr"/>
-          <a:lstStyle/>
-          <a:p>
-            <a:pPr indent="0" marL="0">
-              <a:buNone/>
-            </a:pPr>
-            <a:r>
-              <a:rPr lang="en-US" sz="1300" b="1" dirty="0">
-                <a:solidFill>
-                  <a:srgbClr val="1A3350"/>
-                </a:solidFill>
-                <a:latin typeface="Montserrat ExtraBold" pitchFamily="34" charset="0"/>
-                <a:ea typeface="Montserrat ExtraBold" pitchFamily="34" charset="-122"/>
-                <a:cs typeface="Montserrat ExtraBold" pitchFamily="34" charset="-120"/>
-              </a:rPr>
-              <a:t>Option 4 - ID 1638</a:t>
-            </a:r>
-            <a:endParaRPr lang="en-US" sz="1300" dirty="0"/>
-          </a:p>
-        </p:txBody>
-      </p:sp>
-      <p:sp>
-        <p:nvSpPr>
-          <p:cNvPr id="5" name="Text 3"/>
-          <p:cNvSpPr/>
-          <p:nvPr/>
-        </p:nvSpPr>
-        <p:spPr>
-          <a:xfrm>
-            <a:off x="81382" y="429402"/>
-            <a:ext cx="2057400" cy="320040"/>
-          </a:xfrm>
-          <a:prstGeom prst="rect">
-            <a:avLst/>
-          </a:prstGeom>
-          <a:noFill/>
-          <a:ln/>
-        </p:spPr>
-        <p:txBody>
-          <a:bodyPr wrap="square" rtlCol="0" anchor="ctr"/>
-          <a:lstStyle/>
-          <a:p>
-            <a:pPr indent="0" marL="0">
-              <a:buNone/>
-            </a:pPr>
-            <a:r>
-              <a:rPr lang="en-US" sz="1000" b="1" dirty="0">
-                <a:solidFill>
-                  <a:srgbClr val="1A3350"/>
-                </a:solidFill>
-                <a:latin typeface="Montserrat" pitchFamily="34" charset="0"/>
-                <a:ea typeface="Montserrat" pitchFamily="34" charset="-122"/>
-                <a:cs typeface="Montserrat" pitchFamily="34" charset="-120"/>
-              </a:rPr>
-              <a:t>Location Details</a:t>
-            </a:r>
-            <a:endParaRPr lang="en-US" sz="1000" dirty="0"/>
-          </a:p>
-        </p:txBody>
-      </p:sp>
-      <p:graphicFrame>
-        <p:nvGraphicFramePr>
-          <p:cNvPr id="7" name="Table 0"/>
-          <p:cNvGraphicFramePr>
-            <a:graphicFrameLocks noGrp="1"/>
-          </p:cNvGraphicFramePr>
-          <p:nvPr>
-            <p:extLst>
-              <p:ext uri="{D42A27DB-BD31-4B8C-83A1-F6EECF244321}">
-                <p14:modId xmlns:p14="http://schemas.microsoft.com/office/powerpoint/2010/main" val="1579011935"/>
-              </p:ext>
-            </p:extLst>
-          </p:nvPr>
-        </p:nvGraphicFramePr>
-        <p:xfrm>
-          <a:off x="137160" y="735178"/>
-          <a:ext cx="2121408" cy="914400"/>
-        </p:xfrm>
-        <a:graphic>
-          <a:graphicData uri="http://schemas.openxmlformats.org/drawingml/2006/table">
-            <a:tbl>
-              <a:tblPr/>
-              <a:tblGrid>
-                <a:gridCol w="749808"/>
-                <a:gridCol w="1371600"/>
-              </a:tblGrid>
-              <a:tr h="286664">
-                <a:tc>
-                  <a:txBody>
-                    <a:bodyPr/>
-                    <a:lstStyle/>
-                    <a:p>
-                      <a:pPr indent="0" marL="0">
-                        <a:buNone/>
-                      </a:pPr>
-                      <a:r>
-                        <a:rPr lang="en-US" sz="700" b="1" dirty="0">
-                          <a:solidFill>
-                            <a:srgbClr val="F8F6F1"/>
-                          </a:solidFill>
-                          <a:latin typeface="Montserrat SemiBold" pitchFamily="34" charset="0"/>
-                          <a:ea typeface="Montserrat SemiBold" pitchFamily="34" charset="-122"/>
-                          <a:cs typeface="Montserrat SemiBold" pitchFamily="34" charset="-120"/>
-                        </a:rPr>
-                        <a:t>Address</a:t>
-                      </a:r>
-                      <a:endParaRPr lang="en-US" sz="700" dirty="0">
-                        <a:latin typeface="Montserrat SemiBold" charset="0"/>
-                        <a:ea typeface="Montserrat SemiBold" charset="0"/>
-                        <a:cs typeface="Montserrat SemiBold" charset="0"/>
-                      </a:endParaRPr>
-                    </a:p>
-                  </a:txBody>
-                  <a:tcPr marL="45720" marR="45720" marT="45720" marB="45720" anchor="ctr">
-                    <a:lnL w="6350" cap="flat" cmpd="sng" algn="ctr">
-                      <a:solidFill>
-                        <a:srgbClr val="CCCCCC"/>
-                      </a:solidFill>
-                      <a:prstDash val="solid"/>
-                      <a:round/>
-                      <a:headEnd type="none" w="med" len="med"/>
-                      <a:tailEnd type="none" w="med" len="med"/>
-                    </a:lnL>
-                    <a:lnR w="6350" cap="flat" cmpd="sng" algn="ctr">
-                      <a:solidFill>
-                        <a:srgbClr val="CCCCCC"/>
-                      </a:solidFill>
-                      <a:prstDash val="solid"/>
-                      <a:round/>
-                      <a:headEnd type="none" w="med" len="med"/>
-                      <a:tailEnd type="none" w="med" len="med"/>
-                    </a:lnR>
-                    <a:lnT w="6350" cap="flat" cmpd="sng" algn="ctr">
-                      <a:solidFill>
-                        <a:srgbClr val="CCCCCC"/>
-                      </a:solidFill>
-                      <a:prstDash val="solid"/>
-                      <a:round/>
-                      <a:headEnd type="none" w="med" len="med"/>
-                      <a:tailEnd type="none" w="med" len="med"/>
-                    </a:lnT>
-                    <a:lnB w="6350" cap="flat" cmpd="sng" algn="ctr">
-                      <a:solidFill>
-                        <a:srgbClr val="CCCCCC"/>
-                      </a:solidFill>
-                      <a:prstDash val="solid"/>
-                      <a:round/>
-                      <a:headEnd type="none" w="med" len="med"/>
-                      <a:tailEnd type="none" w="med" len="med"/>
-                    </a:lnB>
-                    <a:solidFill>
-                      <a:srgbClr val="1A3350"/>
-                    </a:solidFill>
-                  </a:tcPr>
-                </a:tc>
-                <a:tc>
-                  <a:txBody>
-                    <a:bodyPr/>
-                    <a:lstStyle/>
-                    <a:p>
-                      <a:pPr indent="0" marL="0">
-                        <a:buNone/>
-                      </a:pPr>
-                      <a:r>
-                        <a:rPr lang="en-US" sz="700" dirty="0">
-                          <a:solidFill>
-                            <a:srgbClr val="1A3350"/>
-                          </a:solidFill>
-                          <a:latin typeface="Montserrat" pitchFamily="34" charset="0"/>
-                          <a:ea typeface="Montserrat" pitchFamily="34" charset="-122"/>
-                          <a:cs typeface="Montserrat" pitchFamily="34" charset="-120"/>
-                        </a:rPr>
-                        <a:t>Secunderabad, Telangana</a:t>
-                      </a:r>
-                      <a:endParaRPr lang="en-US" sz="700" dirty="0">
-                        <a:latin typeface="Montserrat" charset="0"/>
-                        <a:ea typeface="Montserrat" charset="0"/>
-                        <a:cs typeface="Montserrat" charset="0"/>
-                      </a:endParaRPr>
-                    </a:p>
-                  </a:txBody>
-                  <a:tcPr marL="45720" marR="45720" marT="45720" marB="45720" anchor="ctr">
-                    <a:lnL w="6350" cap="flat" cmpd="sng" algn="ctr">
-                      <a:solidFill>
-                        <a:srgbClr val="CCCCCC"/>
-                      </a:solidFill>
-                      <a:prstDash val="solid"/>
-                      <a:round/>
-                      <a:headEnd type="none" w="med" len="med"/>
-                      <a:tailEnd type="none" w="med" len="med"/>
-                    </a:lnL>
-                    <a:lnR w="6350" cap="flat" cmpd="sng" algn="ctr">
-                      <a:solidFill>
-                        <a:srgbClr val="CCCCCC"/>
-                      </a:solidFill>
-                      <a:prstDash val="solid"/>
-                      <a:round/>
-                      <a:headEnd type="none" w="med" len="med"/>
-                      <a:tailEnd type="none" w="med" len="med"/>
-                    </a:lnR>
-                    <a:lnT w="6350" cap="flat" cmpd="sng" algn="ctr">
-                      <a:solidFill>
-                        <a:srgbClr val="CCCCCC"/>
-                      </a:solidFill>
-                      <a:prstDash val="solid"/>
-                      <a:round/>
-                      <a:headEnd type="none" w="med" len="med"/>
-                      <a:tailEnd type="none" w="med" len="med"/>
-                    </a:lnT>
-                    <a:lnB w="6350" cap="flat" cmpd="sng" algn="ctr">
-                      <a:solidFill>
-                        <a:srgbClr val="CCCCCC"/>
-                      </a:solidFill>
-                      <a:prstDash val="solid"/>
-                      <a:round/>
-                      <a:headEnd type="none" w="med" len="med"/>
-                      <a:tailEnd type="none" w="med" len="med"/>
-                    </a:lnB>
-                    <a:solidFill>
-                      <a:srgbClr val="F8F6F1"/>
-                    </a:solidFill>
-                  </a:tcPr>
-                </a:tc>
-              </a:tr>
-              <a:tr h="286664">
-                <a:tc>
-                  <a:txBody>
-                    <a:bodyPr/>
-                    <a:lstStyle/>
-                    <a:p>
-                      <a:pPr indent="0" marL="0">
-                        <a:buNone/>
-                      </a:pPr>
-                      <a:r>
-                        <a:rPr lang="en-US" sz="700" b="1" dirty="0">
-                          <a:solidFill>
-                            <a:srgbClr val="F8F6F1"/>
-                          </a:solidFill>
-                          <a:latin typeface="Montserrat SemiBold" pitchFamily="34" charset="0"/>
-                          <a:ea typeface="Montserrat SemiBold" pitchFamily="34" charset="-122"/>
-                          <a:cs typeface="Montserrat SemiBold" pitchFamily="34" charset="-120"/>
-                        </a:rPr>
-                        <a:t>Google Maps</a:t>
-                      </a:r>
-                      <a:endParaRPr lang="en-US" sz="700" dirty="0">
-                        <a:latin typeface="Montserrat SemiBold" charset="0"/>
-                        <a:ea typeface="Montserrat SemiBold" charset="0"/>
-                        <a:cs typeface="Montserrat SemiBold" charset="0"/>
-                      </a:endParaRPr>
-                    </a:p>
-                  </a:txBody>
-                  <a:tcPr marL="45720" marR="45720" marT="45720" marB="45720" anchor="ctr">
-                    <a:lnL w="6350" cap="flat" cmpd="sng" algn="ctr">
-                      <a:solidFill>
-                        <a:srgbClr val="CCCCCC"/>
-                      </a:solidFill>
-                      <a:prstDash val="solid"/>
-                      <a:round/>
-                      <a:headEnd type="none" w="med" len="med"/>
-                      <a:tailEnd type="none" w="med" len="med"/>
-                    </a:lnL>
-                    <a:lnR w="6350" cap="flat" cmpd="sng" algn="ctr">
-                      <a:solidFill>
-                        <a:srgbClr val="CCCCCC"/>
-                      </a:solidFill>
-                      <a:prstDash val="solid"/>
-                      <a:round/>
-                      <a:headEnd type="none" w="med" len="med"/>
-                      <a:tailEnd type="none" w="med" len="med"/>
-                    </a:lnR>
-                    <a:lnT w="6350" cap="flat" cmpd="sng" algn="ctr">
-                      <a:solidFill>
-                        <a:srgbClr val="CCCCCC"/>
-                      </a:solidFill>
-                      <a:prstDash val="solid"/>
-                      <a:round/>
-                      <a:headEnd type="none" w="med" len="med"/>
-                      <a:tailEnd type="none" w="med" len="med"/>
-                    </a:lnT>
-                    <a:lnB w="6350" cap="flat" cmpd="sng" algn="ctr">
-                      <a:solidFill>
-                        <a:srgbClr val="CCCCCC"/>
-                      </a:solidFill>
-                      <a:prstDash val="solid"/>
-                      <a:round/>
-                      <a:headEnd type="none" w="med" len="med"/>
-                      <a:tailEnd type="none" w="med" len="med"/>
-                    </a:lnB>
-                    <a:solidFill>
-                      <a:srgbClr val="1A3350"/>
-                    </a:solidFill>
-                  </a:tcPr>
-                </a:tc>
-                <a:tc>
-                  <a:txBody>
-                    <a:bodyPr/>
-                    <a:lstStyle/>
-                    <a:p>
-                      <a:pPr indent="0" marL="0">
-                        <a:buNone/>
-                      </a:pPr>
-                      <a:r>
-                        <a:rPr lang="en-US" sz="700" dirty="0">
-                          <a:solidFill>
-                            <a:srgbClr val="1A3350"/>
-                          </a:solidFill>
-                          <a:latin typeface="Montserrat" pitchFamily="34" charset="0"/>
-                          <a:ea typeface="Montserrat" pitchFamily="34" charset="-122"/>
-                          <a:cs typeface="Montserrat" pitchFamily="34" charset="-120"/>
-                        </a:rPr>
-                        <a:t>See link</a:t>
-                      </a:r>
-                      <a:endParaRPr lang="en-US" sz="700" dirty="0">
-                        <a:latin typeface="Montserrat" charset="0"/>
-                        <a:ea typeface="Montserrat" charset="0"/>
-                        <a:cs typeface="Montserrat" charset="0"/>
-                      </a:endParaRPr>
-                    </a:p>
-                  </a:txBody>
-                  <a:tcPr marL="45720" marR="45720" marT="45720" marB="45720" anchor="ctr">
-                    <a:lnL w="6350" cap="flat" cmpd="sng" algn="ctr">
-                      <a:solidFill>
-                        <a:srgbClr val="CCCCCC"/>
-                      </a:solidFill>
-                      <a:prstDash val="solid"/>
-                      <a:round/>
-                      <a:headEnd type="none" w="med" len="med"/>
-                      <a:tailEnd type="none" w="med" len="med"/>
-                    </a:lnL>
-                    <a:lnR w="6350" cap="flat" cmpd="sng" algn="ctr">
-                      <a:solidFill>
-                        <a:srgbClr val="CCCCCC"/>
-                      </a:solidFill>
-                      <a:prstDash val="solid"/>
-                      <a:round/>
-                      <a:headEnd type="none" w="med" len="med"/>
-                      <a:tailEnd type="none" w="med" len="med"/>
-                    </a:lnR>
-                    <a:lnT w="6350" cap="flat" cmpd="sng" algn="ctr">
-                      <a:solidFill>
-                        <a:srgbClr val="CCCCCC"/>
-                      </a:solidFill>
-                      <a:prstDash val="solid"/>
-                      <a:round/>
-                      <a:headEnd type="none" w="med" len="med"/>
-                      <a:tailEnd type="none" w="med" len="med"/>
-                    </a:lnT>
-                    <a:lnB w="6350" cap="flat" cmpd="sng" algn="ctr">
-                      <a:solidFill>
-                        <a:srgbClr val="CCCCCC"/>
-                      </a:solidFill>
-                      <a:prstDash val="solid"/>
-                      <a:round/>
-                      <a:headEnd type="none" w="med" len="med"/>
-                      <a:tailEnd type="none" w="med" len="med"/>
-                    </a:lnB>
-                    <a:solidFill>
-                      <a:srgbClr val="F8F6F1"/>
-                    </a:solidFill>
-                  </a:tcPr>
-                </a:tc>
-              </a:tr>
-            </a:tbl>
-          </a:graphicData>
-        </a:graphic>
-      </p:graphicFrame>
-      <p:sp>
-        <p:nvSpPr>
-          <p:cNvPr id="7" name="Text 4"/>
-          <p:cNvSpPr/>
-          <p:nvPr/>
-        </p:nvSpPr>
-        <p:spPr>
-          <a:xfrm>
-            <a:off x="81382" y="1368491"/>
-            <a:ext cx="2057400" cy="320040"/>
-          </a:xfrm>
-          <a:prstGeom prst="rect">
-            <a:avLst/>
-          </a:prstGeom>
-          <a:noFill/>
-          <a:ln/>
-        </p:spPr>
-        <p:txBody>
-          <a:bodyPr wrap="square" rtlCol="0" anchor="ctr"/>
-          <a:lstStyle/>
-          <a:p>
-            <a:pPr indent="0" marL="0">
-              <a:buNone/>
-            </a:pPr>
-            <a:r>
-              <a:rPr lang="en-US" sz="1000" b="1" dirty="0">
-                <a:solidFill>
-                  <a:srgbClr val="1A3350"/>
-                </a:solidFill>
-                <a:latin typeface="Montserrat" pitchFamily="34" charset="0"/>
-                <a:ea typeface="Montserrat" pitchFamily="34" charset="-122"/>
-                <a:cs typeface="Montserrat" pitchFamily="34" charset="-120"/>
-              </a:rPr>
-              <a:t>Specifications</a:t>
-            </a:r>
-            <a:endParaRPr lang="en-US" sz="1000" dirty="0"/>
-          </a:p>
-        </p:txBody>
-      </p:sp>
-      <p:graphicFrame>
-        <p:nvGraphicFramePr>
-          <p:cNvPr id="13" name="Table 1"/>
-          <p:cNvGraphicFramePr>
-            <a:graphicFrameLocks noGrp="1"/>
-          </p:cNvGraphicFramePr>
-          <p:nvPr>
-            <p:extLst>
-              <p:ext uri="{D42A27DB-BD31-4B8C-83A1-F6EECF244321}">
-                <p14:modId xmlns:p14="http://schemas.microsoft.com/office/powerpoint/2010/main" val="1579011935"/>
-              </p:ext>
-            </p:extLst>
-          </p:nvPr>
-        </p:nvGraphicFramePr>
-        <p:xfrm>
-          <a:off x="137160" y="1674266"/>
-          <a:ext cx="2121408" cy="914400"/>
-        </p:xfrm>
-        <a:graphic>
-          <a:graphicData uri="http://schemas.openxmlformats.org/drawingml/2006/table">
-            <a:tbl>
-              <a:tblPr/>
-              <a:tblGrid>
-                <a:gridCol w="749808"/>
-                <a:gridCol w="594360"/>
-                <a:gridCol w="777240"/>
-              </a:tblGrid>
-              <a:tr h="286664">
-                <a:tc>
-                  <a:txBody>
-                    <a:bodyPr/>
-                    <a:lstStyle/>
-                    <a:p>
-                      <a:pPr indent="0" marL="0">
-                        <a:buNone/>
-                      </a:pPr>
-                      <a:r>
-                        <a:rPr lang="en-US" sz="700" b="1" dirty="0">
-                          <a:solidFill>
-                            <a:srgbClr val="F8F6F1"/>
-                          </a:solidFill>
-                          <a:latin typeface="Montserrat SemiBold" pitchFamily="34" charset="0"/>
-                          <a:ea typeface="Montserrat SemiBold" pitchFamily="34" charset="-122"/>
-                          <a:cs typeface="Montserrat SemiBold" pitchFamily="34" charset="-120"/>
-                        </a:rPr>
-                        <a:t>Offered Area</a:t>
-                      </a:r>
-                      <a:endParaRPr lang="en-US" sz="700" dirty="0">
-                        <a:latin typeface="Montserrat SemiBold" charset="0"/>
-                        <a:ea typeface="Montserrat SemiBold" charset="0"/>
-                        <a:cs typeface="Montserrat SemiBold" charset="0"/>
-                      </a:endParaRPr>
-                    </a:p>
-                  </a:txBody>
-                  <a:tcPr marL="45720" marR="45720" marT="45720" marB="45720" anchor="ctr">
-                    <a:lnL w="6350" cap="flat" cmpd="sng" algn="ctr">
-                      <a:solidFill>
-                        <a:srgbClr val="CCCCCC"/>
-                      </a:solidFill>
-                      <a:prstDash val="solid"/>
-                      <a:round/>
-                      <a:headEnd type="none" w="med" len="med"/>
-                      <a:tailEnd type="none" w="med" len="med"/>
-                    </a:lnL>
-                    <a:lnR w="6350" cap="flat" cmpd="sng" algn="ctr">
-                      <a:solidFill>
-                        <a:srgbClr val="CCCCCC"/>
-                      </a:solidFill>
-                      <a:prstDash val="solid"/>
-                      <a:round/>
-                      <a:headEnd type="none" w="med" len="med"/>
-                      <a:tailEnd type="none" w="med" len="med"/>
-                    </a:lnR>
-                    <a:lnT w="6350" cap="flat" cmpd="sng" algn="ctr">
-                      <a:solidFill>
-                        <a:srgbClr val="CCCCCC"/>
-                      </a:solidFill>
-                      <a:prstDash val="solid"/>
-                      <a:round/>
-                      <a:headEnd type="none" w="med" len="med"/>
-                      <a:tailEnd type="none" w="med" len="med"/>
-                    </a:lnT>
-                    <a:lnB w="6350" cap="flat" cmpd="sng" algn="ctr">
-                      <a:solidFill>
-                        <a:srgbClr val="CCCCCC"/>
-                      </a:solidFill>
-                      <a:prstDash val="solid"/>
-                      <a:round/>
-                      <a:headEnd type="none" w="med" len="med"/>
-                      <a:tailEnd type="none" w="med" len="med"/>
-                    </a:lnB>
-                    <a:solidFill>
-                      <a:srgbClr val="1A3350"/>
-                    </a:solidFill>
-                  </a:tcPr>
-                </a:tc>
-                <a:tc gridSpan="2">
-                  <a:txBody>
-                    <a:bodyPr/>
-                    <a:lstStyle/>
-                    <a:p>
-                      <a:pPr indent="0" marL="0">
-                        <a:buNone/>
-                      </a:pPr>
-                      <a:r>
-                        <a:rPr lang="en-US" sz="700" dirty="0">
-                          <a:solidFill>
-                            <a:srgbClr val="1A3350"/>
-                          </a:solidFill>
-                          <a:latin typeface="Montserrat" pitchFamily="34" charset="0"/>
-                          <a:ea typeface="Montserrat" pitchFamily="34" charset="-122"/>
-                          <a:cs typeface="Montserrat" pitchFamily="34" charset="-120"/>
-                        </a:rPr>
-                        <a:t>17100 sqft</a:t>
-                      </a:r>
-                      <a:endParaRPr lang="en-US" sz="700" dirty="0">
-                        <a:latin typeface="Montserrat" charset="0"/>
-                        <a:ea typeface="Montserrat" charset="0"/>
-                        <a:cs typeface="Montserrat" charset="0"/>
-                      </a:endParaRPr>
-                    </a:p>
-                  </a:txBody>
-                  <a:tcPr marL="45720" marR="45720" marT="45720" marB="45720" anchor="ctr">
-                    <a:lnL w="6350" cap="flat" cmpd="sng" algn="ctr">
-                      <a:solidFill>
-                        <a:srgbClr val="CCCCCC"/>
-                      </a:solidFill>
-                      <a:prstDash val="solid"/>
-                      <a:round/>
-                      <a:headEnd type="none" w="med" len="med"/>
-                      <a:tailEnd type="none" w="med" len="med"/>
-                    </a:lnL>
-                    <a:lnR w="6350" cap="flat" cmpd="sng" algn="ctr">
-                      <a:solidFill>
-                        <a:srgbClr val="CCCCCC"/>
-                      </a:solidFill>
-                      <a:prstDash val="solid"/>
-                      <a:round/>
-                      <a:headEnd type="none" w="med" len="med"/>
-                      <a:tailEnd type="none" w="med" len="med"/>
-                    </a:lnR>
-                    <a:lnT w="6350" cap="flat" cmpd="sng" algn="ctr">
-                      <a:solidFill>
-                        <a:srgbClr val="CCCCCC"/>
-                      </a:solidFill>
-                      <a:prstDash val="solid"/>
-                      <a:round/>
-                      <a:headEnd type="none" w="med" len="med"/>
-                      <a:tailEnd type="none" w="med" len="med"/>
-                    </a:lnT>
-                    <a:lnB w="6350" cap="flat" cmpd="sng" algn="ctr">
-                      <a:solidFill>
-                        <a:srgbClr val="CCCCCC"/>
-                      </a:solidFill>
-                      <a:prstDash val="solid"/>
-                      <a:round/>
-                      <a:headEnd type="none" w="med" len="med"/>
-                      <a:tailEnd type="none" w="med" len="med"/>
-                    </a:lnB>
-                    <a:solidFill>
-                      <a:srgbClr val="F8F6F1"/>
-                    </a:solidFill>
-                  </a:tcPr>
-                </a:tc>
-                <a:tc hMerge="1">
-                  <a:tcPr/>
-                </a:tc>
-              </a:tr>
-              <a:tr h="286664">
-                <a:tc>
-                  <a:txBody>
-                    <a:bodyPr/>
-                    <a:lstStyle/>
-                    <a:p>
-                      <a:pPr indent="0" marL="0">
-                        <a:buNone/>
-                      </a:pPr>
-                      <a:r>
-                        <a:rPr lang="en-US" sz="700" b="1" dirty="0">
-                          <a:solidFill>
-                            <a:srgbClr val="F8F6F1"/>
-                          </a:solidFill>
-                          <a:latin typeface="Montserrat SemiBold" pitchFamily="34" charset="0"/>
-                          <a:ea typeface="Montserrat SemiBold" pitchFamily="34" charset="-122"/>
-                          <a:cs typeface="Montserrat SemiBold" pitchFamily="34" charset="-120"/>
-                        </a:rPr>
-                        <a:t>Building</a:t>
-                      </a:r>
-                      <a:endParaRPr lang="en-US" sz="700" dirty="0">
-                        <a:latin typeface="Montserrat SemiBold" charset="0"/>
-                        <a:ea typeface="Montserrat SemiBold" charset="0"/>
-                        <a:cs typeface="Montserrat SemiBold" charset="0"/>
-                      </a:endParaRPr>
-                    </a:p>
-                  </a:txBody>
-                  <a:tcPr marL="45720" marR="45720" marT="45720" marB="45720" anchor="ctr">
-                    <a:lnL w="6350" cap="flat" cmpd="sng" algn="ctr">
-                      <a:solidFill>
-                        <a:srgbClr val="CCCCCC"/>
-                      </a:solidFill>
-                      <a:prstDash val="solid"/>
-                      <a:round/>
-                      <a:headEnd type="none" w="med" len="med"/>
-                      <a:tailEnd type="none" w="med" len="med"/>
-                    </a:lnL>
-                    <a:lnR w="6350" cap="flat" cmpd="sng" algn="ctr">
-                      <a:solidFill>
-                        <a:srgbClr val="CCCCCC"/>
-                      </a:solidFill>
-                      <a:prstDash val="solid"/>
-                      <a:round/>
-                      <a:headEnd type="none" w="med" len="med"/>
-                      <a:tailEnd type="none" w="med" len="med"/>
-                    </a:lnR>
-                    <a:lnT w="6350" cap="flat" cmpd="sng" algn="ctr">
-                      <a:solidFill>
-                        <a:srgbClr val="CCCCCC"/>
-                      </a:solidFill>
-                      <a:prstDash val="solid"/>
-                      <a:round/>
-                      <a:headEnd type="none" w="med" len="med"/>
-                      <a:tailEnd type="none" w="med" len="med"/>
-                    </a:lnT>
-                    <a:lnB w="6350" cap="flat" cmpd="sng" algn="ctr">
-                      <a:solidFill>
-                        <a:srgbClr val="CCCCCC"/>
-                      </a:solidFill>
-                      <a:prstDash val="solid"/>
-                      <a:round/>
-                      <a:headEnd type="none" w="med" len="med"/>
-                      <a:tailEnd type="none" w="med" len="med"/>
-                    </a:lnB>
-                    <a:solidFill>
-                      <a:srgbClr val="1A3350"/>
-                    </a:solidFill>
-                  </a:tcPr>
-                </a:tc>
-                <a:tc gridSpan="2">
-                  <a:txBody>
-                    <a:bodyPr/>
-                    <a:lstStyle/>
-                    <a:p>
-                      <a:pPr indent="0" marL="0">
-                        <a:buNone/>
-                      </a:pPr>
-                      <a:r>
-                        <a:rPr lang="en-US" sz="700" dirty="0">
-                          <a:solidFill>
-                            <a:srgbClr val="1A3350"/>
-                          </a:solidFill>
-                          <a:latin typeface="Montserrat" pitchFamily="34" charset="0"/>
-                          <a:ea typeface="Montserrat" pitchFamily="34" charset="-122"/>
-                          <a:cs typeface="Montserrat" pitchFamily="34" charset="-120"/>
-                        </a:rPr>
-                        <a:t>PEB</a:t>
-                      </a:r>
-                      <a:endParaRPr lang="en-US" sz="700" dirty="0">
-                        <a:latin typeface="Montserrat" charset="0"/>
-                        <a:ea typeface="Montserrat" charset="0"/>
-                        <a:cs typeface="Montserrat" charset="0"/>
-                      </a:endParaRPr>
-                    </a:p>
-                  </a:txBody>
-                  <a:tcPr marL="45720" marR="45720" marT="45720" marB="45720" anchor="ctr">
-                    <a:lnL w="6350" cap="flat" cmpd="sng" algn="ctr">
-                      <a:solidFill>
-                        <a:srgbClr val="CCCCCC"/>
-                      </a:solidFill>
-                      <a:prstDash val="solid"/>
-                      <a:round/>
-                      <a:headEnd type="none" w="med" len="med"/>
-                      <a:tailEnd type="none" w="med" len="med"/>
-                    </a:lnL>
-                    <a:lnR w="6350" cap="flat" cmpd="sng" algn="ctr">
-                      <a:solidFill>
-                        <a:srgbClr val="CCCCCC"/>
-                      </a:solidFill>
-                      <a:prstDash val="solid"/>
-                      <a:round/>
-                      <a:headEnd type="none" w="med" len="med"/>
-                      <a:tailEnd type="none" w="med" len="med"/>
-                    </a:lnR>
-                    <a:lnT w="6350" cap="flat" cmpd="sng" algn="ctr">
-                      <a:solidFill>
-                        <a:srgbClr val="CCCCCC"/>
-                      </a:solidFill>
-                      <a:prstDash val="solid"/>
-                      <a:round/>
-                      <a:headEnd type="none" w="med" len="med"/>
-                      <a:tailEnd type="none" w="med" len="med"/>
-                    </a:lnT>
-                    <a:lnB w="6350" cap="flat" cmpd="sng" algn="ctr">
-                      <a:solidFill>
-                        <a:srgbClr val="CCCCCC"/>
-                      </a:solidFill>
-                      <a:prstDash val="solid"/>
-                      <a:round/>
-                      <a:headEnd type="none" w="med" len="med"/>
-                      <a:tailEnd type="none" w="med" len="med"/>
-                    </a:lnB>
-                    <a:solidFill>
-                      <a:srgbClr val="F8F6F1"/>
-                    </a:solidFill>
-                  </a:tcPr>
-                </a:tc>
-                <a:tc hMerge="1">
-                  <a:tcPr/>
-                </a:tc>
-              </a:tr>
-              <a:tr h="286664">
-                <a:tc>
-                  <a:txBody>
-                    <a:bodyPr/>
-                    <a:lstStyle/>
-                    <a:p>
-                      <a:pPr indent="0" marL="0">
-                        <a:buNone/>
-                      </a:pPr>
-                      <a:r>
-                        <a:rPr lang="en-US" sz="700" b="1" dirty="0">
-                          <a:solidFill>
-                            <a:srgbClr val="F8F6F1"/>
-                          </a:solidFill>
-                          <a:latin typeface="Montserrat SemiBold" pitchFamily="34" charset="0"/>
-                          <a:ea typeface="Montserrat SemiBold" pitchFamily="34" charset="-122"/>
-                          <a:cs typeface="Montserrat SemiBold" pitchFamily="34" charset="-120"/>
-                        </a:rPr>
-                        <a:t>Docks</a:t>
-                      </a:r>
-                      <a:endParaRPr lang="en-US" sz="700" dirty="0">
-                        <a:latin typeface="Montserrat SemiBold" charset="0"/>
-                        <a:ea typeface="Montserrat SemiBold" charset="0"/>
-                        <a:cs typeface="Montserrat SemiBold" charset="0"/>
-                      </a:endParaRPr>
-                    </a:p>
-                  </a:txBody>
-                  <a:tcPr marL="45720" marR="45720" marT="45720" marB="45720" anchor="ctr">
-                    <a:lnL w="6350" cap="flat" cmpd="sng" algn="ctr">
-                      <a:solidFill>
-                        <a:srgbClr val="CCCCCC"/>
-                      </a:solidFill>
-                      <a:prstDash val="solid"/>
-                      <a:round/>
-                      <a:headEnd type="none" w="med" len="med"/>
-                      <a:tailEnd type="none" w="med" len="med"/>
-                    </a:lnL>
-                    <a:lnR w="6350" cap="flat" cmpd="sng" algn="ctr">
-                      <a:solidFill>
-                        <a:srgbClr val="CCCCCC"/>
-                      </a:solidFill>
-                      <a:prstDash val="solid"/>
-                      <a:round/>
-                      <a:headEnd type="none" w="med" len="med"/>
-                      <a:tailEnd type="none" w="med" len="med"/>
-                    </a:lnR>
-                    <a:lnT w="6350" cap="flat" cmpd="sng" algn="ctr">
-                      <a:solidFill>
-                        <a:srgbClr val="CCCCCC"/>
-                      </a:solidFill>
-                      <a:prstDash val="solid"/>
-                      <a:round/>
-                      <a:headEnd type="none" w="med" len="med"/>
-                      <a:tailEnd type="none" w="med" len="med"/>
-                    </a:lnT>
-                    <a:lnB w="6350" cap="flat" cmpd="sng" algn="ctr">
-                      <a:solidFill>
-                        <a:srgbClr val="CCCCCC"/>
-                      </a:solidFill>
-                      <a:prstDash val="solid"/>
-                      <a:round/>
-                      <a:headEnd type="none" w="med" len="med"/>
-                      <a:tailEnd type="none" w="med" len="med"/>
-                    </a:lnB>
-                    <a:solidFill>
-                      <a:srgbClr val="1A3350"/>
-                    </a:solidFill>
-                  </a:tcPr>
-                </a:tc>
-                <a:tc gridSpan="2">
-                  <a:txBody>
-                    <a:bodyPr/>
-                    <a:lstStyle/>
-                    <a:p>
-                      <a:pPr indent="0" marL="0">
-                        <a:buNone/>
-                      </a:pPr>
-                      <a:r>
-                        <a:rPr lang="en-US" sz="700" dirty="0">
-                          <a:solidFill>
-                            <a:srgbClr val="1A3350"/>
-                          </a:solidFill>
-                          <a:latin typeface="Montserrat" pitchFamily="34" charset="0"/>
-                          <a:ea typeface="Montserrat" pitchFamily="34" charset="-122"/>
-                          <a:cs typeface="Montserrat" pitchFamily="34" charset="-120"/>
-                        </a:rPr>
-                        <a:t>3-4</a:t>
-                      </a:r>
-                      <a:endParaRPr lang="en-US" sz="700" dirty="0">
-                        <a:latin typeface="Montserrat" charset="0"/>
-                        <a:ea typeface="Montserrat" charset="0"/>
-                        <a:cs typeface="Montserrat" charset="0"/>
-                      </a:endParaRPr>
-                    </a:p>
-                  </a:txBody>
-                  <a:tcPr marL="45720" marR="45720" marT="45720" marB="45720" anchor="ctr">
-                    <a:lnL w="6350" cap="flat" cmpd="sng" algn="ctr">
-                      <a:solidFill>
-                        <a:srgbClr val="CCCCCC"/>
-                      </a:solidFill>
-                      <a:prstDash val="solid"/>
-                      <a:round/>
-                      <a:headEnd type="none" w="med" len="med"/>
-                      <a:tailEnd type="none" w="med" len="med"/>
-                    </a:lnL>
-                    <a:lnR w="6350" cap="flat" cmpd="sng" algn="ctr">
-                      <a:solidFill>
-                        <a:srgbClr val="CCCCCC"/>
-                      </a:solidFill>
-                      <a:prstDash val="solid"/>
-                      <a:round/>
-                      <a:headEnd type="none" w="med" len="med"/>
-                      <a:tailEnd type="none" w="med" len="med"/>
-                    </a:lnR>
-                    <a:lnT w="6350" cap="flat" cmpd="sng" algn="ctr">
-                      <a:solidFill>
-                        <a:srgbClr val="CCCCCC"/>
-                      </a:solidFill>
-                      <a:prstDash val="solid"/>
-                      <a:round/>
-                      <a:headEnd type="none" w="med" len="med"/>
-                      <a:tailEnd type="none" w="med" len="med"/>
-                    </a:lnT>
-                    <a:lnB w="6350" cap="flat" cmpd="sng" algn="ctr">
-                      <a:solidFill>
-                        <a:srgbClr val="CCCCCC"/>
-                      </a:solidFill>
-                      <a:prstDash val="solid"/>
-                      <a:round/>
-                      <a:headEnd type="none" w="med" len="med"/>
-                      <a:tailEnd type="none" w="med" len="med"/>
-                    </a:lnB>
-                    <a:solidFill>
-                      <a:srgbClr val="F8F6F1"/>
-                    </a:solidFill>
-                  </a:tcPr>
-                </a:tc>
-                <a:tc hMerge="1">
-                  <a:tcPr/>
-                </a:tc>
-              </a:tr>
-              <a:tr h="286664">
-                <a:tc>
-                  <a:txBody>
-                    <a:bodyPr/>
-                    <a:lstStyle/>
-                    <a:p>
-                      <a:pPr indent="0" marL="0">
-                        <a:buNone/>
-                      </a:pPr>
-                      <a:r>
-                        <a:rPr lang="en-US" sz="700" b="1" dirty="0">
-                          <a:solidFill>
-                            <a:srgbClr val="F8F6F1"/>
-                          </a:solidFill>
-                          <a:latin typeface="Montserrat SemiBold" pitchFamily="34" charset="0"/>
-                          <a:ea typeface="Montserrat SemiBold" pitchFamily="34" charset="-122"/>
-                          <a:cs typeface="Montserrat SemiBold" pitchFamily="34" charset="-120"/>
-                        </a:rPr>
-                        <a:t>Height</a:t>
-                      </a:r>
-                      <a:endParaRPr lang="en-US" sz="700" dirty="0">
-                        <a:latin typeface="Montserrat SemiBold" charset="0"/>
-                        <a:ea typeface="Montserrat SemiBold" charset="0"/>
-                        <a:cs typeface="Montserrat SemiBold" charset="0"/>
-                      </a:endParaRPr>
-                    </a:p>
-                  </a:txBody>
-                  <a:tcPr marL="45720" marR="45720" marT="45720" marB="45720" anchor="ctr">
-                    <a:lnL w="6350" cap="flat" cmpd="sng" algn="ctr">
-                      <a:solidFill>
-                        <a:srgbClr val="CCCCCC"/>
-                      </a:solidFill>
-                      <a:prstDash val="solid"/>
-                      <a:round/>
-                      <a:headEnd type="none" w="med" len="med"/>
-                      <a:tailEnd type="none" w="med" len="med"/>
-                    </a:lnL>
-                    <a:lnR w="6350" cap="flat" cmpd="sng" algn="ctr">
-                      <a:solidFill>
-                        <a:srgbClr val="CCCCCC"/>
-                      </a:solidFill>
-                      <a:prstDash val="solid"/>
-                      <a:round/>
-                      <a:headEnd type="none" w="med" len="med"/>
-                      <a:tailEnd type="none" w="med" len="med"/>
-                    </a:lnR>
-                    <a:lnT w="6350" cap="flat" cmpd="sng" algn="ctr">
-                      <a:solidFill>
-                        <a:srgbClr val="CCCCCC"/>
-                      </a:solidFill>
-                      <a:prstDash val="solid"/>
-                      <a:round/>
-                      <a:headEnd type="none" w="med" len="med"/>
-                      <a:tailEnd type="none" w="med" len="med"/>
-                    </a:lnT>
-                    <a:lnB w="6350" cap="flat" cmpd="sng" algn="ctr">
-                      <a:solidFill>
-                        <a:srgbClr val="CCCCCC"/>
-                      </a:solidFill>
-                      <a:prstDash val="solid"/>
-                      <a:round/>
-                      <a:headEnd type="none" w="med" len="med"/>
-                      <a:tailEnd type="none" w="med" len="med"/>
-                    </a:lnB>
-                    <a:solidFill>
-                      <a:srgbClr val="1A3350"/>
-                    </a:solidFill>
-                  </a:tcPr>
-                </a:tc>
-                <a:tc gridSpan="2">
-                  <a:txBody>
-                    <a:bodyPr/>
-                    <a:lstStyle/>
-                    <a:p>
-                      <a:pPr indent="0" marL="0">
-                        <a:buNone/>
-                      </a:pPr>
-                      <a:r>
-                        <a:rPr lang="en-US" sz="700" dirty="0">
-                          <a:solidFill>
-                            <a:srgbClr val="1A3350"/>
-                          </a:solidFill>
-                          <a:latin typeface="Montserrat" pitchFamily="34" charset="0"/>
-                          <a:ea typeface="Montserrat" pitchFamily="34" charset="-122"/>
-                          <a:cs typeface="Montserrat" pitchFamily="34" charset="-120"/>
-                        </a:rPr>
-                        <a:t>28</a:t>
-                      </a:r>
-                      <a:endParaRPr lang="en-US" sz="700" dirty="0">
-                        <a:latin typeface="Montserrat" charset="0"/>
-                        <a:ea typeface="Montserrat" charset="0"/>
-                        <a:cs typeface="Montserrat" charset="0"/>
-                      </a:endParaRPr>
-                    </a:p>
-                  </a:txBody>
-                  <a:tcPr marL="45720" marR="45720" marT="45720" marB="45720" anchor="ctr">
-                    <a:lnL w="6350" cap="flat" cmpd="sng" algn="ctr">
-                      <a:solidFill>
-                        <a:srgbClr val="CCCCCC"/>
-                      </a:solidFill>
-                      <a:prstDash val="solid"/>
-                      <a:round/>
-                      <a:headEnd type="none" w="med" len="med"/>
-                      <a:tailEnd type="none" w="med" len="med"/>
-                    </a:lnL>
-                    <a:lnR w="6350" cap="flat" cmpd="sng" algn="ctr">
-                      <a:solidFill>
-                        <a:srgbClr val="CCCCCC"/>
-                      </a:solidFill>
-                      <a:prstDash val="solid"/>
-                      <a:round/>
-                      <a:headEnd type="none" w="med" len="med"/>
-                      <a:tailEnd type="none" w="med" len="med"/>
-                    </a:lnR>
-                    <a:lnT w="6350" cap="flat" cmpd="sng" algn="ctr">
-                      <a:solidFill>
-                        <a:srgbClr val="CCCCCC"/>
-                      </a:solidFill>
-                      <a:prstDash val="solid"/>
-                      <a:round/>
-                      <a:headEnd type="none" w="med" len="med"/>
-                      <a:tailEnd type="none" w="med" len="med"/>
-                    </a:lnT>
-                    <a:lnB w="6350" cap="flat" cmpd="sng" algn="ctr">
-                      <a:solidFill>
-                        <a:srgbClr val="CCCCCC"/>
-                      </a:solidFill>
-                      <a:prstDash val="solid"/>
-                      <a:round/>
-                      <a:headEnd type="none" w="med" len="med"/>
-                      <a:tailEnd type="none" w="med" len="med"/>
-                    </a:lnB>
-                    <a:solidFill>
-                      <a:srgbClr val="F8F6F1"/>
-                    </a:solidFill>
-                  </a:tcPr>
-                </a:tc>
-                <a:tc hMerge="1">
-                  <a:tcPr/>
-                </a:tc>
-              </a:tr>
-              <a:tr h="416966">
-                <a:tc>
-                  <a:txBody>
-                    <a:bodyPr/>
-                    <a:lstStyle/>
-                    <a:p>
-                      <a:pPr indent="0" marL="0">
-                        <a:buNone/>
-                      </a:pPr>
-                      <a:r>
-                        <a:rPr lang="en-US" sz="700" b="1" dirty="0">
-                          <a:solidFill>
-                            <a:srgbClr val="F8F6F1"/>
-                          </a:solidFill>
-                          <a:latin typeface="Montserrat SemiBold" pitchFamily="34" charset="0"/>
-                          <a:ea typeface="Montserrat SemiBold" pitchFamily="34" charset="-122"/>
-                          <a:cs typeface="Montserrat SemiBold" pitchFamily="34" charset="-120"/>
-                        </a:rPr>
-                        <a:t>Flooring</a:t>
-                      </a:r>
-                      <a:endParaRPr lang="en-US" sz="700" dirty="0">
-                        <a:latin typeface="Montserrat SemiBold" charset="0"/>
-                        <a:ea typeface="Montserrat SemiBold" charset="0"/>
-                        <a:cs typeface="Montserrat SemiBold" charset="0"/>
-                      </a:endParaRPr>
-                    </a:p>
-                  </a:txBody>
-                  <a:tcPr marL="45720" marR="45720" marT="45720" marB="45720" anchor="ctr">
-                    <a:lnL w="6350" cap="flat" cmpd="sng" algn="ctr">
-                      <a:solidFill>
-                        <a:srgbClr val="CCCCCC"/>
-                      </a:solidFill>
-                      <a:prstDash val="solid"/>
-                      <a:round/>
-                      <a:headEnd type="none" w="med" len="med"/>
-                      <a:tailEnd type="none" w="med" len="med"/>
-                    </a:lnL>
-                    <a:lnR w="6350" cap="flat" cmpd="sng" algn="ctr">
-                      <a:solidFill>
-                        <a:srgbClr val="CCCCCC"/>
-                      </a:solidFill>
-                      <a:prstDash val="solid"/>
-                      <a:round/>
-                      <a:headEnd type="none" w="med" len="med"/>
-                      <a:tailEnd type="none" w="med" len="med"/>
-                    </a:lnR>
-                    <a:lnT w="6350" cap="flat" cmpd="sng" algn="ctr">
-                      <a:solidFill>
-                        <a:srgbClr val="CCCCCC"/>
-                      </a:solidFill>
-                      <a:prstDash val="solid"/>
-                      <a:round/>
-                      <a:headEnd type="none" w="med" len="med"/>
-                      <a:tailEnd type="none" w="med" len="med"/>
-                    </a:lnT>
-                    <a:lnB w="6350" cap="flat" cmpd="sng" algn="ctr">
-                      <a:solidFill>
-                        <a:srgbClr val="CCCCCC"/>
-                      </a:solidFill>
-                      <a:prstDash val="solid"/>
-                      <a:round/>
-                      <a:headEnd type="none" w="med" len="med"/>
-                      <a:tailEnd type="none" w="med" len="med"/>
-                    </a:lnB>
-                    <a:solidFill>
-                      <a:srgbClr val="1A3350"/>
-                    </a:solidFill>
-                  </a:tcPr>
-                </a:tc>
-                <a:tc gridSpan="2">
-                  <a:txBody>
-                    <a:bodyPr/>
-                    <a:lstStyle/>
-                    <a:p>
-                      <a:pPr indent="0" marL="0">
-                        <a:buNone/>
-                      </a:pPr>
-                      <a:r>
-                        <a:rPr lang="en-US" sz="700" dirty="0">
-                          <a:solidFill>
-                            <a:srgbClr val="1A3350"/>
-                          </a:solidFill>
-                          <a:latin typeface="Montserrat" pitchFamily="34" charset="0"/>
-                          <a:ea typeface="Montserrat" pitchFamily="34" charset="-122"/>
-                          <a:cs typeface="Montserrat" pitchFamily="34" charset="-120"/>
-                        </a:rPr>
-                        <a:t>Washroom, Parking, Water,</a:t>
-                      </a:r>
-                      <a:endParaRPr lang="en-US" sz="700" dirty="0">
-                        <a:latin typeface="Montserrat" charset="0"/>
-                        <a:ea typeface="Montserrat" charset="0"/>
-                        <a:cs typeface="Montserrat" charset="0"/>
-                      </a:endParaRPr>
-                    </a:p>
-                  </a:txBody>
-                  <a:tcPr marL="45720" marR="45720" marT="45720" marB="45720" anchor="ctr">
-                    <a:lnL w="6350" cap="flat" cmpd="sng" algn="ctr">
-                      <a:solidFill>
-                        <a:srgbClr val="CCCCCC"/>
-                      </a:solidFill>
-                      <a:prstDash val="solid"/>
-                      <a:round/>
-                      <a:headEnd type="none" w="med" len="med"/>
-                      <a:tailEnd type="none" w="med" len="med"/>
-                    </a:lnL>
-                    <a:lnR w="6350" cap="flat" cmpd="sng" algn="ctr">
-                      <a:solidFill>
-                        <a:srgbClr val="CCCCCC"/>
-                      </a:solidFill>
-                      <a:prstDash val="solid"/>
-                      <a:round/>
-                      <a:headEnd type="none" w="med" len="med"/>
-                      <a:tailEnd type="none" w="med" len="med"/>
-                    </a:lnR>
-                    <a:lnT w="6350" cap="flat" cmpd="sng" algn="ctr">
-                      <a:solidFill>
-                        <a:srgbClr val="CCCCCC"/>
-                      </a:solidFill>
-                      <a:prstDash val="solid"/>
-                      <a:round/>
-                      <a:headEnd type="none" w="med" len="med"/>
-                      <a:tailEnd type="none" w="med" len="med"/>
-                    </a:lnT>
-                    <a:lnB w="6350" cap="flat" cmpd="sng" algn="ctr">
-                      <a:solidFill>
-                        <a:srgbClr val="CCCCCC"/>
-                      </a:solidFill>
-                      <a:prstDash val="solid"/>
-                      <a:round/>
-                      <a:headEnd type="none" w="med" len="med"/>
-                      <a:tailEnd type="none" w="med" len="med"/>
-                    </a:lnB>
-                    <a:solidFill>
-                      <a:srgbClr val="F8F6F1"/>
-                    </a:solidFill>
-                  </a:tcPr>
-                </a:tc>
-                <a:tc hMerge="1">
-                  <a:tcPr/>
-                </a:tc>
-              </a:tr>
-              <a:tr h="286664">
-                <a:tc>
-                  <a:txBody>
-                    <a:bodyPr/>
-                    <a:lstStyle/>
-                    <a:p>
-                      <a:pPr indent="0" marL="0">
-                        <a:buNone/>
-                      </a:pPr>
-                      <a:r>
-                        <a:rPr lang="en-US" sz="700" b="1" dirty="0">
-                          <a:solidFill>
-                            <a:srgbClr val="F8F6F1"/>
-                          </a:solidFill>
-                          <a:latin typeface="Montserrat SemiBold" pitchFamily="34" charset="0"/>
-                          <a:ea typeface="Montserrat SemiBold" pitchFamily="34" charset="-122"/>
-                          <a:cs typeface="Montserrat SemiBold" pitchFamily="34" charset="-120"/>
-                        </a:rPr>
-                        <a:t>Fire Safety</a:t>
-                      </a:r>
-                      <a:endParaRPr lang="en-US" sz="700" dirty="0">
-                        <a:latin typeface="Montserrat SemiBold" charset="0"/>
-                        <a:ea typeface="Montserrat SemiBold" charset="0"/>
-                        <a:cs typeface="Montserrat SemiBold" charset="0"/>
-                      </a:endParaRPr>
-                    </a:p>
-                  </a:txBody>
-                  <a:tcPr marL="45720" marR="45720" marT="45720" marB="45720" anchor="ctr">
-                    <a:lnL w="6350" cap="flat" cmpd="sng" algn="ctr">
-                      <a:solidFill>
-                        <a:srgbClr val="CCCCCC"/>
-                      </a:solidFill>
-                      <a:prstDash val="solid"/>
-                      <a:round/>
-                      <a:headEnd type="none" w="med" len="med"/>
-                      <a:tailEnd type="none" w="med" len="med"/>
-                    </a:lnL>
-                    <a:lnR w="6350" cap="flat" cmpd="sng" algn="ctr">
-                      <a:solidFill>
-                        <a:srgbClr val="CCCCCC"/>
-                      </a:solidFill>
-                      <a:prstDash val="solid"/>
-                      <a:round/>
-                      <a:headEnd type="none" w="med" len="med"/>
-                      <a:tailEnd type="none" w="med" len="med"/>
-                    </a:lnR>
-                    <a:lnT w="6350" cap="flat" cmpd="sng" algn="ctr">
-                      <a:solidFill>
-                        <a:srgbClr val="CCCCCC"/>
-                      </a:solidFill>
-                      <a:prstDash val="solid"/>
-                      <a:round/>
-                      <a:headEnd type="none" w="med" len="med"/>
-                      <a:tailEnd type="none" w="med" len="med"/>
-                    </a:lnT>
-                    <a:lnB w="6350" cap="flat" cmpd="sng" algn="ctr">
-                      <a:solidFill>
-                        <a:srgbClr val="CCCCCC"/>
-                      </a:solidFill>
-                      <a:prstDash val="solid"/>
-                      <a:round/>
-                      <a:headEnd type="none" w="med" len="med"/>
-                      <a:tailEnd type="none" w="med" len="med"/>
-                    </a:lnB>
-                    <a:solidFill>
-                      <a:srgbClr val="1A3350"/>
-                    </a:solidFill>
-                  </a:tcPr>
-                </a:tc>
-                <a:tc gridSpan="2">
-                  <a:txBody>
-                    <a:bodyPr/>
-                    <a:lstStyle/>
-                    <a:p>
-                      <a:pPr indent="0" marL="0">
-                        <a:buNone/>
-                      </a:pPr>
-                      <a:r>
-                        <a:rPr lang="en-US" sz="700" dirty="0">
-                          <a:solidFill>
-                            <a:srgbClr val="1A3350"/>
-                          </a:solidFill>
-                          <a:latin typeface="Montserrat" pitchFamily="34" charset="0"/>
-                          <a:ea typeface="Montserrat" pitchFamily="34" charset="-122"/>
-                          <a:cs typeface="Montserrat" pitchFamily="34" charset="-120"/>
-                        </a:rPr>
-                        <a:t>N/A</a:t>
-                      </a:r>
-                      <a:endParaRPr lang="en-US" sz="700" dirty="0">
-                        <a:latin typeface="Montserrat" charset="0"/>
-                        <a:ea typeface="Montserrat" charset="0"/>
-                        <a:cs typeface="Montserrat" charset="0"/>
-                      </a:endParaRPr>
-                    </a:p>
-                  </a:txBody>
-                  <a:tcPr marL="45720" marR="45720" marT="45720" marB="45720" anchor="ctr">
-                    <a:lnL w="6350" cap="flat" cmpd="sng" algn="ctr">
-                      <a:solidFill>
-                        <a:srgbClr val="CCCCCC"/>
-                      </a:solidFill>
-                      <a:prstDash val="solid"/>
-                      <a:round/>
-                      <a:headEnd type="none" w="med" len="med"/>
-                      <a:tailEnd type="none" w="med" len="med"/>
-                    </a:lnL>
-                    <a:lnR w="6350" cap="flat" cmpd="sng" algn="ctr">
-                      <a:solidFill>
-                        <a:srgbClr val="CCCCCC"/>
-                      </a:solidFill>
-                      <a:prstDash val="solid"/>
-                      <a:round/>
-                      <a:headEnd type="none" w="med" len="med"/>
-                      <a:tailEnd type="none" w="med" len="med"/>
-                    </a:lnR>
-                    <a:lnT w="6350" cap="flat" cmpd="sng" algn="ctr">
-                      <a:solidFill>
-                        <a:srgbClr val="CCCCCC"/>
-                      </a:solidFill>
-                      <a:prstDash val="solid"/>
-                      <a:round/>
-                      <a:headEnd type="none" w="med" len="med"/>
-                      <a:tailEnd type="none" w="med" len="med"/>
-                    </a:lnT>
-                    <a:lnB w="6350" cap="flat" cmpd="sng" algn="ctr">
-                      <a:solidFill>
-                        <a:srgbClr val="CCCCCC"/>
-                      </a:solidFill>
-                      <a:prstDash val="solid"/>
-                      <a:round/>
-                      <a:headEnd type="none" w="med" len="med"/>
-                      <a:tailEnd type="none" w="med" len="med"/>
-                    </a:lnB>
-                    <a:solidFill>
-                      <a:srgbClr val="F8F6F1"/>
-                    </a:solidFill>
-                  </a:tcPr>
-                </a:tc>
-                <a:tc hMerge="1">
-                  <a:tcPr/>
-                </a:tc>
-              </a:tr>
-              <a:tr h="416966">
-                <a:tc>
-                  <a:txBody>
-                    <a:bodyPr/>
-                    <a:lstStyle/>
-                    <a:p>
-                      <a:pPr indent="0" marL="0">
-                        <a:buNone/>
-                      </a:pPr>
-                      <a:r>
-                        <a:rPr lang="en-US" sz="700" b="1" dirty="0">
-                          <a:solidFill>
-                            <a:srgbClr val="F8F6F1"/>
-                          </a:solidFill>
-                          <a:latin typeface="Montserrat SemiBold" pitchFamily="34" charset="0"/>
-                          <a:ea typeface="Montserrat SemiBold" pitchFamily="34" charset="-122"/>
-                          <a:cs typeface="Montserrat SemiBold" pitchFamily="34" charset="-120"/>
-                        </a:rPr>
-                        <a:t>Compliances</a:t>
-                      </a:r>
-                      <a:endParaRPr lang="en-US" sz="700" dirty="0">
-                        <a:latin typeface="Montserrat SemiBold" charset="0"/>
-                        <a:ea typeface="Montserrat SemiBold" charset="0"/>
-                        <a:cs typeface="Montserrat SemiBold" charset="0"/>
-                      </a:endParaRPr>
-                    </a:p>
-                  </a:txBody>
-                  <a:tcPr marL="45720" marR="45720" marT="45720" marB="45720" anchor="ctr">
-                    <a:lnL w="6350" cap="flat" cmpd="sng" algn="ctr">
-                      <a:solidFill>
-                        <a:srgbClr val="CCCCCC"/>
-                      </a:solidFill>
-                      <a:prstDash val="solid"/>
-                      <a:round/>
-                      <a:headEnd type="none" w="med" len="med"/>
-                      <a:tailEnd type="none" w="med" len="med"/>
-                    </a:lnL>
-                    <a:lnR w="6350" cap="flat" cmpd="sng" algn="ctr">
-                      <a:solidFill>
-                        <a:srgbClr val="CCCCCC"/>
-                      </a:solidFill>
-                      <a:prstDash val="solid"/>
-                      <a:round/>
-                      <a:headEnd type="none" w="med" len="med"/>
-                      <a:tailEnd type="none" w="med" len="med"/>
-                    </a:lnR>
-                    <a:lnT w="6350" cap="flat" cmpd="sng" algn="ctr">
-                      <a:solidFill>
-                        <a:srgbClr val="CCCCCC"/>
-                      </a:solidFill>
-                      <a:prstDash val="solid"/>
-                      <a:round/>
-                      <a:headEnd type="none" w="med" len="med"/>
-                      <a:tailEnd type="none" w="med" len="med"/>
-                    </a:lnT>
-                    <a:lnB w="6350" cap="flat" cmpd="sng" algn="ctr">
-                      <a:solidFill>
-                        <a:srgbClr val="CCCCCC"/>
-                      </a:solidFill>
-                      <a:prstDash val="solid"/>
-                      <a:round/>
-                      <a:headEnd type="none" w="med" len="med"/>
-                      <a:tailEnd type="none" w="med" len="med"/>
-                    </a:lnB>
-                    <a:solidFill>
-                      <a:srgbClr val="1A3350"/>
-                    </a:solidFill>
-                  </a:tcPr>
-                </a:tc>
-                <a:tc gridSpan="2">
-                  <a:txBody>
-                    <a:bodyPr/>
-                    <a:lstStyle/>
-                    <a:p>
-                      <a:pPr indent="0" marL="0">
-                        <a:buNone/>
-                      </a:pPr>
-                      <a:r>
-                        <a:rPr lang="en-US" sz="700" dirty="0">
-                          <a:solidFill>
-                            <a:srgbClr val="1A3350"/>
-                          </a:solidFill>
-                          <a:latin typeface="Montserrat" pitchFamily="34" charset="0"/>
-                          <a:ea typeface="Montserrat" pitchFamily="34" charset="-122"/>
-                          <a:cs typeface="Montserrat" pitchFamily="34" charset="-120"/>
-                        </a:rPr>
-                        <a:t>As per client requirement</a:t>
-                      </a:r>
-                      <a:endParaRPr lang="en-US" sz="700" dirty="0">
-                        <a:latin typeface="Montserrat" charset="0"/>
-                        <a:ea typeface="Montserrat" charset="0"/>
-                        <a:cs typeface="Montserrat" charset="0"/>
-                      </a:endParaRPr>
-                    </a:p>
-                  </a:txBody>
-                  <a:tcPr marL="45720" marR="45720" marT="45720" marB="45720" anchor="ctr">
-                    <a:lnL w="6350" cap="flat" cmpd="sng" algn="ctr">
-                      <a:solidFill>
-                        <a:srgbClr val="CCCCCC"/>
-                      </a:solidFill>
-                      <a:prstDash val="solid"/>
-                      <a:round/>
-                      <a:headEnd type="none" w="med" len="med"/>
-                      <a:tailEnd type="none" w="med" len="med"/>
-                    </a:lnL>
-                    <a:lnR w="6350" cap="flat" cmpd="sng" algn="ctr">
-                      <a:solidFill>
-                        <a:srgbClr val="CCCCCC"/>
-                      </a:solidFill>
-                      <a:prstDash val="solid"/>
-                      <a:round/>
-                      <a:headEnd type="none" w="med" len="med"/>
-                      <a:tailEnd type="none" w="med" len="med"/>
-                    </a:lnR>
-                    <a:lnT w="6350" cap="flat" cmpd="sng" algn="ctr">
-                      <a:solidFill>
-                        <a:srgbClr val="CCCCCC"/>
-                      </a:solidFill>
-                      <a:prstDash val="solid"/>
-                      <a:round/>
-                      <a:headEnd type="none" w="med" len="med"/>
-                      <a:tailEnd type="none" w="med" len="med"/>
-                    </a:lnT>
-                    <a:lnB w="6350" cap="flat" cmpd="sng" algn="ctr">
-                      <a:solidFill>
-                        <a:srgbClr val="CCCCCC"/>
-                      </a:solidFill>
-                      <a:prstDash val="solid"/>
-                      <a:round/>
-                      <a:headEnd type="none" w="med" len="med"/>
-                      <a:tailEnd type="none" w="med" len="med"/>
-                    </a:lnB>
-                    <a:solidFill>
-                      <a:srgbClr val="F8F6F1"/>
-                    </a:solidFill>
-                  </a:tcPr>
-                </a:tc>
-                <a:tc hMerge="1">
-                  <a:tcPr/>
-                </a:tc>
-              </a:tr>
-              <a:tr h="286664">
-                <a:tc>
-                  <a:txBody>
-                    <a:bodyPr/>
-                    <a:lstStyle/>
-                    <a:p>
-                      <a:pPr indent="0" marL="0">
-                        <a:buNone/>
-                      </a:pPr>
-                      <a:r>
-                        <a:rPr lang="en-US" sz="700" b="1" dirty="0">
-                          <a:solidFill>
-                            <a:srgbClr val="F8F6F1"/>
-                          </a:solidFill>
-                          <a:latin typeface="Montserrat SemiBold" pitchFamily="34" charset="0"/>
-                          <a:ea typeface="Montserrat SemiBold" pitchFamily="34" charset="-122"/>
-                          <a:cs typeface="Montserrat SemiBold" pitchFamily="34" charset="-120"/>
-                        </a:rPr>
-                        <a:t>Handover</a:t>
-                      </a:r>
-                      <a:endParaRPr lang="en-US" sz="700" dirty="0">
-                        <a:latin typeface="Montserrat SemiBold" charset="0"/>
-                        <a:ea typeface="Montserrat SemiBold" charset="0"/>
-                        <a:cs typeface="Montserrat SemiBold" charset="0"/>
-                      </a:endParaRPr>
-                    </a:p>
-                  </a:txBody>
-                  <a:tcPr marL="45720" marR="45720" marT="45720" marB="45720" anchor="ctr">
-                    <a:lnL w="6350" cap="flat" cmpd="sng" algn="ctr">
-                      <a:solidFill>
-                        <a:srgbClr val="CCCCCC"/>
-                      </a:solidFill>
-                      <a:prstDash val="solid"/>
-                      <a:round/>
-                      <a:headEnd type="none" w="med" len="med"/>
-                      <a:tailEnd type="none" w="med" len="med"/>
-                    </a:lnL>
-                    <a:lnR w="6350" cap="flat" cmpd="sng" algn="ctr">
-                      <a:solidFill>
-                        <a:srgbClr val="CCCCCC"/>
-                      </a:solidFill>
-                      <a:prstDash val="solid"/>
-                      <a:round/>
-                      <a:headEnd type="none" w="med" len="med"/>
-                      <a:tailEnd type="none" w="med" len="med"/>
-                    </a:lnR>
-                    <a:lnT w="6350" cap="flat" cmpd="sng" algn="ctr">
-                      <a:solidFill>
-                        <a:srgbClr val="CCCCCC"/>
-                      </a:solidFill>
-                      <a:prstDash val="solid"/>
-                      <a:round/>
-                      <a:headEnd type="none" w="med" len="med"/>
-                      <a:tailEnd type="none" w="med" len="med"/>
-                    </a:lnT>
-                    <a:lnB w="6350" cap="flat" cmpd="sng" algn="ctr">
-                      <a:solidFill>
-                        <a:srgbClr val="CCCCCC"/>
-                      </a:solidFill>
-                      <a:prstDash val="solid"/>
-                      <a:round/>
-                      <a:headEnd type="none" w="med" len="med"/>
-                      <a:tailEnd type="none" w="med" len="med"/>
-                    </a:lnB>
-                    <a:solidFill>
-                      <a:srgbClr val="1A3350"/>
-                    </a:solidFill>
-                  </a:tcPr>
-                </a:tc>
-                <a:tc gridSpan="2">
-                  <a:txBody>
-                    <a:bodyPr/>
-                    <a:lstStyle/>
-                    <a:p>
-                      <a:pPr indent="0" marL="0">
-                        <a:buNone/>
-                      </a:pPr>
-                      <a:r>
-                        <a:rPr lang="en-US" sz="700" dirty="0">
-                          <a:solidFill>
-                            <a:srgbClr val="1A3350"/>
-                          </a:solidFill>
-                          <a:latin typeface="Montserrat" pitchFamily="34" charset="0"/>
-                          <a:ea typeface="Montserrat" pitchFamily="34" charset="-122"/>
-                          <a:cs typeface="Montserrat" pitchFamily="34" charset="-120"/>
-                        </a:rPr>
-                        <a:t>Immediate</a:t>
-                      </a:r>
-                      <a:endParaRPr lang="en-US" sz="700" dirty="0">
-                        <a:latin typeface="Montserrat" charset="0"/>
-                        <a:ea typeface="Montserrat" charset="0"/>
-                        <a:cs typeface="Montserrat" charset="0"/>
-                      </a:endParaRPr>
-                    </a:p>
-                  </a:txBody>
-                  <a:tcPr marL="45720" marR="45720" marT="45720" marB="45720" anchor="ctr">
-                    <a:lnL w="6350" cap="flat" cmpd="sng" algn="ctr">
-                      <a:solidFill>
-                        <a:srgbClr val="CCCCCC"/>
-                      </a:solidFill>
-                      <a:prstDash val="solid"/>
-                      <a:round/>
-                      <a:headEnd type="none" w="med" len="med"/>
-                      <a:tailEnd type="none" w="med" len="med"/>
-                    </a:lnL>
-                    <a:lnR w="6350" cap="flat" cmpd="sng" algn="ctr">
-                      <a:solidFill>
-                        <a:srgbClr val="CCCCCC"/>
-                      </a:solidFill>
-                      <a:prstDash val="solid"/>
-                      <a:round/>
-                      <a:headEnd type="none" w="med" len="med"/>
-                      <a:tailEnd type="none" w="med" len="med"/>
-                    </a:lnR>
-                    <a:lnT w="6350" cap="flat" cmpd="sng" algn="ctr">
-                      <a:solidFill>
-                        <a:srgbClr val="CCCCCC"/>
-                      </a:solidFill>
-                      <a:prstDash val="solid"/>
-                      <a:round/>
-                      <a:headEnd type="none" w="med" len="med"/>
-                      <a:tailEnd type="none" w="med" len="med"/>
-                    </a:lnT>
-                    <a:lnB w="6350" cap="flat" cmpd="sng" algn="ctr">
-                      <a:solidFill>
-                        <a:srgbClr val="CCCCCC"/>
-                      </a:solidFill>
-                      <a:prstDash val="solid"/>
-                      <a:round/>
-                      <a:headEnd type="none" w="med" len="med"/>
-                      <a:tailEnd type="none" w="med" len="med"/>
-                    </a:lnB>
-                    <a:solidFill>
-                      <a:srgbClr val="F8F6F1"/>
-                    </a:solidFill>
-                  </a:tcPr>
-                </a:tc>
-                <a:tc hMerge="1">
-                  <a:tcPr/>
-                </a:tc>
-              </a:tr>
-            </a:tbl>
-          </a:graphicData>
-        </a:graphic>
-      </p:graphicFrame>
-      <p:sp>
-        <p:nvSpPr>
-          <p:cNvPr id="9" name="Text 5"/>
-          <p:cNvSpPr/>
-          <p:nvPr/>
-        </p:nvSpPr>
-        <p:spPr>
-          <a:xfrm>
-            <a:off x="81382" y="4288170"/>
-            <a:ext cx="2057400" cy="320040"/>
-          </a:xfrm>
-          <a:prstGeom prst="rect">
-            <a:avLst/>
-          </a:prstGeom>
-          <a:noFill/>
-          <a:ln/>
-        </p:spPr>
-        <p:txBody>
-          <a:bodyPr wrap="square" rtlCol="0" anchor="ctr"/>
-          <a:lstStyle/>
-          <a:p>
-            <a:pPr indent="0" marL="0">
-              <a:buNone/>
-            </a:pPr>
-            <a:r>
-              <a:rPr lang="en-US" sz="1000" b="1" dirty="0">
-                <a:solidFill>
-                  <a:srgbClr val="1A3350"/>
-                </a:solidFill>
-                <a:latin typeface="Montserrat" pitchFamily="34" charset="0"/>
-                <a:ea typeface="Montserrat" pitchFamily="34" charset="-122"/>
-                <a:cs typeface="Montserrat" pitchFamily="34" charset="-120"/>
-              </a:rPr>
-              <a:t>Commercials</a:t>
-            </a:r>
-            <a:endParaRPr lang="en-US" sz="1000" dirty="0"/>
-          </a:p>
-        </p:txBody>
-      </p:sp>
-      <p:graphicFrame>
-        <p:nvGraphicFramePr>
-          <p:cNvPr id="19" name="Table 2"/>
-          <p:cNvGraphicFramePr>
-            <a:graphicFrameLocks noGrp="1"/>
-          </p:cNvGraphicFramePr>
-          <p:nvPr>
-            <p:extLst>
-              <p:ext uri="{D42A27DB-BD31-4B8C-83A1-F6EECF244321}">
-                <p14:modId xmlns:p14="http://schemas.microsoft.com/office/powerpoint/2010/main" val="1579011935"/>
-              </p:ext>
-            </p:extLst>
-          </p:nvPr>
-        </p:nvGraphicFramePr>
-        <p:xfrm>
-          <a:off x="137160" y="4593946"/>
-          <a:ext cx="2121408" cy="914400"/>
-        </p:xfrm>
-        <a:graphic>
-          <a:graphicData uri="http://schemas.openxmlformats.org/drawingml/2006/table">
-            <a:tbl>
-              <a:tblPr/>
-              <a:tblGrid>
-                <a:gridCol w="749808"/>
-                <a:gridCol w="1371600"/>
-              </a:tblGrid>
-              <a:tr h="416966">
-                <a:tc>
-                  <a:txBody>
-                    <a:bodyPr/>
-                    <a:lstStyle/>
-                    <a:p>
-                      <a:pPr indent="0" marL="0">
-                        <a:buNone/>
-                      </a:pPr>
-                      <a:r>
-                        <a:rPr lang="en-US" sz="700" b="1" dirty="0">
-                          <a:solidFill>
-                            <a:srgbClr val="F8F6F1"/>
-                          </a:solidFill>
-                          <a:latin typeface="Montserrat SemiBold" pitchFamily="34" charset="0"/>
-                          <a:ea typeface="Montserrat SemiBold" pitchFamily="34" charset="-122"/>
-                          <a:cs typeface="Montserrat SemiBold" pitchFamily="34" charset="-120"/>
-                        </a:rPr>
-                        <a:t>Rent per sq.ft (INR)</a:t>
-                      </a:r>
-                      <a:endParaRPr lang="en-US" sz="700" dirty="0">
-                        <a:latin typeface="Montserrat SemiBold" charset="0"/>
-                        <a:ea typeface="Montserrat SemiBold" charset="0"/>
-                        <a:cs typeface="Montserrat SemiBold" charset="0"/>
-                      </a:endParaRPr>
-                    </a:p>
-                  </a:txBody>
-                  <a:tcPr marL="45720" marR="45720" marT="45720" marB="45720" anchor="ctr">
-                    <a:lnL w="6350" cap="flat" cmpd="sng" algn="ctr">
-                      <a:solidFill>
-                        <a:srgbClr val="CCCCCC"/>
-                      </a:solidFill>
-                      <a:prstDash val="solid"/>
-                      <a:round/>
-                      <a:headEnd type="none" w="med" len="med"/>
-                      <a:tailEnd type="none" w="med" len="med"/>
-                    </a:lnL>
-                    <a:lnR w="6350" cap="flat" cmpd="sng" algn="ctr">
-                      <a:solidFill>
-                        <a:srgbClr val="CCCCCC"/>
-                      </a:solidFill>
-                      <a:prstDash val="solid"/>
-                      <a:round/>
-                      <a:headEnd type="none" w="med" len="med"/>
-                      <a:tailEnd type="none" w="med" len="med"/>
-                    </a:lnR>
-                    <a:lnT w="6350" cap="flat" cmpd="sng" algn="ctr">
-                      <a:solidFill>
-                        <a:srgbClr val="CCCCCC"/>
-                      </a:solidFill>
-                      <a:prstDash val="solid"/>
-                      <a:round/>
-                      <a:headEnd type="none" w="med" len="med"/>
-                      <a:tailEnd type="none" w="med" len="med"/>
-                    </a:lnT>
-                    <a:lnB w="6350" cap="flat" cmpd="sng" algn="ctr">
-                      <a:solidFill>
-                        <a:srgbClr val="CCCCCC"/>
-                      </a:solidFill>
-                      <a:prstDash val="solid"/>
-                      <a:round/>
-                      <a:headEnd type="none" w="med" len="med"/>
-                      <a:tailEnd type="none" w="med" len="med"/>
-                    </a:lnB>
-                    <a:solidFill>
-                      <a:srgbClr val="1A3350"/>
-                    </a:solidFill>
-                  </a:tcPr>
-                </a:tc>
-                <a:tc>
-                  <a:txBody>
-                    <a:bodyPr/>
-                    <a:lstStyle/>
-                    <a:p>
-                      <a:pPr indent="0" marL="0">
-                        <a:buNone/>
-                      </a:pPr>
-                      <a:r>
-                        <a:rPr lang="en-US" sz="700" dirty="0">
-                          <a:solidFill>
-                            <a:srgbClr val="1A3350"/>
-                          </a:solidFill>
-                          <a:latin typeface="Montserrat" pitchFamily="34" charset="0"/>
-                          <a:ea typeface="Montserrat" pitchFamily="34" charset="-122"/>
-                          <a:cs typeface="Montserrat" pitchFamily="34" charset="-120"/>
-                        </a:rPr>
-                        <a:t>22</a:t>
-                      </a:r>
-                      <a:endParaRPr lang="en-US" sz="700" dirty="0">
-                        <a:latin typeface="Montserrat" charset="0"/>
-                        <a:ea typeface="Montserrat" charset="0"/>
-                        <a:cs typeface="Montserrat" charset="0"/>
-                      </a:endParaRPr>
-                    </a:p>
-                  </a:txBody>
-                  <a:tcPr marL="45720" marR="45720" marT="45720" marB="45720" anchor="ctr">
-                    <a:lnL w="6350" cap="flat" cmpd="sng" algn="ctr">
-                      <a:solidFill>
-                        <a:srgbClr val="CCCCCC"/>
-                      </a:solidFill>
-                      <a:prstDash val="solid"/>
-                      <a:round/>
-                      <a:headEnd type="none" w="med" len="med"/>
-                      <a:tailEnd type="none" w="med" len="med"/>
-                    </a:lnL>
-                    <a:lnR w="6350" cap="flat" cmpd="sng" algn="ctr">
-                      <a:solidFill>
-                        <a:srgbClr val="CCCCCC"/>
-                      </a:solidFill>
-                      <a:prstDash val="solid"/>
-                      <a:round/>
-                      <a:headEnd type="none" w="med" len="med"/>
-                      <a:tailEnd type="none" w="med" len="med"/>
-                    </a:lnR>
-                    <a:lnT w="6350" cap="flat" cmpd="sng" algn="ctr">
-                      <a:solidFill>
-                        <a:srgbClr val="CCCCCC"/>
-                      </a:solidFill>
-                      <a:prstDash val="solid"/>
-                      <a:round/>
-                      <a:headEnd type="none" w="med" len="med"/>
-                      <a:tailEnd type="none" w="med" len="med"/>
-                    </a:lnT>
-                    <a:lnB w="6350" cap="flat" cmpd="sng" algn="ctr">
-                      <a:solidFill>
-                        <a:srgbClr val="CCCCCC"/>
-                      </a:solidFill>
-                      <a:prstDash val="solid"/>
-                      <a:round/>
-                      <a:headEnd type="none" w="med" len="med"/>
-                      <a:tailEnd type="none" w="med" len="med"/>
-                    </a:lnB>
-                    <a:solidFill>
-                      <a:srgbClr val="F8F6F1"/>
-                    </a:solidFill>
-                  </a:tcPr>
-                </a:tc>
-              </a:tr>
-            </a:tbl>
-          </a:graphicData>
-        </a:graphic>
-      </p:graphicFrame>
-      <p:pic>
-        <p:nvPicPr>
-          <p:cNvPr id="11" name="Image 0" descr="preencoded.png">    </p:cNvPr>
-          <p:cNvPicPr>
-            <a:picLocks noChangeAspect="1"/>
-          </p:cNvPicPr>
-          <p:nvPr/>
-        </p:nvPicPr>
-        <p:blipFill>
-          <a:blip r:embed="rId1"/>
           <a:srcRect l="0" r="0" t="0" b="0"/>
           <a:stretch/>
         </p:blipFill>
@@ -11759,13 +10175,13 @@
           <p:nvPr/>
         </p:nvPicPr>
         <p:blipFill>
-          <a:blip r:embed="rId2"/>
+          <a:blip r:embed="rId3"/>
           <a:srcRect l="0" r="0" t="0" b="0"/>
           <a:stretch/>
         </p:blipFill>
         <p:spPr>
           <a:xfrm>
-            <a:off x="2676449" y="327355"/>
+            <a:off x="5800954" y="2615184"/>
             <a:ext cx="2904134" cy="2093976"/>
           </a:xfrm>
           <a:prstGeom prst="rect">
@@ -11782,7 +10198,7 @@
           <p:nvPr/>
         </p:nvPicPr>
         <p:blipFill>
-          <a:blip r:embed="rId3"/>
+          <a:blip r:embed="rId4"/>
           <a:srcRect l="0" r="0" t="0" b="0"/>
           <a:stretch/>
         </p:blipFill>
@@ -11805,13 +10221,13 @@
           <p:nvPr/>
         </p:nvPicPr>
         <p:blipFill>
-          <a:blip r:embed="rId4"/>
+          <a:blip r:embed="rId5"/>
           <a:srcRect l="0" r="0" t="0" b="0"/>
           <a:stretch/>
         </p:blipFill>
         <p:spPr>
           <a:xfrm>
-            <a:off x="5800954" y="2615184"/>
+            <a:off x="2676449" y="327355"/>
             <a:ext cx="2904134" cy="2093976"/>
           </a:xfrm>
           <a:prstGeom prst="rect">
@@ -11828,7 +10244,7 @@
           <p:nvPr/>
         </p:nvPicPr>
         <p:blipFill>
-          <a:blip r:embed="rId5"/>
+          <a:blip r:embed="rId6"/>
           <a:stretch>
             <a:fillRect/>
           </a:stretch>
@@ -11851,8 +10267,8 @@
         </p:nvSpPr>
         <p:spPr>
           <a:xfrm>
-            <a:off x="4572000" y="4887468"/>
-            <a:ext cx="4389120" cy="256032"/>
+            <a:off x="4251960" y="4773168"/>
+            <a:ext cx="4572000" cy="256032"/>
           </a:xfrm>
           <a:prstGeom prst="rect">
             <a:avLst/>
@@ -11868,7 +10284,7 @@
               <a:buNone/>
             </a:pPr>
             <a:r>
-              <a:rPr lang="en-US" sz="850" dirty="0">
+              <a:rPr lang="en-US" sz="750" dirty="0">
                 <a:solidFill>
                   <a:srgbClr val="1A3350"/>
                 </a:solidFill>
@@ -11876,9 +10292,9 @@
                 <a:ea typeface="Montserrat" pitchFamily="34" charset="-122"/>
                 <a:cs typeface="Montserrat" pitchFamily="34" charset="-120"/>
               </a:rPr>
-              <a:t>Prepared by WareOnGo  |  Dated 23/05/2026  |  Confidential</a:t>
+              <a:t>Prepared by WareOnGo  |  Dated 25/05/2026  |  Confidential</a:t>
             </a:r>
-            <a:endParaRPr lang="en-US" sz="850" dirty="0"/>
+            <a:endParaRPr lang="en-US" sz="750" dirty="0"/>
           </a:p>
         </p:txBody>
       </p:sp>
@@ -11890,9 +10306,9 @@
 </p:sld>
 </file>
 
-<file path=ppt/slides/slide7.xml><?xml version="1.0" encoding="utf-8"?>
+<file path=ppt/slides/slide6.xml><?xml version="1.0" encoding="utf-8"?>
 <p:sld xmlns:a="http://schemas.openxmlformats.org/drawingml/2006/main" xmlns:r="http://schemas.openxmlformats.org/officeDocument/2006/relationships" xmlns:p="http://schemas.openxmlformats.org/presentationml/2006/main">
-  <p:cSld name="Slide 7">
+  <p:cSld name="Slide 6">
     <p:bg>
       <p:bgPr>
         <a:solidFill>
@@ -12091,8 +10507,8 @@
         </p:nvSpPr>
         <p:spPr>
           <a:xfrm>
-            <a:off x="4572000" y="4887468"/>
-            <a:ext cx="4389120" cy="256032"/>
+            <a:off x="4251960" y="4773168"/>
+            <a:ext cx="4572000" cy="256032"/>
           </a:xfrm>
           <a:prstGeom prst="rect">
             <a:avLst/>
@@ -12108,7 +10524,7 @@
               <a:buNone/>
             </a:pPr>
             <a:r>
-              <a:rPr lang="en-US" sz="850" dirty="0">
+              <a:rPr lang="en-US" sz="750" dirty="0">
                 <a:solidFill>
                   <a:srgbClr val="1A3350"/>
                 </a:solidFill>
@@ -12116,9 +10532,9 @@
                 <a:ea typeface="Montserrat" pitchFamily="34" charset="-122"/>
                 <a:cs typeface="Montserrat" pitchFamily="34" charset="-120"/>
               </a:rPr>
-              <a:t>Prepared by WareOnGo  |  Dated 23/05/2026  |  Confidential</a:t>
+              <a:t>Prepared by WareOnGo  |  Dated 25/05/2026  |  Confidential</a:t>
             </a:r>
-            <a:endParaRPr lang="en-US" sz="850" dirty="0"/>
+            <a:endParaRPr lang="en-US" sz="750" dirty="0"/>
           </a:p>
         </p:txBody>
       </p:sp>

</xml_diff>